<commit_message>
Publish labs with no supplied Stage 1 client
</commit_message>
<xml_diff>
--- a/labs/Lab01/slides.pptx
+++ b/labs/Lab01/slides.pptx
@@ -1418,7 +1418,7 @@
           <a:p>
             <a:r>
               <a:rPr lang="en-US" dirty="0"/>
-              <a:t>Minute 40. The adapter protects the learning sequence: HTTP transport is implemented in Analyze. It does not supply a config loader or state model. Do not hand out a module diagram as the answer.</a:t>
+              <a:t>Minute 40. Students implement the endpoint client in Stage 1 and extend it for function calling in Analyze. No application code or tests are supplied. Do not hand out a module diagram as the answer.</a:t>
             </a:r>
             <a:endParaRPr lang="en-US" dirty="0"/>
           </a:p>
@@ -1682,7 +1682,7 @@
           <a:p>
             <a:r>
               <a:rPr lang="en-US" dirty="0"/>
-              <a:t>The schema is a shared external contract. Students choose its internal representation. base_url can include any path prefix; the adapter adds /chat/completions only. Aider has a separate YAML config. No Ollama-specific dependency belongs in the application.</a:t>
+              <a:t>The schema is a shared external contract. Students choose its internal representation. base_url can include any path prefix; the client appends /chat/completions only. Aider has a separate YAML config. No Ollama-specific dependency belongs in the application.</a:t>
             </a:r>
             <a:endParaRPr lang="en-US" dirty="0"/>
           </a:p>
@@ -2122,7 +2122,7 @@
           <a:p>
             <a:r>
               <a:rPr lang="en-US" dirty="0"/>
-              <a:t>The rubric contains each feature suballocation. Only one F4 outcome point depends on live-model success; honest unsuccessful evidence can earn live-reporting points. Supplied transport tests earn no application-test credit.</a:t>
+              <a:t>The rubric contains each feature suballocation. Only one F4 outcome point depends on live-model success; honest unsuccessful evidence can earn live-reporting points. Students author all tests, including client protocol checks.</a:t>
             </a:r>
             <a:endParaRPr lang="en-US" dirty="0"/>
           </a:p>

</xml_diff>

<commit_message>
Publish concrete Stage 1 application examples
</commit_message>
<xml_diff>
--- a/labs/Lab01/slides.pptx
+++ b/labs/Lab01/slides.pptx
@@ -42,9 +42,11 @@
     <p:sldId id="290" r:id="rId36"/>
     <p:sldId id="291" r:id="rId37"/>
     <p:sldId id="292" r:id="rId38"/>
+    <p:sldId id="293" r:id="rId39"/>
+    <p:sldId id="294" r:id="rId40"/>
   </p:sldIdLst>
   <p:notesMasterIdLst>
-    <p:notesMasterId r:id="rId39"/>
+    <p:notesMasterId r:id="rId41"/>
   </p:notesMasterIdLst>
   <p:sldSz cx="9334500" cy="5248275"/>
   <p:notesSz cx="5248275" cy="9334500"/>
@@ -1594,7 +1596,7 @@
           <a:p>
             <a:r>
               <a:rPr lang="en-US" dirty="0"/>
-              <a:t>Configuration and lifecycle are cross-cutting requirements, not a hidden eighth feature. No scope cut accompanies the redesign. Point to SPEC.md for complete edge cases.</a:t>
+              <a:t>Open EXAMPLES.md from the student template. The transcripts describe expected behavior, not a captured staff run. This is a bounded application, not all of Aider. Students implement the context assembly, endpoint client and edit handling themselves. No application code or tests are supplied.</a:t>
             </a:r>
             <a:endParaRPr lang="en-US" dirty="0"/>
           </a:p>
@@ -1682,7 +1684,7 @@
           <a:p>
             <a:r>
               <a:rPr lang="en-US" dirty="0"/>
-              <a:t>The schema is a shared external contract. Students choose its internal representation. base_url can include any path prefix; the client appends /chat/completions only. Aider has a separate YAML config. No Ollama-specific dependency belongs in the application.</a:t>
+              <a:t>Use the exact greeting files and replies in EXAMPLES.md. Undo assumes an owned current-session HEAD and a clean target; a human commit or dirty tree requires refusal. Ask students to state what they would assert in a test. The model emits text; their program is responsible for these observable outcomes. Keep the project introduction within its existing time block by using these concrete examples to explain the feature list.</a:t>
             </a:r>
             <a:endParaRPr lang="en-US" dirty="0"/>
           </a:p>
@@ -1770,7 +1772,7 @@
           <a:p>
             <a:r>
               <a:rPr lang="en-US" dirty="0"/>
-              <a:t>They are learning to design within constraints. Different architectures can satisfy the same assignment. Future compatibility needs a rationale, not a premature plugin framework.</a:t>
+              <a:t>Configuration and lifecycle are cross-cutting requirements, not a hidden eighth feature. No scope cut accompanies the redesign. Point to SPEC.md for complete edge cases.</a:t>
             </a:r>
             <a:endParaRPr lang="en-US" dirty="0"/>
           </a:p>
@@ -1858,7 +1860,7 @@
           <a:p>
             <a:r>
               <a:rPr lang="en-US" dirty="0"/>
-              <a:t>A substantial spec is not one giant context dump. Requirements map to planned tests; those test names need not exist in the initial design. Experiments are allowed when labeled and reconciled before the dependent implementation.</a:t>
+              <a:t>The schema is a shared external contract. Students choose its internal representation. base_url can include any path prefix; the client appends /chat/completions only. Aider has a separate YAML config. No Ollama-specific dependency belongs in the application.</a:t>
             </a:r>
             <a:endParaRPr lang="en-US" dirty="0"/>
           </a:p>
@@ -1946,7 +1948,7 @@
           <a:p>
             <a:r>
               <a:rPr lang="en-US" dirty="0"/>
-              <a:t>Their diagrams must show their system, not copy the Aider diagram. Mermaid is enough. Label unimplemented parts and tie component names to code once it exists.</a:t>
+              <a:t>They are learning to design within constraints. Different architectures can satisfy the same assignment. Future compatibility needs a rationale, not a premature plugin framework.</a:t>
             </a:r>
             <a:endParaRPr lang="en-US" dirty="0"/>
           </a:p>
@@ -2034,7 +2036,7 @@
           <a:p>
             <a:r>
               <a:rPr lang="en-US" dirty="0"/>
-              <a:t>All points shown are within the build grade. Design can retain credit when implementation falls short, provided its claims and final status are accurate.</a:t>
+              <a:t>A substantial spec is not one giant context dump. Requirements map to planned tests; those test names need not exist in the initial design. Experiments are allowed when labeled and reconciled before the dependent implementation.</a:t>
             </a:r>
             <a:endParaRPr lang="en-US" dirty="0"/>
           </a:p>
@@ -2122,7 +2124,7 @@
           <a:p>
             <a:r>
               <a:rPr lang="en-US" dirty="0"/>
-              <a:t>The rubric contains each feature suballocation. Only one F4 outcome point depends on live-model success; honest unsuccessful evidence can earn live-reporting points. Students author all tests, including client protocol checks.</a:t>
+              <a:t>Their diagrams must show their system, not copy the Aider diagram. Mermaid is enough. Label unimplemented parts and tie component names to code once it exists.</a:t>
             </a:r>
             <a:endParaRPr lang="en-US" dirty="0"/>
           </a:p>
@@ -2210,7 +2212,7 @@
           <a:p>
             <a:r>
               <a:rPr lang="en-US" dirty="0"/>
-              <a:t>Explain evidence as concrete pointers, not log volume. No points for suffering and no repeated deductions for one missing feature across otherwise sound artifacts. Policy violations use academic-integrity procedures.</a:t>
+              <a:t>All points shown are within the build grade. Design can retain credit when implementation falls short, provided its claims and final status are accurate.</a:t>
             </a:r>
             <a:endParaRPr lang="en-US" dirty="0"/>
           </a:p>
@@ -2298,7 +2300,7 @@
           <a:p>
             <a:r>
               <a:rPr lang="en-US" dirty="0"/>
-              <a:t>The assigned packet states the exact model IDs and observed-session exception. No frontier design followed by local implementation. Keep design and development sessions, disclose actual aliases and known quantization.</a:t>
+              <a:t>The rubric contains each feature suballocation. Only one F4 outcome point depends on live-model success; honest unsuccessful evidence can earn live-reporting points. Students author all tests, including client protocol checks.</a:t>
             </a:r>
             <a:endParaRPr lang="en-US" dirty="0"/>
           </a:p>
@@ -2386,7 +2388,7 @@
           <a:p>
             <a:r>
               <a:rPr lang="en-US" dirty="0"/>
-              <a:t>Close the 15-minute project block. Dates remain Sep 25 for the build and Sep 24 for hackathon 1. Do not promise a workload estimate. A runnable slice early reduces integration surprises.</a:t>
+              <a:t>Explain evidence as concrete pointers, not log volume. No points for suffering and no repeated deductions for one missing feature across otherwise sound artifacts. Policy violations use academic-integrity procedures.</a:t>
             </a:r>
             <a:endParaRPr lang="en-US" dirty="0"/>
           </a:p>
@@ -2562,7 +2564,7 @@
           <a:p>
             <a:r>
               <a:rPr lang="en-US" dirty="0"/>
-              <a:t>Keep this comparison in lab. It is a mechanism comparison, not a claim that Aider lacks automation or that an agentic CLI needs no human judgment. Claude Code is the concrete comparison; no subscription is required for Stage 1. Source: https://code.claude.com/docs/en/overview</a:t>
+              <a:t>The assigned packet states the exact model IDs and observed-session exception. No frontier design followed by local implementation. Keep design and development sessions, disclose actual aliases and known quantization.</a:t>
             </a:r>
             <a:endParaRPr lang="en-US" dirty="0"/>
           </a:p>
@@ -2650,7 +2652,7 @@
           <a:p>
             <a:r>
               <a:rPr lang="en-US" dirty="0"/>
-              <a:t>Use a hypothetical trace, not an unobserved product demonstration. The model can choose actions only from what its harness exposes and permissions allow. Students build this responsibility in Analyze.</a:t>
+              <a:t>Close the 15-minute project block. Dates remain Sep 25 for the build and Sep 24 for hackathon 1. Do not promise a workload estimate. A runnable slice early reduces integration surprises.</a:t>
             </a:r>
             <a:endParaRPr lang="en-US" dirty="0"/>
           </a:p>
@@ -2738,7 +2740,7 @@
           <a:p>
             <a:r>
               <a:rPr lang="en-US" dirty="0"/>
-              <a:t>Keep product feature details at mechanism level, avoid promising exact weeks for every branded feature. Their DEVELOPMENT.md starts the habit of writing instructions for a future session. Code and permissions enforce constraints that prose alone cannot guarantee.</a:t>
+              <a:t>Keep this comparison in lab. It is a mechanism comparison, not a claim that Aider lacks automation or that an agentic CLI needs no human judgment. Claude Code is the concrete comparison; no subscription is required for Stage 1. Source: https://code.claude.com/docs/en/overview</a:t>
             </a:r>
             <a:endParaRPr lang="en-US" dirty="0"/>
           </a:p>
@@ -2826,7 +2828,7 @@
           <a:p>
             <a:r>
               <a:rPr lang="en-US" dirty="0"/>
-              <a:t>OpenClaw is a concrete future-system comparison, not a library students must adopt. Source: https://docs.openclaw.ai/concepts/architecture. Keep client/node connections distinct from the agent runtime; the gateway is not simply several agents on one task.</a:t>
+              <a:t>Use a hypothetical trace, not an unobserved product demonstration. The model can choose actions only from what its harness exposes and permissions allow. Students build this responsibility in Analyze.</a:t>
             </a:r>
             <a:endParaRPr lang="en-US" dirty="0"/>
           </a:p>
@@ -2914,7 +2916,7 @@
           <a:p>
             <a:r>
               <a:rPr lang="en-US" dirty="0"/>
-              <a:t>End future comparison at minute 65. Ask for boundary reasoning, not December implementation. Students may change their answers as the course progresses.</a:t>
+              <a:t>Keep product feature details at mechanism level, avoid promising exact weeks for every branded feature. Their DEVELOPMENT.md starts the habit of writing instructions for a future session. Code and permissions enforce constraints that prose alone cannot guarantee.</a:t>
             </a:r>
             <a:endParaRPr lang="en-US" dirty="0"/>
           </a:p>
@@ -3002,7 +3004,7 @@
           <a:p>
             <a:r>
               <a:rPr lang="en-US" dirty="0"/>
-              <a:t>No application exists to run yet. bin/dev test checks the transport, not a completed feature. The whole initial system spec is finished after lab, before application implementation. Use peer review plus staff triage.</a:t>
+              <a:t>OpenClaw is a concrete future-system comparison, not a library students must adopt. Source: https://docs.openclaw.ai/concepts/architecture. Keep client/node connections distinct from the agent runtime; the gateway is not simply several agents on one task.</a:t>
             </a:r>
             <a:endParaRPr lang="en-US" dirty="0"/>
           </a:p>
@@ -3090,7 +3092,7 @@
           <a:p>
             <a:r>
               <a:rPr lang="en-US" dirty="0"/>
-              <a:t>Do not require every student to queue for a five-minute full-design review. Record unresolved questions and a follow-up path. Peer review concerns contracts, not sharing implementation solutions.</a:t>
+              <a:t>End future comparison at minute 65. Ask for boundary reasoning, not December implementation. Students may change their answers as the course progresses.</a:t>
             </a:r>
             <a:endParaRPr lang="en-US" dirty="0"/>
           </a:p>
@@ -3178,6 +3180,182 @@
           <a:p>
             <a:r>
               <a:rPr lang="en-US" dirty="0"/>
+              <a:t>No application exists to run yet. Students launch aider directly using .env and the supplied Aider configuration; they implement bin/assistant themselves. The whole initial system spec is finished after lab, before application implementation. Use peer review plus staff triage.</a:t>
+            </a:r>
+            <a:endParaRPr lang="en-US" dirty="0"/>
+          </a:p>
+        </p:txBody>
+      </p:sp>
+      <p:sp>
+        <p:nvSpPr>
+          <p:cNvPr id="4" name="Slide Number Placeholder 3"/>
+          <p:cNvSpPr>
+            <a:spLocks noGrp="1"/>
+          </p:cNvSpPr>
+          <p:nvPr>
+            <p:ph type="sldNum" sz="quarter" idx="10"/>
+          </p:nvPr>
+        </p:nvSpPr>
+        <p:spPr/>
+        <p:txBody>
+          <a:bodyPr/>
+          <a:lstStyle/>
+          <a:p>
+            <a:fld id="{F7021451-1387-4CA6-816F-3879F97B5CBC}" type="slidenum">
+              <a:rPr lang="en-US"/>
+              <a:t>37</a:t>
+            </a:fld>
+            <a:endParaRPr lang="en-US"/>
+          </a:p>
+        </p:txBody>
+      </p:sp>
+    </p:spTree>
+    <p:extLst>
+      <p:ext uri="{BB962C8B-B14F-4D97-AF65-F5344CB8AC3E}">
+        <p14:creationId xmlns:p14="http://schemas.microsoft.com/office/powerpoint/2010/main" val="1024086991"/>
+      </p:ext>
+    </p:extLst>
+  </p:cSld>
+  <p:clrMapOvr>
+    <a:masterClrMapping/>
+  </p:clrMapOvr>
+</p:notes>
+</file>
+
+<file path=ppt/notesSlides/notesSlide38.xml><?xml version="1.0" encoding="utf-8"?>
+<p:notes xmlns:a="http://schemas.openxmlformats.org/drawingml/2006/main" xmlns:r="http://schemas.openxmlformats.org/officeDocument/2006/relationships" xmlns:p="http://schemas.openxmlformats.org/presentationml/2006/main">
+  <p:cSld>
+    <p:spTree>
+      <p:nvGrpSpPr>
+        <p:cNvPr id="1" name=""/>
+        <p:cNvGrpSpPr/>
+        <p:nvPr/>
+      </p:nvGrpSpPr>
+      <p:grpSpPr>
+        <a:xfrm>
+          <a:off x="0" y="0"/>
+          <a:ext cx="0" cy="0"/>
+          <a:chOff x="0" y="0"/>
+          <a:chExt cx="0" cy="0"/>
+        </a:xfrm>
+      </p:grpSpPr>
+      <p:sp>
+        <p:nvSpPr>
+          <p:cNvPr id="2" name="Slide Image Placeholder 1"/>
+          <p:cNvSpPr>
+            <a:spLocks noGrp="1" noRot="1" noChangeAspect="1"/>
+          </p:cNvSpPr>
+          <p:nvPr>
+            <p:ph type="sldImg"/>
+          </p:nvPr>
+        </p:nvSpPr>
+        <p:spPr/>
+      </p:sp>
+      <p:sp>
+        <p:nvSpPr>
+          <p:cNvPr id="3" name="Notes Placeholder 2"/>
+          <p:cNvSpPr>
+            <a:spLocks noGrp="1"/>
+          </p:cNvSpPr>
+          <p:nvPr>
+            <p:ph type="body" idx="1"/>
+          </p:nvPr>
+        </p:nvSpPr>
+        <p:spPr/>
+        <p:txBody>
+          <a:bodyPr/>
+          <a:lstStyle/>
+          <a:p>
+            <a:r>
+              <a:rPr lang="en-US" dirty="0"/>
+              <a:t>Do not require every student to queue for a five-minute full-design review. Record unresolved questions and a follow-up path. Peer review concerns contracts, not sharing implementation solutions.</a:t>
+            </a:r>
+            <a:endParaRPr lang="en-US" dirty="0"/>
+          </a:p>
+        </p:txBody>
+      </p:sp>
+      <p:sp>
+        <p:nvSpPr>
+          <p:cNvPr id="4" name="Slide Number Placeholder 3"/>
+          <p:cNvSpPr>
+            <a:spLocks noGrp="1"/>
+          </p:cNvSpPr>
+          <p:nvPr>
+            <p:ph type="sldNum" sz="quarter" idx="10"/>
+          </p:nvPr>
+        </p:nvSpPr>
+        <p:spPr/>
+        <p:txBody>
+          <a:bodyPr/>
+          <a:lstStyle/>
+          <a:p>
+            <a:fld id="{F7021451-1387-4CA6-816F-3879F97B5CBC}" type="slidenum">
+              <a:rPr lang="en-US"/>
+              <a:t>38</a:t>
+            </a:fld>
+            <a:endParaRPr lang="en-US"/>
+          </a:p>
+        </p:txBody>
+      </p:sp>
+    </p:spTree>
+    <p:extLst>
+      <p:ext uri="{BB962C8B-B14F-4D97-AF65-F5344CB8AC3E}">
+        <p14:creationId xmlns:p14="http://schemas.microsoft.com/office/powerpoint/2010/main" val="1024086991"/>
+      </p:ext>
+    </p:extLst>
+  </p:cSld>
+  <p:clrMapOvr>
+    <a:masterClrMapping/>
+  </p:clrMapOvr>
+</p:notes>
+</file>
+
+<file path=ppt/notesSlides/notesSlide39.xml><?xml version="1.0" encoding="utf-8"?>
+<p:notes xmlns:a="http://schemas.openxmlformats.org/drawingml/2006/main" xmlns:r="http://schemas.openxmlformats.org/officeDocument/2006/relationships" xmlns:p="http://schemas.openxmlformats.org/presentationml/2006/main">
+  <p:cSld>
+    <p:spTree>
+      <p:nvGrpSpPr>
+        <p:cNvPr id="1" name=""/>
+        <p:cNvGrpSpPr/>
+        <p:nvPr/>
+      </p:nvGrpSpPr>
+      <p:grpSpPr>
+        <a:xfrm>
+          <a:off x="0" y="0"/>
+          <a:ext cx="0" cy="0"/>
+          <a:chOff x="0" y="0"/>
+          <a:chExt cx="0" cy="0"/>
+        </a:xfrm>
+      </p:grpSpPr>
+      <p:sp>
+        <p:nvSpPr>
+          <p:cNvPr id="2" name="Slide Image Placeholder 1"/>
+          <p:cNvSpPr>
+            <a:spLocks noGrp="1" noRot="1" noChangeAspect="1"/>
+          </p:cNvSpPr>
+          <p:nvPr>
+            <p:ph type="sldImg"/>
+          </p:nvPr>
+        </p:nvSpPr>
+        <p:spPr/>
+      </p:sp>
+      <p:sp>
+        <p:nvSpPr>
+          <p:cNvPr id="3" name="Notes Placeholder 2"/>
+          <p:cNvSpPr>
+            <a:spLocks noGrp="1"/>
+          </p:cNvSpPr>
+          <p:nvPr>
+            <p:ph type="body" idx="1"/>
+          </p:nvPr>
+        </p:nvSpPr>
+        <p:spPr/>
+        <p:txBody>
+          <a:bodyPr/>
+          <a:lstStyle/>
+          <a:p>
+            <a:r>
+              <a:rPr lang="en-US" dirty="0"/>
               <a:t>Remind students of the complete submission packet: design, diagrams, specs, code/tests, configuration example, DEVELOPMENT.md, operating README, evidence, AI_LOG.md, reflection, and sessions. All exact requirements and scoring live in their repository.</a:t>
             </a:r>
             <a:endParaRPr lang="en-US" dirty="0"/>
@@ -3201,7 +3379,7 @@
           <a:p>
             <a:fld id="{F7021451-1387-4CA6-816F-3879F97B5CBC}" type="slidenum">
               <a:rPr lang="en-US"/>
-              <a:t>37</a:t>
+              <a:t>39</a:t>
             </a:fld>
             <a:endParaRPr lang="en-US"/>
           </a:p>
@@ -5228,6 +5406,84 @@
 <file path=ppt/slides/slide37.xml><?xml version="1.0" encoding="utf-8"?>
 <p:sld xmlns:a="http://schemas.openxmlformats.org/drawingml/2006/main" xmlns:r="http://schemas.openxmlformats.org/officeDocument/2006/relationships" xmlns:p="http://schemas.openxmlformats.org/presentationml/2006/main">
   <p:cSld name="Slide 37">
+    <p:bg>
+      <p:bgPr>
+        <a:blipFill dpi="0" rotWithShape="1">
+          <a:blip r:embed="rId1">
+            <a:lum/>
+          </a:blip>
+          <a:srcRect/>
+          <a:stretch>
+            <a:fillRect/>
+          </a:stretch>
+        </a:blipFill>
+        <a:effectLst/>
+      </p:bgPr>
+    </p:bg>
+    <p:spTree>
+      <p:nvGrpSpPr>
+        <p:cNvPr id="1" name=""/>
+        <p:cNvGrpSpPr/>
+        <p:nvPr/>
+      </p:nvGrpSpPr>
+      <p:grpSpPr>
+        <a:xfrm>
+          <a:off x="0" y="0"/>
+          <a:ext cx="0" cy="0"/>
+          <a:chOff x="0" y="0"/>
+          <a:chExt cx="0" cy="0"/>
+        </a:xfrm>
+      </p:grpSpPr>
+    </p:spTree>
+  </p:cSld>
+  <p:clrMapOvr>
+    <a:masterClrMapping/>
+  </p:clrMapOvr>
+</p:sld>
+</file>
+
+<file path=ppt/slides/slide38.xml><?xml version="1.0" encoding="utf-8"?>
+<p:sld xmlns:a="http://schemas.openxmlformats.org/drawingml/2006/main" xmlns:r="http://schemas.openxmlformats.org/officeDocument/2006/relationships" xmlns:p="http://schemas.openxmlformats.org/presentationml/2006/main">
+  <p:cSld name="Slide 38">
+    <p:bg>
+      <p:bgPr>
+        <a:blipFill dpi="0" rotWithShape="1">
+          <a:blip r:embed="rId1">
+            <a:lum/>
+          </a:blip>
+          <a:srcRect/>
+          <a:stretch>
+            <a:fillRect/>
+          </a:stretch>
+        </a:blipFill>
+        <a:effectLst/>
+      </p:bgPr>
+    </p:bg>
+    <p:spTree>
+      <p:nvGrpSpPr>
+        <p:cNvPr id="1" name=""/>
+        <p:cNvGrpSpPr/>
+        <p:nvPr/>
+      </p:nvGrpSpPr>
+      <p:grpSpPr>
+        <a:xfrm>
+          <a:off x="0" y="0"/>
+          <a:ext cx="0" cy="0"/>
+          <a:chOff x="0" y="0"/>
+          <a:chExt cx="0" cy="0"/>
+        </a:xfrm>
+      </p:grpSpPr>
+    </p:spTree>
+  </p:cSld>
+  <p:clrMapOvr>
+    <a:masterClrMapping/>
+  </p:clrMapOvr>
+</p:sld>
+</file>
+
+<file path=ppt/slides/slide39.xml><?xml version="1.0" encoding="utf-8"?>
+<p:sld xmlns:a="http://schemas.openxmlformats.org/drawingml/2006/main" xmlns:r="http://schemas.openxmlformats.org/officeDocument/2006/relationships" xmlns:p="http://schemas.openxmlformats.org/presentationml/2006/main">
+  <p:cSld name="Slide 39">
     <p:bg>
       <p:bgPr>
         <a:blipFill dpi="0" rotWithShape="1">

</xml_diff>

<commit_message>
Publish the rewritten Lab01 deck
Assertion-evidence rewrite: one claim per slide title, evidence
underneath, and three rebuilt diagrams on the theme palette.

Co-Authored-By: Claude Opus 5 (1M context) <noreply@anthropic.com>
</commit_message>
<xml_diff>
--- a/labs/Lab01/slides.pptx
+++ b/labs/Lab01/slides.pptx
@@ -44,9 +44,15 @@
     <p:sldId id="292" r:id="rId38"/>
     <p:sldId id="293" r:id="rId39"/>
     <p:sldId id="294" r:id="rId40"/>
+    <p:sldId id="295" r:id="rId41"/>
+    <p:sldId id="296" r:id="rId42"/>
+    <p:sldId id="297" r:id="rId43"/>
+    <p:sldId id="298" r:id="rId44"/>
+    <p:sldId id="299" r:id="rId45"/>
+    <p:sldId id="300" r:id="rId46"/>
   </p:sldIdLst>
   <p:notesMasterIdLst>
-    <p:notesMasterId r:id="rId41"/>
+    <p:notesMasterId r:id="rId47"/>
   </p:notesMasterIdLst>
   <p:sldSz cx="9334500" cy="5248275"/>
   <p:notesSz cx="5248275" cy="9334500"/>
@@ -540,7 +546,9 @@
           <a:p>
             <a:r>
               <a:rPr lang="en-US" dirty="0"/>
-              <a:t>This lab connects the tool students have used to the system they will design. The future-tool comparison stays here. Finish instruction at minute 65.</a:t>
+              <a:t>Two halves. The first takes apart the tool they have been using since Lab00.
+The second hands them the build and gives them 45 minutes to start designing.
+Finish instruction at minute 65 and protect the work block.</a:t>
             </a:r>
             <a:endParaRPr lang="en-US" dirty="0"/>
           </a:p>
@@ -628,7 +636,10 @@
           <a:p>
             <a:r>
               <a:rPr lang="en-US" dirty="0"/>
-              <a:t>Missing divider is a syntax error. A nonexistent path or zero exact matches can be a later validation error. Their design can separate those responsibilities; we grade outcomes rather than one function signature.</a:t>
+              <a:t>Deliberately small and deliberately incomplete. Ask what is missing before you
+say it: task.py never gains the field, store.py never writes it. A student who
+reads only this block sees a finished feature.
+Nothing has changed on disk yet. This is a proposal in a chat reply.</a:t>
             </a:r>
             <a:endParaRPr lang="en-US" dirty="0"/>
           </a:p>
@@ -716,7 +727,9 @@
           <a:p>
             <a:r>
               <a:rPr lang="en-US" dirty="0"/>
-              <a:t>Do not describe partial application as untestable. It is testable with a different contract. Their stricter rule reduces recovery cases and makes the target state easier to reason about.</a:t>
+              <a:t>Their design may split these across two functions or keep them in one. We grade
+the error behavior, not the signature. What we do want is that a malformed block
+and an unapplicable block are distinguishable to the person reading the output.</a:t>
             </a:r>
             <a:endParaRPr lang="en-US" dirty="0"/>
           </a:p>
@@ -804,7 +817,11 @@
           <a:p>
             <a:r>
               <a:rPr lang="en-US" dirty="0"/>
-              <a:t>Explain that Aider has real automation. Never say it cannot run commands or tests. Its normal task framing and available repair cycles differ from a general tool-selection loop. Source: https://aider.chat/docs/usage/lint-test.html</a:t>
+              <a:t>Two spaces are enough to break a match. Show the difference before you name it.
+Partial application is not untestable, it is testable against a different
+contract. Do not tell them one policy is the only defensible one. The stricter
+rule is here because it makes the state after a failure trivial to state and
+to assert.</a:t>
             </a:r>
             <a:endParaRPr lang="en-US" dirty="0"/>
           </a:p>
@@ -892,7 +909,11 @@
           <a:p>
             <a:r>
               <a:rPr lang="en-US" dirty="0"/>
-              <a:t>Keep Aider development commits distinct from commits created by the student assistant in a target repo. In Stage 1 the target is disposable and clean; owned HEAD commits can be undone. Running shell commands arrives later and has consequences git cannot reverse.</a:t>
+              <a:t>Say clearly that Aider has real automation. It runs commands, it can run your
+tests, and it can loop on their output. Never say it cannot.
+The distinction that matters is who picks the next action. Here the harness has
+a fixed repair cycle. In the tools we look at after the break, the model picks.
+Source: https://aider.chat/docs/usage/lint-test.html</a:t>
             </a:r>
             <a:endParaRPr lang="en-US" dirty="0"/>
           </a:p>
@@ -980,7 +1001,12 @@
           <a:p>
             <a:r>
               <a:rPr lang="en-US" dirty="0"/>
-              <a:t>Use the last three minutes of the first block. Pair discussion, then take two answers. Seek the missing storage update or persistence test. Do not reward memorizing a source filename.</a:t>
+              <a:t>Keep two kinds of commit apart: the ones Aider makes while they build, and the
+ones their assistant will make in a target repo. In Stage 1 the target is
+disposable and clean, so an owned HEAD commit can be undone safely. A human
+commit on top, or a dirty tree, means their tool has to refuse.
+Running shell commands arrives in the Analyze phase and brings consequences git
+cannot undo.</a:t>
             </a:r>
             <a:endParaRPr lang="en-US" dirty="0"/>
           </a:p>
@@ -1068,7 +1094,9 @@
           <a:p>
             <a:r>
               <a:rPr lang="en-US" dirty="0"/>
-              <a:t>This begins the 10-minute diagnosis block. There may be more than one cause. Ask what evidence distinguishes two explanations before declaring the model too weak.</a:t>
+              <a:t>Pairs for two minutes, then take two answers. You are listening for the missing
+storage write or the missing persistence test. Do not reward naming a source
+file inside aider.</a:t>
             </a:r>
             <a:endParaRPr lang="en-US" dirty="0"/>
           </a:p>
@@ -1156,7 +1184,8 @@
           <a:p>
             <a:r>
               <a:rPr lang="en-US" dirty="0"/>
-              <a:t>Do not claim the model is irrelevant or that every failure is context. Students can improve their harness and their prompts while still measuring model limitations.</a:t>
+              <a:t>Ten minutes. The habit to build: a symptom is evidence about which of the three
+levers is wrong, and re-running the same prompt tests nothing.</a:t>
             </a:r>
             <a:endParaRPr lang="en-US" dirty="0"/>
           </a:p>
@@ -1244,7 +1273,9 @@
           <a:p>
             <a:r>
               <a:rPr lang="en-US" dirty="0"/>
-              <a:t>Give four minutes to pairs and two for responses. A persistence round-trip test is a good answer. The student should infer a storage problem from evidence, not blindly add all files or switch models.</a:t>
+              <a:t>Push back on "the model is too weak" every time it comes up today. Ask what
+observation would distinguish a weak model from a missing file, and make them
+answer before they change models.</a:t>
             </a:r>
             <a:endParaRPr lang="en-US" dirty="0"/>
           </a:p>
@@ -1332,7 +1363,9 @@
           <a:p>
             <a:r>
               <a:rPr lang="en-US" dirty="0"/>
-              <a:t>Three minutes including logistics. Exact room/time and the course model must be announced by staff; do not invent them. The existing project is preparation, but no separate hackathon solution is assigned. Build due the next day.</a:t>
+              <a:t>Do not let this become "the model does not matter" or "every failure is
+context." Both halves are real. The point is that the harness is the half they
+are about to build, and it is the half they control.</a:t>
             </a:r>
             <a:endParaRPr lang="en-US" dirty="0"/>
           </a:p>
@@ -1420,7 +1453,10 @@
           <a:p>
             <a:r>
               <a:rPr lang="en-US" dirty="0"/>
-              <a:t>Minute 40. Students implement the endpoint client in Stage 1 and extend it for function calling in Analyze. No application code or tests are supplied. Do not hand out a module diagram as the answer.</a:t>
+              <a:t>Four minutes in pairs, two for answers. A persistence round trip is the answer
+you are hoping for: write it, restart, read it back.
+Watch for the two reflexes you want to break. Adding every file in the package
+is not diagnosis, and switching models is not diagnosis.</a:t>
             </a:r>
             <a:endParaRPr lang="en-US" dirty="0"/>
           </a:p>
@@ -1508,7 +1544,9 @@
           <a:p>
             <a:r>
               <a:rPr lang="en-US" dirty="0"/>
-              <a:t>The work block starts at 65, not after an additional agenda segment. No one is expected to finish a substantial system spec today.</a:t>
+              <a:t>Put this up while the room settles and leave it up. The agenda is part of the
+first block, not an extra segment in front of it. Say out loud that the work
+block is real working time and that you will stop talking at minute 65.</a:t>
             </a:r>
             <a:endParaRPr lang="en-US" dirty="0"/>
           </a:p>
@@ -1596,7 +1634,10 @@
           <a:p>
             <a:r>
               <a:rPr lang="en-US" dirty="0"/>
-              <a:t>Open EXAMPLES.md from the student template. The transcripts describe expected behavior, not a captured staff run. This is a bounded application, not all of Aider. Students implement the context assembly, endpoint client and edit handling themselves. No application code or tests are supplied.</a:t>
+              <a:t>Three minutes including logistics. Room, time and the model in the workspace are
+announced by staff. Do not invent any of them here.
+Say the accommodations line out loud: conflicts and accommodations go to staff
+now, not the week of. Build is due the next day, September 25.</a:t>
             </a:r>
             <a:endParaRPr lang="en-US" dirty="0"/>
           </a:p>
@@ -1684,7 +1725,8 @@
           <a:p>
             <a:r>
               <a:rPr lang="en-US" dirty="0"/>
-              <a:t>Use the exact greeting files and replies in EXAMPLES.md. Undo assumes an owned current-session HEAD and a clean target; a human commit or dirty tree requires refusal. Ask students to state what they would assert in a test. The model emits text; their program is responsible for these observable outcomes. Keep the project introduction within its existing time block by using these concrete examples to explain the feature list.</a:t>
+              <a:t>Minute 40. Fifteen minutes. Everything here is also written down in their
+packet, so do not read the rubric aloud line by line.</a:t>
             </a:r>
             <a:endParaRPr lang="en-US" dirty="0"/>
           </a:p>
@@ -1772,7 +1814,11 @@
           <a:p>
             <a:r>
               <a:rPr lang="en-US" dirty="0"/>
-              <a:t>Configuration and lifecycle are cross-cutting requirements, not a hidden eighth feature. No scope cut accompanies the redesign. Point to SPEC.md for complete edge cases.</a:t>
+              <a:t>This is the slide that answers the question every student is holding. No
+starter application, no supplied session module, no TOML to edit, no two
+prescribed specs.
+They implement the endpoint client in Stage 1 and extend it for function
+calling in Analyze.</a:t>
             </a:r>
             <a:endParaRPr lang="en-US" dirty="0"/>
           </a:p>
@@ -1860,7 +1906,12 @@
           <a:p>
             <a:r>
               <a:rPr lang="en-US" dirty="0"/>
-              <a:t>The schema is a shared external contract. Students choose its internal representation. base_url can include any path prefix; the client appends /chat/completions only. Aider has a separate YAML config. No Ollama-specific dependency belongs in the application.</a:t>
+              <a:t>Open EXAMPLES.md from the template and walk the four transcripts: a question, an
+approved edit, a cancellation, an undo. Say that these are the expected
+behavior, not a recording of a staff implementation.
+Ask what happens to the files and to HEAD at each point. That question starts
+their acceptance criteria, which is a better use of this block than a tour of
+the feature list.</a:t>
             </a:r>
             <a:endParaRPr lang="en-US" dirty="0"/>
           </a:p>
@@ -1948,7 +1999,11 @@
           <a:p>
             <a:r>
               <a:rPr lang="en-US" dirty="0"/>
-              <a:t>They are learning to design within constraints. Different architectures can satisfy the same assignment. Future compatibility needs a rationale, not a premature plugin framework.</a:t>
+              <a:t>Use the exact greeting files and replies from EXAMPLES.md so the table matches
+what they will read tonight.
+Undo assumes an owned, current-session HEAD and a clean target. A human commit
+on top, or uncommitted changes, means refuse. Ask them what they would assert in
+a test for each row.</a:t>
             </a:r>
             <a:endParaRPr lang="en-US" dirty="0"/>
           </a:p>
@@ -2036,7 +2091,8 @@
           <a:p>
             <a:r>
               <a:rPr lang="en-US" dirty="0"/>
-              <a:t>A substantial spec is not one giant context dump. Requirements map to planned tests; those test names need not exist in the initial design. Experiments are allowed when labeled and reconciled before the dependent implementation.</a:t>
+              <a:t>Configuration and lifecycle run across all seven. They are not a hidden eighth
+feature and there is no scope cut this term. Every edge case is in SPEC.md.</a:t>
             </a:r>
             <a:endParaRPr lang="en-US" dirty="0"/>
           </a:p>
@@ -2124,7 +2180,10 @@
           <a:p>
             <a:r>
               <a:rPr lang="en-US" dirty="0"/>
-              <a:t>Their diagrams must show their system, not copy the Aider diagram. Mermaid is enough. Label unimplemented parts and tie component names to code once it exists.</a:t>
+              <a:t>base_url can carry any path prefix. Their client appends /chat/completions and
+nothing else. Aider's own YAML config is a separate file and unrelated.
+No Ollama-specific dependency belongs anywhere in the application. Provider
+independence is a requirement, not a preference.</a:t>
             </a:r>
             <a:endParaRPr lang="en-US" dirty="0"/>
           </a:p>
@@ -2212,7 +2271,9 @@
           <a:p>
             <a:r>
               <a:rPr lang="en-US" dirty="0"/>
-              <a:t>All points shown are within the build grade. Design can retain credit when implementation falls short, provided its claims and final status are accurate.</a:t>
+              <a:t>The last line is the one to say out loud. A plugin framework in week 3, written
+for a capability they have not been given yet, is a cost with no evidence behind
+it. Future compatibility needs a reason.</a:t>
             </a:r>
             <a:endParaRPr lang="en-US" dirty="0"/>
           </a:p>
@@ -2300,7 +2361,10 @@
           <a:p>
             <a:r>
               <a:rPr lang="en-US" dirty="0"/>
-              <a:t>The rubric contains each feature suballocation. Only one F4 outcome point depends on live-model success; honest unsuccessful evidence can earn live-reporting points. Students author all tests, including client protocol checks.</a:t>
+              <a:t>A system spec is not one giant context dump. Requirements map to planned tests,
+and those test files do not have to exist yet.
+Experiments are allowed. Label them, and reconcile them with the design before
+you build on top of them.</a:t>
             </a:r>
             <a:endParaRPr lang="en-US" dirty="0"/>
           </a:p>
@@ -2388,7 +2452,9 @@
           <a:p>
             <a:r>
               <a:rPr lang="en-US" dirty="0"/>
-              <a:t>Explain evidence as concrete pointers, not log volume. No points for suffering and no repeated deductions for one missing feature across otherwise sound artifacts. Policy violations use academic-integrity procedures.</a:t>
+              <a:t>Their diagrams describe their system. Copying the Aider picture from earlier
+today earns nothing. Label anything not yet implemented, and tie component names
+to real code once the code exists.</a:t>
             </a:r>
             <a:endParaRPr lang="en-US" dirty="0"/>
           </a:p>
@@ -2476,7 +2542,10 @@
           <a:p>
             <a:r>
               <a:rPr lang="en-US" dirty="0"/>
-              <a:t>Practice began in whole-file mode. Say that this is a simplified diff-mode trace, not a transcript claiming a particular model did exactly this. The feature spans CLI, task data, and storage.</a:t>
+              <a:t>They met this request in the practice lessons, in whole-file mode. Today's
+trace is diff mode and it is illustrative: a simplified turn, not a captured
+transcript of a particular model. The three files matter later, when the
+feature half-works.</a:t>
             </a:r>
             <a:endParaRPr lang="en-US" dirty="0"/>
           </a:p>
@@ -2564,7 +2633,10 @@
           <a:p>
             <a:r>
               <a:rPr lang="en-US" dirty="0"/>
-              <a:t>The assigned packet states the exact model IDs and observed-session exception. No frontier design followed by local implementation. Keep design and development sessions, disclose actual aliases and known quantization.</a:t>
+              <a:t>These are points inside the build grade, not percentages of the course grade.
+The build is 4.5% of the course and is due September 25.
+Design keeps its credit when the implementation falls short, as long as the
+design's claims and the final status are honest.</a:t>
             </a:r>
             <a:endParaRPr lang="en-US" dirty="0"/>
           </a:p>
@@ -2652,7 +2724,10 @@
           <a:p>
             <a:r>
               <a:rPr lang="en-US" dirty="0"/>
-              <a:t>Close the 15-minute project block. Dates remain Sep 25 for the build and Sep 24 for hackathon 1. Do not promise a workload estimate. A runnable slice early reduces integration surprises.</a:t>
+              <a:t>The per-feature split is in RUBRIC.md. Only one F4 point depends on the live
+model actually succeeding, and honest evidence of an unsuccessful run still
+earns the reporting points.
+They write every test, including the client protocol checks.</a:t>
             </a:r>
             <a:endParaRPr lang="en-US" dirty="0"/>
           </a:p>
@@ -2740,7 +2815,9 @@
           <a:p>
             <a:r>
               <a:rPr lang="en-US" dirty="0"/>
-              <a:t>Keep this comparison in lab. It is a mechanism comparison, not a claim that Aider lacks automation or that an agentic CLI needs no human judgment. Claude Code is the concrete comparison; no subscription is required for Stage 1. Source: https://code.claude.com/docs/en/overview</a:t>
+              <a:t>No points for suffering, and no repeated deductions for one missing feature
+across otherwise sound artifacts.
+Policy violations go through academic integrity procedures, not the rubric.</a:t>
             </a:r>
             <a:endParaRPr lang="en-US" dirty="0"/>
           </a:p>
@@ -2828,7 +2905,11 @@
           <a:p>
             <a:r>
               <a:rPr lang="en-US" dirty="0"/>
-              <a:t>Use a hypothetical trace, not an unobserved product demonstration. The model can choose actions only from what its harness exposes and permissions allow. Students build this responsibility in Analyze.</a:t>
+              <a:t>Exact model IDs and the observed-session exception are in the assignment packet.
+Read them from there rather than from memory.
+The pattern being ruled out is a frontier model for the design followed by a
+local model for the code. Keep the sessions, disclose real aliases and any
+quantization you know about.</a:t>
             </a:r>
             <a:endParaRPr lang="en-US" dirty="0"/>
           </a:p>
@@ -2916,7 +2997,9 @@
           <a:p>
             <a:r>
               <a:rPr lang="en-US" dirty="0"/>
-              <a:t>Keep product feature details at mechanism level, avoid promising exact weeks for every branded feature. Their DEVELOPMENT.md starts the habit of writing instructions for a future session. Code and permissions enforce constraints that prose alone cannot guarantee.</a:t>
+              <a:t>Close the project block here. Build due September 25, hackathon September 24.
+Do not estimate the workload out loud. Do say that a runnable slice early is
+what keeps the December integration from being a surprise.</a:t>
             </a:r>
             <a:endParaRPr lang="en-US" dirty="0"/>
           </a:p>
@@ -3004,7 +3087,9 @@
           <a:p>
             <a:r>
               <a:rPr lang="en-US" dirty="0"/>
-              <a:t>OpenClaw is a concrete future-system comparison, not a library students must adopt. Source: https://docs.openclaw.ai/concepts/architecture. Keep client/node connections distinct from the agent runtime; the gateway is not simply several agents on one task.</a:t>
+              <a:t>Minutes 55 to 65. This is a mechanism comparison, not a product tour and not a
+recommendation. Nothing here is a Stage 1 dependency and no subscription is
+needed for this course.</a:t>
             </a:r>
             <a:endParaRPr lang="en-US" dirty="0"/>
           </a:p>
@@ -3092,7 +3177,9 @@
           <a:p>
             <a:r>
               <a:rPr lang="en-US" dirty="0"/>
-              <a:t>End future comparison at minute 65. Ask for boundary reasoning, not December implementation. Students may change their answers as the course progresses.</a:t>
+              <a:t>Do not turn the left column into a weakness. Aider automates plenty. What
+changes on the right is who decides the next action.
+Source: https://code.claude.com/docs/en/overview</a:t>
             </a:r>
             <a:endParaRPr lang="en-US" dirty="0"/>
           </a:p>
@@ -3180,7 +3267,10 @@
           <a:p>
             <a:r>
               <a:rPr lang="en-US" dirty="0"/>
-              <a:t>No application exists to run yet. Students launch aider directly using .env and the supplied Aider configuration; they implement bin/assistant themselves. The whole initial system spec is finished after lab, before application implementation. Use peer review plus staff triage.</a:t>
+              <a:t>Label this a hypothetical trace. You have not run it and it is not a product
+demonstration.
+The model can only choose from what the harness exposes and what permissions
+allow. That sentence is the whole design problem, and they build it in Analyze.</a:t>
             </a:r>
             <a:endParaRPr lang="en-US" dirty="0"/>
           </a:p>
@@ -3268,7 +3358,9 @@
           <a:p>
             <a:r>
               <a:rPr lang="en-US" dirty="0"/>
-              <a:t>Do not require every student to queue for a five-minute full-design review. Record unresolved questions and a follow-up path. Peer review concerns contracts, not sharing implementation solutions.</a:t>
+              <a:t>Stay at mechanism level and do not promise a week for each branded feature.
+Their DEVELOPMENT.md is the first version of this habit: instructions written
+for a session that has not happened yet.</a:t>
             </a:r>
             <a:endParaRPr lang="en-US" dirty="0"/>
           </a:p>
@@ -3356,7 +3448,11 @@
           <a:p>
             <a:r>
               <a:rPr lang="en-US" dirty="0"/>
-              <a:t>Remind students of the complete submission packet: design, diagrams, specs, code/tests, configuration example, DEVELOPMENT.md, operating README, evidence, AI_LOG.md, reflection, and sessions. All exact requirements and scoring live in their repository.</a:t>
+              <a:t>Your terminal is one entry point. A gateway is what makes it several.
+Keep the client connections separate from the agent runtime in their heads. This
+is not several agents working on one task. OpenClaw is a comparison, not a
+library anyone here has to adopt.
+Source: https://docs.openclaw.ai/concepts/architecture</a:t>
             </a:r>
             <a:endParaRPr lang="en-US" dirty="0"/>
           </a:p>
@@ -3444,7 +3540,7 @@
           <a:p>
             <a:r>
               <a:rPr lang="en-US" dirty="0"/>
-              <a:t>This is a responsibility diagram of Aider, not a required architecture for their project. Ask students to locate the filesystem write: the model has not acquired direct access to their disk.</a:t>
+              <a:t>Six steps. Say up front that only step 2 belongs to the model.</a:t>
             </a:r>
             <a:endParaRPr lang="en-US" dirty="0"/>
           </a:p>
@@ -3486,6 +3582,549 @@
 </p:notes>
 </file>
 
+<file path=ppt/notesSlides/notesSlide40.xml><?xml version="1.0" encoding="utf-8"?>
+<p:notes xmlns:a="http://schemas.openxmlformats.org/drawingml/2006/main" xmlns:r="http://schemas.openxmlformats.org/officeDocument/2006/relationships" xmlns:p="http://schemas.openxmlformats.org/presentationml/2006/main">
+  <p:cSld>
+    <p:spTree>
+      <p:nvGrpSpPr>
+        <p:cNvPr id="1" name=""/>
+        <p:cNvGrpSpPr/>
+        <p:nvPr/>
+      </p:nvGrpSpPr>
+      <p:grpSpPr>
+        <a:xfrm>
+          <a:off x="0" y="0"/>
+          <a:ext cx="0" cy="0"/>
+          <a:chOff x="0" y="0"/>
+          <a:chExt cx="0" cy="0"/>
+        </a:xfrm>
+      </p:grpSpPr>
+      <p:sp>
+        <p:nvSpPr>
+          <p:cNvPr id="2" name="Slide Image Placeholder 1"/>
+          <p:cNvSpPr>
+            <a:spLocks noGrp="1" noRot="1" noChangeAspect="1"/>
+          </p:cNvSpPr>
+          <p:nvPr>
+            <p:ph type="sldImg"/>
+          </p:nvPr>
+        </p:nvSpPr>
+        <p:spPr/>
+      </p:sp>
+      <p:sp>
+        <p:nvSpPr>
+          <p:cNvPr id="3" name="Notes Placeholder 2"/>
+          <p:cNvSpPr>
+            <a:spLocks noGrp="1"/>
+          </p:cNvSpPr>
+          <p:nvPr>
+            <p:ph type="body" idx="1"/>
+          </p:nvPr>
+        </p:nvSpPr>
+        <p:spPr/>
+        <p:txBody>
+          <a:bodyPr/>
+          <a:lstStyle/>
+          <a:p>
+            <a:r>
+              <a:rPr lang="en-US" dirty="0"/>
+              <a:t>End the comparison here, at minute 65. Nothing after this slide is yours to
+talk through.</a:t>
+            </a:r>
+            <a:endParaRPr lang="en-US" dirty="0"/>
+          </a:p>
+        </p:txBody>
+      </p:sp>
+      <p:sp>
+        <p:nvSpPr>
+          <p:cNvPr id="4" name="Slide Number Placeholder 3"/>
+          <p:cNvSpPr>
+            <a:spLocks noGrp="1"/>
+          </p:cNvSpPr>
+          <p:nvPr>
+            <p:ph type="sldNum" sz="quarter" idx="10"/>
+          </p:nvPr>
+        </p:nvSpPr>
+        <p:spPr/>
+        <p:txBody>
+          <a:bodyPr/>
+          <a:lstStyle/>
+          <a:p>
+            <a:fld id="{F7021451-1387-4CA6-816F-3879F97B5CBC}" type="slidenum">
+              <a:rPr lang="en-US"/>
+              <a:t>40</a:t>
+            </a:fld>
+            <a:endParaRPr lang="en-US"/>
+          </a:p>
+        </p:txBody>
+      </p:sp>
+    </p:spTree>
+    <p:extLst>
+      <p:ext uri="{BB962C8B-B14F-4D97-AF65-F5344CB8AC3E}">
+        <p14:creationId xmlns:p14="http://schemas.microsoft.com/office/powerpoint/2010/main" val="1024086991"/>
+      </p:ext>
+    </p:extLst>
+  </p:cSld>
+  <p:clrMapOvr>
+    <a:masterClrMapping/>
+  </p:clrMapOvr>
+</p:notes>
+</file>
+
+<file path=ppt/notesSlides/notesSlide41.xml><?xml version="1.0" encoding="utf-8"?>
+<p:notes xmlns:a="http://schemas.openxmlformats.org/drawingml/2006/main" xmlns:r="http://schemas.openxmlformats.org/officeDocument/2006/relationships" xmlns:p="http://schemas.openxmlformats.org/presentationml/2006/main">
+  <p:cSld>
+    <p:spTree>
+      <p:nvGrpSpPr>
+        <p:cNvPr id="1" name=""/>
+        <p:cNvGrpSpPr/>
+        <p:nvPr/>
+      </p:nvGrpSpPr>
+      <p:grpSpPr>
+        <a:xfrm>
+          <a:off x="0" y="0"/>
+          <a:ext cx="0" cy="0"/>
+          <a:chOff x="0" y="0"/>
+          <a:chExt cx="0" cy="0"/>
+        </a:xfrm>
+      </p:grpSpPr>
+      <p:sp>
+        <p:nvSpPr>
+          <p:cNvPr id="2" name="Slide Image Placeholder 1"/>
+          <p:cNvSpPr>
+            <a:spLocks noGrp="1" noRot="1" noChangeAspect="1"/>
+          </p:cNvSpPr>
+          <p:nvPr>
+            <p:ph type="sldImg"/>
+          </p:nvPr>
+        </p:nvSpPr>
+        <p:spPr/>
+      </p:sp>
+      <p:sp>
+        <p:nvSpPr>
+          <p:cNvPr id="3" name="Notes Placeholder 2"/>
+          <p:cNvSpPr>
+            <a:spLocks noGrp="1"/>
+          </p:cNvSpPr>
+          <p:nvPr>
+            <p:ph type="body" idx="1"/>
+          </p:nvPr>
+        </p:nvSpPr>
+        <p:spPr/>
+        <p:txBody>
+          <a:bodyPr/>
+          <a:lstStyle/>
+          <a:p>
+            <a:r>
+              <a:rPr lang="en-US" dirty="0"/>
+              <a:t>Stop talking. Staff circulate from here. Leave the deck up so students can page
+back through it themselves.</a:t>
+            </a:r>
+            <a:endParaRPr lang="en-US" dirty="0"/>
+          </a:p>
+        </p:txBody>
+      </p:sp>
+      <p:sp>
+        <p:nvSpPr>
+          <p:cNvPr id="4" name="Slide Number Placeholder 3"/>
+          <p:cNvSpPr>
+            <a:spLocks noGrp="1"/>
+          </p:cNvSpPr>
+          <p:nvPr>
+            <p:ph type="sldNum" sz="quarter" idx="10"/>
+          </p:nvPr>
+        </p:nvSpPr>
+        <p:spPr/>
+        <p:txBody>
+          <a:bodyPr/>
+          <a:lstStyle/>
+          <a:p>
+            <a:fld id="{F7021451-1387-4CA6-816F-3879F97B5CBC}" type="slidenum">
+              <a:rPr lang="en-US"/>
+              <a:t>41</a:t>
+            </a:fld>
+            <a:endParaRPr lang="en-US"/>
+          </a:p>
+        </p:txBody>
+      </p:sp>
+    </p:spTree>
+    <p:extLst>
+      <p:ext uri="{BB962C8B-B14F-4D97-AF65-F5344CB8AC3E}">
+        <p14:creationId xmlns:p14="http://schemas.microsoft.com/office/powerpoint/2010/main" val="1024086991"/>
+      </p:ext>
+    </p:extLst>
+  </p:cSld>
+  <p:clrMapOvr>
+    <a:masterClrMapping/>
+  </p:clrMapOvr>
+</p:notes>
+</file>
+
+<file path=ppt/notesSlides/notesSlide42.xml><?xml version="1.0" encoding="utf-8"?>
+<p:notes xmlns:a="http://schemas.openxmlformats.org/drawingml/2006/main" xmlns:r="http://schemas.openxmlformats.org/officeDocument/2006/relationships" xmlns:p="http://schemas.openxmlformats.org/presentationml/2006/main">
+  <p:cSld>
+    <p:spTree>
+      <p:nvGrpSpPr>
+        <p:cNvPr id="1" name=""/>
+        <p:cNvGrpSpPr/>
+        <p:nvPr/>
+      </p:nvGrpSpPr>
+      <p:grpSpPr>
+        <a:xfrm>
+          <a:off x="0" y="0"/>
+          <a:ext cx="0" cy="0"/>
+          <a:chOff x="0" y="0"/>
+          <a:chExt cx="0" cy="0"/>
+        </a:xfrm>
+      </p:grpSpPr>
+      <p:sp>
+        <p:nvSpPr>
+          <p:cNvPr id="2" name="Slide Image Placeholder 1"/>
+          <p:cNvSpPr>
+            <a:spLocks noGrp="1" noRot="1" noChangeAspect="1"/>
+          </p:cNvSpPr>
+          <p:nvPr>
+            <p:ph type="sldImg"/>
+          </p:nvPr>
+        </p:nvSpPr>
+        <p:spPr/>
+      </p:sp>
+      <p:sp>
+        <p:nvSpPr>
+          <p:cNvPr id="3" name="Notes Placeholder 2"/>
+          <p:cNvSpPr>
+            <a:spLocks noGrp="1"/>
+          </p:cNvSpPr>
+          <p:nvPr>
+            <p:ph type="body" idx="1"/>
+          </p:nvPr>
+        </p:nvSpPr>
+        <p:spPr/>
+        <p:txBody>
+          <a:bodyPr/>
+          <a:lstStyle/>
+          <a:p>
+            <a:r>
+              <a:rPr lang="en-US" dirty="0"/>
+              <a:t>No application exists to run yet. They launch aider directly with .env and the
+supplied configuration, and they write bin/assistant themselves.
+If someone lacks repository access, fix it immediately and let them read the
+packet while you do. Do not hand them an unrelated clone as a substitute.</a:t>
+            </a:r>
+            <a:endParaRPr lang="en-US" dirty="0"/>
+          </a:p>
+        </p:txBody>
+      </p:sp>
+      <p:sp>
+        <p:nvSpPr>
+          <p:cNvPr id="4" name="Slide Number Placeholder 3"/>
+          <p:cNvSpPr>
+            <a:spLocks noGrp="1"/>
+          </p:cNvSpPr>
+          <p:nvPr>
+            <p:ph type="sldNum" sz="quarter" idx="10"/>
+          </p:nvPr>
+        </p:nvSpPr>
+        <p:spPr/>
+        <p:txBody>
+          <a:bodyPr/>
+          <a:lstStyle/>
+          <a:p>
+            <a:fld id="{F7021451-1387-4CA6-816F-3879F97B5CBC}" type="slidenum">
+              <a:rPr lang="en-US"/>
+              <a:t>42</a:t>
+            </a:fld>
+            <a:endParaRPr lang="en-US"/>
+          </a:p>
+        </p:txBody>
+      </p:sp>
+    </p:spTree>
+    <p:extLst>
+      <p:ext uri="{BB962C8B-B14F-4D97-AF65-F5344CB8AC3E}">
+        <p14:creationId xmlns:p14="http://schemas.microsoft.com/office/powerpoint/2010/main" val="1024086991"/>
+      </p:ext>
+    </p:extLst>
+  </p:cSld>
+  <p:clrMapOvr>
+    <a:masterClrMapping/>
+  </p:clrMapOvr>
+</p:notes>
+</file>
+
+<file path=ppt/notesSlides/notesSlide43.xml><?xml version="1.0" encoding="utf-8"?>
+<p:notes xmlns:a="http://schemas.openxmlformats.org/drawingml/2006/main" xmlns:r="http://schemas.openxmlformats.org/officeDocument/2006/relationships" xmlns:p="http://schemas.openxmlformats.org/presentationml/2006/main">
+  <p:cSld>
+    <p:spTree>
+      <p:nvGrpSpPr>
+        <p:cNvPr id="1" name=""/>
+        <p:cNvGrpSpPr/>
+        <p:nvPr/>
+      </p:nvGrpSpPr>
+      <p:grpSpPr>
+        <a:xfrm>
+          <a:off x="0" y="0"/>
+          <a:ext cx="0" cy="0"/>
+          <a:chOff x="0" y="0"/>
+          <a:chExt cx="0" cy="0"/>
+        </a:xfrm>
+      </p:grpSpPr>
+      <p:sp>
+        <p:nvSpPr>
+          <p:cNvPr id="2" name="Slide Image Placeholder 1"/>
+          <p:cNvSpPr>
+            <a:spLocks noGrp="1" noRot="1" noChangeAspect="1"/>
+          </p:cNvSpPr>
+          <p:nvPr>
+            <p:ph type="sldImg"/>
+          </p:nvPr>
+        </p:nvSpPr>
+        <p:spPr/>
+      </p:sp>
+      <p:sp>
+        <p:nvSpPr>
+          <p:cNvPr id="3" name="Notes Placeholder 2"/>
+          <p:cNvSpPr>
+            <a:spLocks noGrp="1"/>
+          </p:cNvSpPr>
+          <p:nvPr>
+            <p:ph type="body" idx="1"/>
+          </p:nvPr>
+        </p:nvSpPr>
+        <p:spPr/>
+        <p:txBody>
+          <a:bodyPr/>
+          <a:lstStyle/>
+          <a:p>
+            <a:r>
+              <a:rPr lang="en-US" dirty="0"/>
+              <a:t>Fifty students at five minutes each is 250 staff-minutes, so there is no full
+design review queue today and do not promise one.
+Peer review is about contracts and verification. It is not code sharing. A
+blocking question gets a concrete follow-up through Ed or office hours.
+What you are looking for as you circulate: an observable outcome, named state
+ownership, explicit error behavior, and one meaningful test. Accept different
+architectures. Do not require a particular file, class or module count.</a:t>
+            </a:r>
+            <a:endParaRPr lang="en-US" dirty="0"/>
+          </a:p>
+        </p:txBody>
+      </p:sp>
+      <p:sp>
+        <p:nvSpPr>
+          <p:cNvPr id="4" name="Slide Number Placeholder 3"/>
+          <p:cNvSpPr>
+            <a:spLocks noGrp="1"/>
+          </p:cNvSpPr>
+          <p:nvPr>
+            <p:ph type="sldNum" sz="quarter" idx="10"/>
+          </p:nvPr>
+        </p:nvSpPr>
+        <p:spPr/>
+        <p:txBody>
+          <a:bodyPr/>
+          <a:lstStyle/>
+          <a:p>
+            <a:fld id="{F7021451-1387-4CA6-816F-3879F97B5CBC}" type="slidenum">
+              <a:rPr lang="en-US"/>
+              <a:t>43</a:t>
+            </a:fld>
+            <a:endParaRPr lang="en-US"/>
+          </a:p>
+        </p:txBody>
+      </p:sp>
+    </p:spTree>
+    <p:extLst>
+      <p:ext uri="{BB962C8B-B14F-4D97-AF65-F5344CB8AC3E}">
+        <p14:creationId xmlns:p14="http://schemas.microsoft.com/office/powerpoint/2010/main" val="1024086991"/>
+      </p:ext>
+    </p:extLst>
+  </p:cSld>
+  <p:clrMapOvr>
+    <a:masterClrMapping/>
+  </p:clrMapOvr>
+</p:notes>
+</file>
+
+<file path=ppt/notesSlides/notesSlide44.xml><?xml version="1.0" encoding="utf-8"?>
+<p:notes xmlns:a="http://schemas.openxmlformats.org/drawingml/2006/main" xmlns:r="http://schemas.openxmlformats.org/officeDocument/2006/relationships" xmlns:p="http://schemas.openxmlformats.org/presentationml/2006/main">
+  <p:cSld>
+    <p:spTree>
+      <p:nvGrpSpPr>
+        <p:cNvPr id="1" name=""/>
+        <p:cNvGrpSpPr/>
+        <p:nvPr/>
+      </p:nvGrpSpPr>
+      <p:grpSpPr>
+        <a:xfrm>
+          <a:off x="0" y="0"/>
+          <a:ext cx="0" cy="0"/>
+          <a:chOff x="0" y="0"/>
+          <a:chExt cx="0" cy="0"/>
+        </a:xfrm>
+      </p:grpSpPr>
+      <p:sp>
+        <p:nvSpPr>
+          <p:cNvPr id="2" name="Slide Image Placeholder 1"/>
+          <p:cNvSpPr>
+            <a:spLocks noGrp="1" noRot="1" noChangeAspect="1"/>
+          </p:cNvSpPr>
+          <p:nvPr>
+            <p:ph type="sldImg"/>
+          </p:nvPr>
+        </p:nvSpPr>
+        <p:spPr/>
+      </p:sp>
+      <p:sp>
+        <p:nvSpPr>
+          <p:cNvPr id="3" name="Notes Placeholder 2"/>
+          <p:cNvSpPr>
+            <a:spLocks noGrp="1"/>
+          </p:cNvSpPr>
+          <p:nvPr>
+            <p:ph type="body" idx="1"/>
+          </p:nvPr>
+        </p:nvSpPr>
+        <p:spPr/>
+        <p:txBody>
+          <a:bodyPr/>
+          <a:lstStyle/>
+          <a:p>
+            <a:r>
+              <a:rPr lang="en-US" dirty="0"/>
+              <a:t>Read the packet list once: design, diagrams, specs, code and tests,
+configuration example, DEVELOPMENT.md, operating README, evidence, AI_LOG.md,
+reflection, and the preserved sessions.
+Lab02 is supported implementation and verification time. September 25 does not
+move.</a:t>
+            </a:r>
+            <a:endParaRPr lang="en-US" dirty="0"/>
+          </a:p>
+        </p:txBody>
+      </p:sp>
+      <p:sp>
+        <p:nvSpPr>
+          <p:cNvPr id="4" name="Slide Number Placeholder 3"/>
+          <p:cNvSpPr>
+            <a:spLocks noGrp="1"/>
+          </p:cNvSpPr>
+          <p:nvPr>
+            <p:ph type="sldNum" sz="quarter" idx="10"/>
+          </p:nvPr>
+        </p:nvSpPr>
+        <p:spPr/>
+        <p:txBody>
+          <a:bodyPr/>
+          <a:lstStyle/>
+          <a:p>
+            <a:fld id="{F7021451-1387-4CA6-816F-3879F97B5CBC}" type="slidenum">
+              <a:rPr lang="en-US"/>
+              <a:t>44</a:t>
+            </a:fld>
+            <a:endParaRPr lang="en-US"/>
+          </a:p>
+        </p:txBody>
+      </p:sp>
+    </p:spTree>
+    <p:extLst>
+      <p:ext uri="{BB962C8B-B14F-4D97-AF65-F5344CB8AC3E}">
+        <p14:creationId xmlns:p14="http://schemas.microsoft.com/office/powerpoint/2010/main" val="1024086991"/>
+      </p:ext>
+    </p:extLst>
+  </p:cSld>
+  <p:clrMapOvr>
+    <a:masterClrMapping/>
+  </p:clrMapOvr>
+</p:notes>
+</file>
+
+<file path=ppt/notesSlides/notesSlide45.xml><?xml version="1.0" encoding="utf-8"?>
+<p:notes xmlns:a="http://schemas.openxmlformats.org/drawingml/2006/main" xmlns:r="http://schemas.openxmlformats.org/officeDocument/2006/relationships" xmlns:p="http://schemas.openxmlformats.org/presentationml/2006/main">
+  <p:cSld>
+    <p:spTree>
+      <p:nvGrpSpPr>
+        <p:cNvPr id="1" name=""/>
+        <p:cNvGrpSpPr/>
+        <p:nvPr/>
+      </p:nvGrpSpPr>
+      <p:grpSpPr>
+        <a:xfrm>
+          <a:off x="0" y="0"/>
+          <a:ext cx="0" cy="0"/>
+          <a:chOff x="0" y="0"/>
+          <a:chExt cx="0" cy="0"/>
+        </a:xfrm>
+      </p:grpSpPr>
+      <p:sp>
+        <p:nvSpPr>
+          <p:cNvPr id="2" name="Slide Image Placeholder 1"/>
+          <p:cNvSpPr>
+            <a:spLocks noGrp="1" noRot="1" noChangeAspect="1"/>
+          </p:cNvSpPr>
+          <p:nvPr>
+            <p:ph type="sldImg"/>
+          </p:nvPr>
+        </p:nvSpPr>
+        <p:spPr/>
+      </p:sp>
+      <p:sp>
+        <p:nvSpPr>
+          <p:cNvPr id="3" name="Notes Placeholder 2"/>
+          <p:cNvSpPr>
+            <a:spLocks noGrp="1"/>
+          </p:cNvSpPr>
+          <p:nvPr>
+            <p:ph type="body" idx="1"/>
+          </p:nvPr>
+        </p:nvSpPr>
+        <p:spPr/>
+        <p:txBody>
+          <a:bodyPr/>
+          <a:lstStyle/>
+          <a:p>
+            <a:r>
+              <a:rPr lang="en-US" dirty="0"/>
+              <a:t/>
+            </a:r>
+            <a:endParaRPr lang="en-US" dirty="0"/>
+          </a:p>
+        </p:txBody>
+      </p:sp>
+      <p:sp>
+        <p:nvSpPr>
+          <p:cNvPr id="4" name="Slide Number Placeholder 3"/>
+          <p:cNvSpPr>
+            <a:spLocks noGrp="1"/>
+          </p:cNvSpPr>
+          <p:nvPr>
+            <p:ph type="sldNum" sz="quarter" idx="10"/>
+          </p:nvPr>
+        </p:nvSpPr>
+        <p:spPr/>
+        <p:txBody>
+          <a:bodyPr/>
+          <a:lstStyle/>
+          <a:p>
+            <a:fld id="{F7021451-1387-4CA6-816F-3879F97B5CBC}" type="slidenum">
+              <a:rPr lang="en-US"/>
+              <a:t>45</a:t>
+            </a:fld>
+            <a:endParaRPr lang="en-US"/>
+          </a:p>
+        </p:txBody>
+      </p:sp>
+    </p:spTree>
+    <p:extLst>
+      <p:ext uri="{BB962C8B-B14F-4D97-AF65-F5344CB8AC3E}">
+        <p14:creationId xmlns:p14="http://schemas.microsoft.com/office/powerpoint/2010/main" val="1024086991"/>
+      </p:ext>
+    </p:extLst>
+  </p:cSld>
+  <p:clrMapOvr>
+    <a:masterClrMapping/>
+  </p:clrMapOvr>
+</p:notes>
+</file>
+
 <file path=ppt/notesSlides/notesSlide5.xml><?xml version="1.0" encoding="utf-8"?>
 <p:notes xmlns:a="http://schemas.openxmlformats.org/drawingml/2006/main" xmlns:r="http://schemas.openxmlformats.org/officeDocument/2006/relationships" xmlns:p="http://schemas.openxmlformats.org/presentationml/2006/main">
   <p:cSld>
@@ -3532,7 +4171,10 @@
           <a:p>
             <a:r>
               <a:rPr lang="en-US" dirty="0"/>
-              <a:t>Avoid claiming a universal seven-part ordering; actual prompt composition depends on coder, model, and settings. Ask what the model would need to implement priority consistently across CLI and storage.</a:t>
+              <a:t>Ask the room to find the arrow that writes a file. There is not one leaving the
+amber box. The model produced text, and a program decided what to do with it.
+This is a picture of Aider, not a required architecture for their build. They
+will draw their own version of this in a week.</a:t>
             </a:r>
             <a:endParaRPr lang="en-US" dirty="0"/>
           </a:p>
@@ -3620,7 +4262,11 @@
           <a:p>
             <a:r>
               <a:rPr lang="en-US" dirty="0"/>
-              <a:t>Explain why these files are relevant. This is an example selection, not an instruction to add every file. Read-only context still consumes space. /tokens gives a diagnostic, not a guarantee of implementation correctness.</a:t>
+              <a:t>Do not claim a fixed seven-part ordering. What actually goes into the prompt
+depends on the coder, the model and the settings, and it changes between
+releases. The list above is the shape, not the wire format.
+Ask what the model would need in order to add priority consistently to the CLI,
+the task and the store. That question sets up the next two slides.</a:t>
             </a:r>
             <a:endParaRPr lang="en-US" dirty="0"/>
           </a:p>
@@ -3708,7 +4354,10 @@
           <a:p>
             <a:r>
               <a:rPr lang="en-US" dirty="0"/>
-              <a:t>The excerpt is illustrative. Aider builds a graph of definitions/references and ranks useful portions. Do not promise the map includes every file or proves a dependency absent. Source: https://aider.chat/docs/repomap.html</a:t>
+              <a:t>Walk through why these three files and not the whole package. This is one
+sensible selection, not a rule to add everything. Read-only context still
+costs budget. /tokens tells you what you are spending, and nothing about
+whether the edit will be correct.</a:t>
             </a:r>
             <a:endParaRPr lang="en-US" dirty="0"/>
           </a:p>
@@ -3796,7 +4445,10 @@
           <a:p>
             <a:r>
               <a:rPr lang="en-US" dirty="0"/>
-              <a:t>Ask what can be removed and what must survive. Their project will preserve system instructions, current request, and selected file contents, rejecting an oversized mandatory input rather than silently truncating it.</a:t>
+              <a:t>The excerpt is illustrative. Do not promise the map contains every file, and do
+not use its silence as proof that a dependency is absent. When a student says
+"the model should have known," check whether they added the file or only let the
+map mention it. Source: https://aider.chat/docs/repomap.html</a:t>
             </a:r>
             <a:endParaRPr lang="en-US" dirty="0"/>
           </a:p>
@@ -3884,7 +4536,10 @@
           <a:p>
             <a:r>
               <a:rPr lang="en-US" dirty="0"/>
-              <a:t>A deliberately small illustrative block. It does not implement storage or validation. Ask what is missing. Reading only the happy-looking block would miss the incomplete feature.</a:t>
+              <a:t>Ask what they would drop first and what has to survive. Their Stage 1 contract
+keeps the system instructions, the current request and the added file contents,
+and refuses an oversized required input instead of silently trimming it. That
+refusal is a design decision they have to write down and test.</a:t>
             </a:r>
             <a:endParaRPr lang="en-US" dirty="0"/>
           </a:p>
@@ -5523,6 +6178,240 @@
 <file path=ppt/slides/slide4.xml><?xml version="1.0" encoding="utf-8"?>
 <p:sld xmlns:a="http://schemas.openxmlformats.org/drawingml/2006/main" xmlns:r="http://schemas.openxmlformats.org/officeDocument/2006/relationships" xmlns:p="http://schemas.openxmlformats.org/presentationml/2006/main">
   <p:cSld name="Slide 4">
+    <p:bg>
+      <p:bgPr>
+        <a:blipFill dpi="0" rotWithShape="1">
+          <a:blip r:embed="rId1">
+            <a:lum/>
+          </a:blip>
+          <a:srcRect/>
+          <a:stretch>
+            <a:fillRect/>
+          </a:stretch>
+        </a:blipFill>
+        <a:effectLst/>
+      </p:bgPr>
+    </p:bg>
+    <p:spTree>
+      <p:nvGrpSpPr>
+        <p:cNvPr id="1" name=""/>
+        <p:cNvGrpSpPr/>
+        <p:nvPr/>
+      </p:nvGrpSpPr>
+      <p:grpSpPr>
+        <a:xfrm>
+          <a:off x="0" y="0"/>
+          <a:ext cx="0" cy="0"/>
+          <a:chOff x="0" y="0"/>
+          <a:chExt cx="0" cy="0"/>
+        </a:xfrm>
+      </p:grpSpPr>
+    </p:spTree>
+  </p:cSld>
+  <p:clrMapOvr>
+    <a:masterClrMapping/>
+  </p:clrMapOvr>
+</p:sld>
+</file>
+
+<file path=ppt/slides/slide40.xml><?xml version="1.0" encoding="utf-8"?>
+<p:sld xmlns:a="http://schemas.openxmlformats.org/drawingml/2006/main" xmlns:r="http://schemas.openxmlformats.org/officeDocument/2006/relationships" xmlns:p="http://schemas.openxmlformats.org/presentationml/2006/main">
+  <p:cSld name="Slide 40">
+    <p:bg>
+      <p:bgPr>
+        <a:blipFill dpi="0" rotWithShape="1">
+          <a:blip r:embed="rId1">
+            <a:lum/>
+          </a:blip>
+          <a:srcRect/>
+          <a:stretch>
+            <a:fillRect/>
+          </a:stretch>
+        </a:blipFill>
+        <a:effectLst/>
+      </p:bgPr>
+    </p:bg>
+    <p:spTree>
+      <p:nvGrpSpPr>
+        <p:cNvPr id="1" name=""/>
+        <p:cNvGrpSpPr/>
+        <p:nvPr/>
+      </p:nvGrpSpPr>
+      <p:grpSpPr>
+        <a:xfrm>
+          <a:off x="0" y="0"/>
+          <a:ext cx="0" cy="0"/>
+          <a:chOff x="0" y="0"/>
+          <a:chExt cx="0" cy="0"/>
+        </a:xfrm>
+      </p:grpSpPr>
+    </p:spTree>
+  </p:cSld>
+  <p:clrMapOvr>
+    <a:masterClrMapping/>
+  </p:clrMapOvr>
+</p:sld>
+</file>
+
+<file path=ppt/slides/slide41.xml><?xml version="1.0" encoding="utf-8"?>
+<p:sld xmlns:a="http://schemas.openxmlformats.org/drawingml/2006/main" xmlns:r="http://schemas.openxmlformats.org/officeDocument/2006/relationships" xmlns:p="http://schemas.openxmlformats.org/presentationml/2006/main">
+  <p:cSld name="Slide 41">
+    <p:bg>
+      <p:bgPr>
+        <a:blipFill dpi="0" rotWithShape="1">
+          <a:blip r:embed="rId1">
+            <a:lum/>
+          </a:blip>
+          <a:srcRect/>
+          <a:stretch>
+            <a:fillRect/>
+          </a:stretch>
+        </a:blipFill>
+        <a:effectLst/>
+      </p:bgPr>
+    </p:bg>
+    <p:spTree>
+      <p:nvGrpSpPr>
+        <p:cNvPr id="1" name=""/>
+        <p:cNvGrpSpPr/>
+        <p:nvPr/>
+      </p:nvGrpSpPr>
+      <p:grpSpPr>
+        <a:xfrm>
+          <a:off x="0" y="0"/>
+          <a:ext cx="0" cy="0"/>
+          <a:chOff x="0" y="0"/>
+          <a:chExt cx="0" cy="0"/>
+        </a:xfrm>
+      </p:grpSpPr>
+    </p:spTree>
+  </p:cSld>
+  <p:clrMapOvr>
+    <a:masterClrMapping/>
+  </p:clrMapOvr>
+</p:sld>
+</file>
+
+<file path=ppt/slides/slide42.xml><?xml version="1.0" encoding="utf-8"?>
+<p:sld xmlns:a="http://schemas.openxmlformats.org/drawingml/2006/main" xmlns:r="http://schemas.openxmlformats.org/officeDocument/2006/relationships" xmlns:p="http://schemas.openxmlformats.org/presentationml/2006/main">
+  <p:cSld name="Slide 42">
+    <p:bg>
+      <p:bgPr>
+        <a:blipFill dpi="0" rotWithShape="1">
+          <a:blip r:embed="rId1">
+            <a:lum/>
+          </a:blip>
+          <a:srcRect/>
+          <a:stretch>
+            <a:fillRect/>
+          </a:stretch>
+        </a:blipFill>
+        <a:effectLst/>
+      </p:bgPr>
+    </p:bg>
+    <p:spTree>
+      <p:nvGrpSpPr>
+        <p:cNvPr id="1" name=""/>
+        <p:cNvGrpSpPr/>
+        <p:nvPr/>
+      </p:nvGrpSpPr>
+      <p:grpSpPr>
+        <a:xfrm>
+          <a:off x="0" y="0"/>
+          <a:ext cx="0" cy="0"/>
+          <a:chOff x="0" y="0"/>
+          <a:chExt cx="0" cy="0"/>
+        </a:xfrm>
+      </p:grpSpPr>
+    </p:spTree>
+  </p:cSld>
+  <p:clrMapOvr>
+    <a:masterClrMapping/>
+  </p:clrMapOvr>
+</p:sld>
+</file>
+
+<file path=ppt/slides/slide43.xml><?xml version="1.0" encoding="utf-8"?>
+<p:sld xmlns:a="http://schemas.openxmlformats.org/drawingml/2006/main" xmlns:r="http://schemas.openxmlformats.org/officeDocument/2006/relationships" xmlns:p="http://schemas.openxmlformats.org/presentationml/2006/main">
+  <p:cSld name="Slide 43">
+    <p:bg>
+      <p:bgPr>
+        <a:blipFill dpi="0" rotWithShape="1">
+          <a:blip r:embed="rId1">
+            <a:lum/>
+          </a:blip>
+          <a:srcRect/>
+          <a:stretch>
+            <a:fillRect/>
+          </a:stretch>
+        </a:blipFill>
+        <a:effectLst/>
+      </p:bgPr>
+    </p:bg>
+    <p:spTree>
+      <p:nvGrpSpPr>
+        <p:cNvPr id="1" name=""/>
+        <p:cNvGrpSpPr/>
+        <p:nvPr/>
+      </p:nvGrpSpPr>
+      <p:grpSpPr>
+        <a:xfrm>
+          <a:off x="0" y="0"/>
+          <a:ext cx="0" cy="0"/>
+          <a:chOff x="0" y="0"/>
+          <a:chExt cx="0" cy="0"/>
+        </a:xfrm>
+      </p:grpSpPr>
+    </p:spTree>
+  </p:cSld>
+  <p:clrMapOvr>
+    <a:masterClrMapping/>
+  </p:clrMapOvr>
+</p:sld>
+</file>
+
+<file path=ppt/slides/slide44.xml><?xml version="1.0" encoding="utf-8"?>
+<p:sld xmlns:a="http://schemas.openxmlformats.org/drawingml/2006/main" xmlns:r="http://schemas.openxmlformats.org/officeDocument/2006/relationships" xmlns:p="http://schemas.openxmlformats.org/presentationml/2006/main">
+  <p:cSld name="Slide 44">
+    <p:bg>
+      <p:bgPr>
+        <a:blipFill dpi="0" rotWithShape="1">
+          <a:blip r:embed="rId1">
+            <a:lum/>
+          </a:blip>
+          <a:srcRect/>
+          <a:stretch>
+            <a:fillRect/>
+          </a:stretch>
+        </a:blipFill>
+        <a:effectLst/>
+      </p:bgPr>
+    </p:bg>
+    <p:spTree>
+      <p:nvGrpSpPr>
+        <p:cNvPr id="1" name=""/>
+        <p:cNvGrpSpPr/>
+        <p:nvPr/>
+      </p:nvGrpSpPr>
+      <p:grpSpPr>
+        <a:xfrm>
+          <a:off x="0" y="0"/>
+          <a:ext cx="0" cy="0"/>
+          <a:chOff x="0" y="0"/>
+          <a:chExt cx="0" cy="0"/>
+        </a:xfrm>
+      </p:grpSpPr>
+    </p:spTree>
+  </p:cSld>
+  <p:clrMapOvr>
+    <a:masterClrMapping/>
+  </p:clrMapOvr>
+</p:sld>
+</file>
+
+<file path=ppt/slides/slide45.xml><?xml version="1.0" encoding="utf-8"?>
+<p:sld xmlns:a="http://schemas.openxmlformats.org/drawingml/2006/main" xmlns:r="http://schemas.openxmlformats.org/officeDocument/2006/relationships" xmlns:p="http://schemas.openxmlformats.org/presentationml/2006/main">
+  <p:cSld name="Slide 45">
     <p:bg>
       <p:bgPr>
         <a:blipFill dpi="0" rotWithShape="1">

</xml_diff>

<commit_message>
Lab01: republish with office hours and the new slide 2
Slide 2 no longer carries per-part minutes, and the second half of the
session is office hours with no deliverable. Byte-identical to
aase-f26@1988712.

Co-Authored-By: Claude Opus 5 (1M context) <noreply@anthropic.com>
Claude-Session: https://claude.ai/code/session_015pu78gNF4378sH81fTPKSc
</commit_message>
<xml_diff>
--- a/labs/Lab01/slides.pptx
+++ b/labs/Lab01/slides.pptx
@@ -1545,8 +1545,12 @@
             <a:r>
               <a:rPr lang="en-US" dirty="0"/>
               <a:t>Put this up while the room settles and leave it up. The agenda is part of the
-first block, not an extra segment in front of it. Say out loud that the work
-block is real working time and that you will stop talking at minute 65.</a:t>
+first block, not an extra segment in front of it.
+Say out loud that the second half is genuinely office hours: they work, you
+circulate, and nobody hands anything in today. Students who have been told all
+term that labs end in a checkoff will not believe it unless you say it.
+Do not preview the build past the word itself. The reveal is still yours to
+make in the third section.</a:t>
             </a:r>
             <a:endParaRPr lang="en-US" dirty="0"/>
           </a:p>
@@ -3718,7 +3722,9 @@
             <a:r>
               <a:rPr lang="en-US" dirty="0"/>
               <a:t>Stop talking. Staff circulate from here. Leave the deck up so students can page
-back through it themselves.</a:t>
+back through it themselves.
+This is the point where you say plainly that nothing is due at the end of
+today. Most of them will still expect a checkoff.</a:t>
             </a:r>
             <a:endParaRPr lang="en-US" dirty="0"/>
           </a:p>
@@ -3809,7 +3815,10 @@
               <a:t>No application exists to run yet. They launch aider directly with .env and the
 supplied configuration, and they write bin/assistant themselves.
 If someone lacks repository access, fix it immediately and let them read the
-packet while you do. Do not hand them an unrelated clone as a substitute.</a:t>
+packet while you do. Do not hand them an unrelated clone as a substitute.
+That one is worth hunting for rather than waiting to be asked about.
+The list is a menu, not an order of work. A student who spends the whole time
+reading SPEC.md has used it correctly.</a:t>
             </a:r>
             <a:endParaRPr lang="en-US" dirty="0"/>
           </a:p>
@@ -3991,7 +4000,11 @@
           <a:p>
             <a:r>
               <a:rPr lang="en-US" dirty="0"/>
-              <a:t>Read the packet list once: design, diagrams, specs, code and tests,
+              <a:t>Say the distinction out loud. Nothing on this slide is due because of today;
+it is the order of work for a project that has been due Sep 25 all along, and
+a room that has just been told the lab collects nothing can hear this list as
+a lab assignment if you let it.
+Read the packet list once: design, diagrams, specs, code and tests,
 configuration example, DEVELOPMENT.md, operating README, evidence, AI_LOG.md,
 reflection, and the preserved sessions.
 Lab02 is supported implementation and verification time. September 25 does not

</xml_diff>

<commit_message>
Lab01: republish the overhauled deck
Opens by explaining what Aider is: models and endpoints, the three config
files, the session banner, the command set. All slides retitled to the new
title rule. 43 slides. Byte-identical to aase-f26@9a5357c.

Co-Authored-By: Claude Opus 5 (1M context) <noreply@anthropic.com>
Claude-Session: https://claude.ai/code/session_015pu78gNF4378sH81fTPKSc
</commit_message>
<xml_diff>
--- a/labs/Lab01/slides.pptx
+++ b/labs/Lab01/slides.pptx
@@ -48,11 +48,9 @@
     <p:sldId id="296" r:id="rId42"/>
     <p:sldId id="297" r:id="rId43"/>
     <p:sldId id="298" r:id="rId44"/>
-    <p:sldId id="299" r:id="rId45"/>
-    <p:sldId id="300" r:id="rId46"/>
   </p:sldIdLst>
   <p:notesMasterIdLst>
-    <p:notesMasterId r:id="rId47"/>
+    <p:notesMasterId r:id="rId45"/>
   </p:notesMasterIdLst>
   <p:sldSz cx="9334500" cy="5248275"/>
   <p:notesSz cx="5248275" cy="9334500"/>
@@ -636,6 +634,462 @@
           <a:p>
             <a:r>
               <a:rPr lang="en-US" dirty="0"/>
+              <a:t>Ask the room to find the arrow that writes a file. There is not one leaving the
+amber box. The model produced text, and a program decided what to do with it.
+This is a picture of Aider, not a required architecture for their build. They
+will draw their own version of this in a week.</a:t>
+            </a:r>
+            <a:endParaRPr lang="en-US" dirty="0"/>
+          </a:p>
+        </p:txBody>
+      </p:sp>
+      <p:sp>
+        <p:nvSpPr>
+          <p:cNvPr id="4" name="Slide Number Placeholder 3"/>
+          <p:cNvSpPr>
+            <a:spLocks noGrp="1"/>
+          </p:cNvSpPr>
+          <p:nvPr>
+            <p:ph type="sldNum" sz="quarter" idx="10"/>
+          </p:nvPr>
+        </p:nvSpPr>
+        <p:spPr/>
+        <p:txBody>
+          <a:bodyPr/>
+          <a:lstStyle/>
+          <a:p>
+            <a:fld id="{F7021451-1387-4CA6-816F-3879F97B5CBC}" type="slidenum">
+              <a:rPr lang="en-US"/>
+              <a:t>10</a:t>
+            </a:fld>
+            <a:endParaRPr lang="en-US"/>
+          </a:p>
+        </p:txBody>
+      </p:sp>
+    </p:spTree>
+    <p:extLst>
+      <p:ext uri="{BB962C8B-B14F-4D97-AF65-F5344CB8AC3E}">
+        <p14:creationId xmlns:p14="http://schemas.microsoft.com/office/powerpoint/2010/main" val="1024086991"/>
+      </p:ext>
+    </p:extLst>
+  </p:cSld>
+  <p:clrMapOvr>
+    <a:masterClrMapping/>
+  </p:clrMapOvr>
+</p:notes>
+</file>
+
+<file path=ppt/notesSlides/notesSlide11.xml><?xml version="1.0" encoding="utf-8"?>
+<p:notes xmlns:a="http://schemas.openxmlformats.org/drawingml/2006/main" xmlns:r="http://schemas.openxmlformats.org/officeDocument/2006/relationships" xmlns:p="http://schemas.openxmlformats.org/presentationml/2006/main">
+  <p:cSld>
+    <p:spTree>
+      <p:nvGrpSpPr>
+        <p:cNvPr id="1" name=""/>
+        <p:cNvGrpSpPr/>
+        <p:nvPr/>
+      </p:nvGrpSpPr>
+      <p:grpSpPr>
+        <a:xfrm>
+          <a:off x="0" y="0"/>
+          <a:ext cx="0" cy="0"/>
+          <a:chOff x="0" y="0"/>
+          <a:chExt cx="0" cy="0"/>
+        </a:xfrm>
+      </p:grpSpPr>
+      <p:sp>
+        <p:nvSpPr>
+          <p:cNvPr id="2" name="Slide Image Placeholder 1"/>
+          <p:cNvSpPr>
+            <a:spLocks noGrp="1" noRot="1" noChangeAspect="1"/>
+          </p:cNvSpPr>
+          <p:nvPr>
+            <p:ph type="sldImg"/>
+          </p:nvPr>
+        </p:nvSpPr>
+        <p:spPr/>
+      </p:sp>
+      <p:sp>
+        <p:nvSpPr>
+          <p:cNvPr id="3" name="Notes Placeholder 2"/>
+          <p:cNvSpPr>
+            <a:spLocks noGrp="1"/>
+          </p:cNvSpPr>
+          <p:nvPr>
+            <p:ph type="body" idx="1"/>
+          </p:nvPr>
+        </p:nvSpPr>
+        <p:spPr/>
+        <p:txBody>
+          <a:bodyPr/>
+          <a:lstStyle/>
+          <a:p>
+            <a:r>
+              <a:rPr lang="en-US" dirty="0"/>
+              <a:t>Do not claim a fixed seven-part ordering. What actually goes into the prompt
+depends on the coder, the model and the settings, and it changes between
+releases. The list above is the shape, not the wire format.
+Ask what the model would need in order to add priority consistently to the CLI,
+the task and the store. That question sets up the next two slides.</a:t>
+            </a:r>
+            <a:endParaRPr lang="en-US" dirty="0"/>
+          </a:p>
+        </p:txBody>
+      </p:sp>
+      <p:sp>
+        <p:nvSpPr>
+          <p:cNvPr id="4" name="Slide Number Placeholder 3"/>
+          <p:cNvSpPr>
+            <a:spLocks noGrp="1"/>
+          </p:cNvSpPr>
+          <p:nvPr>
+            <p:ph type="sldNum" sz="quarter" idx="10"/>
+          </p:nvPr>
+        </p:nvSpPr>
+        <p:spPr/>
+        <p:txBody>
+          <a:bodyPr/>
+          <a:lstStyle/>
+          <a:p>
+            <a:fld id="{F7021451-1387-4CA6-816F-3879F97B5CBC}" type="slidenum">
+              <a:rPr lang="en-US"/>
+              <a:t>11</a:t>
+            </a:fld>
+            <a:endParaRPr lang="en-US"/>
+          </a:p>
+        </p:txBody>
+      </p:sp>
+    </p:spTree>
+    <p:extLst>
+      <p:ext uri="{BB962C8B-B14F-4D97-AF65-F5344CB8AC3E}">
+        <p14:creationId xmlns:p14="http://schemas.microsoft.com/office/powerpoint/2010/main" val="1024086991"/>
+      </p:ext>
+    </p:extLst>
+  </p:cSld>
+  <p:clrMapOvr>
+    <a:masterClrMapping/>
+  </p:clrMapOvr>
+</p:notes>
+</file>
+
+<file path=ppt/notesSlides/notesSlide12.xml><?xml version="1.0" encoding="utf-8"?>
+<p:notes xmlns:a="http://schemas.openxmlformats.org/drawingml/2006/main" xmlns:r="http://schemas.openxmlformats.org/officeDocument/2006/relationships" xmlns:p="http://schemas.openxmlformats.org/presentationml/2006/main">
+  <p:cSld>
+    <p:spTree>
+      <p:nvGrpSpPr>
+        <p:cNvPr id="1" name=""/>
+        <p:cNvGrpSpPr/>
+        <p:nvPr/>
+      </p:nvGrpSpPr>
+      <p:grpSpPr>
+        <a:xfrm>
+          <a:off x="0" y="0"/>
+          <a:ext cx="0" cy="0"/>
+          <a:chOff x="0" y="0"/>
+          <a:chExt cx="0" cy="0"/>
+        </a:xfrm>
+      </p:grpSpPr>
+      <p:sp>
+        <p:nvSpPr>
+          <p:cNvPr id="2" name="Slide Image Placeholder 1"/>
+          <p:cNvSpPr>
+            <a:spLocks noGrp="1" noRot="1" noChangeAspect="1"/>
+          </p:cNvSpPr>
+          <p:nvPr>
+            <p:ph type="sldImg"/>
+          </p:nvPr>
+        </p:nvSpPr>
+        <p:spPr/>
+      </p:sp>
+      <p:sp>
+        <p:nvSpPr>
+          <p:cNvPr id="3" name="Notes Placeholder 2"/>
+          <p:cNvSpPr>
+            <a:spLocks noGrp="1"/>
+          </p:cNvSpPr>
+          <p:nvPr>
+            <p:ph type="body" idx="1"/>
+          </p:nvPr>
+        </p:nvSpPr>
+        <p:spPr/>
+        <p:txBody>
+          <a:bodyPr/>
+          <a:lstStyle/>
+          <a:p>
+            <a:r>
+              <a:rPr lang="en-US" dirty="0"/>
+              <a:t>Walk through why these three files and not the whole package. This is one
+sensible selection, not a rule to add everything. Read-only context still
+costs budget. /tokens tells you what you are spending, and nothing about
+whether the edit will be correct.</a:t>
+            </a:r>
+            <a:endParaRPr lang="en-US" dirty="0"/>
+          </a:p>
+        </p:txBody>
+      </p:sp>
+      <p:sp>
+        <p:nvSpPr>
+          <p:cNvPr id="4" name="Slide Number Placeholder 3"/>
+          <p:cNvSpPr>
+            <a:spLocks noGrp="1"/>
+          </p:cNvSpPr>
+          <p:nvPr>
+            <p:ph type="sldNum" sz="quarter" idx="10"/>
+          </p:nvPr>
+        </p:nvSpPr>
+        <p:spPr/>
+        <p:txBody>
+          <a:bodyPr/>
+          <a:lstStyle/>
+          <a:p>
+            <a:fld id="{F7021451-1387-4CA6-816F-3879F97B5CBC}" type="slidenum">
+              <a:rPr lang="en-US"/>
+              <a:t>12</a:t>
+            </a:fld>
+            <a:endParaRPr lang="en-US"/>
+          </a:p>
+        </p:txBody>
+      </p:sp>
+    </p:spTree>
+    <p:extLst>
+      <p:ext uri="{BB962C8B-B14F-4D97-AF65-F5344CB8AC3E}">
+        <p14:creationId xmlns:p14="http://schemas.microsoft.com/office/powerpoint/2010/main" val="1024086991"/>
+      </p:ext>
+    </p:extLst>
+  </p:cSld>
+  <p:clrMapOvr>
+    <a:masterClrMapping/>
+  </p:clrMapOvr>
+</p:notes>
+</file>
+
+<file path=ppt/notesSlides/notesSlide13.xml><?xml version="1.0" encoding="utf-8"?>
+<p:notes xmlns:a="http://schemas.openxmlformats.org/drawingml/2006/main" xmlns:r="http://schemas.openxmlformats.org/officeDocument/2006/relationships" xmlns:p="http://schemas.openxmlformats.org/presentationml/2006/main">
+  <p:cSld>
+    <p:spTree>
+      <p:nvGrpSpPr>
+        <p:cNvPr id="1" name=""/>
+        <p:cNvGrpSpPr/>
+        <p:nvPr/>
+      </p:nvGrpSpPr>
+      <p:grpSpPr>
+        <a:xfrm>
+          <a:off x="0" y="0"/>
+          <a:ext cx="0" cy="0"/>
+          <a:chOff x="0" y="0"/>
+          <a:chExt cx="0" cy="0"/>
+        </a:xfrm>
+      </p:grpSpPr>
+      <p:sp>
+        <p:nvSpPr>
+          <p:cNvPr id="2" name="Slide Image Placeholder 1"/>
+          <p:cNvSpPr>
+            <a:spLocks noGrp="1" noRot="1" noChangeAspect="1"/>
+          </p:cNvSpPr>
+          <p:nvPr>
+            <p:ph type="sldImg"/>
+          </p:nvPr>
+        </p:nvSpPr>
+        <p:spPr/>
+      </p:sp>
+      <p:sp>
+        <p:nvSpPr>
+          <p:cNvPr id="3" name="Notes Placeholder 2"/>
+          <p:cNvSpPr>
+            <a:spLocks noGrp="1"/>
+          </p:cNvSpPr>
+          <p:nvPr>
+            <p:ph type="body" idx="1"/>
+          </p:nvPr>
+        </p:nvSpPr>
+        <p:spPr/>
+        <p:txBody>
+          <a:bodyPr/>
+          <a:lstStyle/>
+          <a:p>
+            <a:r>
+              <a:rPr lang="en-US" dirty="0"/>
+              <a:t>The excerpt is illustrative. Do not promise the map contains every file, and do
+not use its silence as proof that a dependency is absent. When a student says
+"the model should have known," check whether they added the file or only let the
+map mention it. Source: https://aider.chat/docs/repomap.html</a:t>
+            </a:r>
+            <a:endParaRPr lang="en-US" dirty="0"/>
+          </a:p>
+        </p:txBody>
+      </p:sp>
+      <p:sp>
+        <p:nvSpPr>
+          <p:cNvPr id="4" name="Slide Number Placeholder 3"/>
+          <p:cNvSpPr>
+            <a:spLocks noGrp="1"/>
+          </p:cNvSpPr>
+          <p:nvPr>
+            <p:ph type="sldNum" sz="quarter" idx="10"/>
+          </p:nvPr>
+        </p:nvSpPr>
+        <p:spPr/>
+        <p:txBody>
+          <a:bodyPr/>
+          <a:lstStyle/>
+          <a:p>
+            <a:fld id="{F7021451-1387-4CA6-816F-3879F97B5CBC}" type="slidenum">
+              <a:rPr lang="en-US"/>
+              <a:t>13</a:t>
+            </a:fld>
+            <a:endParaRPr lang="en-US"/>
+          </a:p>
+        </p:txBody>
+      </p:sp>
+    </p:spTree>
+    <p:extLst>
+      <p:ext uri="{BB962C8B-B14F-4D97-AF65-F5344CB8AC3E}">
+        <p14:creationId xmlns:p14="http://schemas.microsoft.com/office/powerpoint/2010/main" val="1024086991"/>
+      </p:ext>
+    </p:extLst>
+  </p:cSld>
+  <p:clrMapOvr>
+    <a:masterClrMapping/>
+  </p:clrMapOvr>
+</p:notes>
+</file>
+
+<file path=ppt/notesSlides/notesSlide14.xml><?xml version="1.0" encoding="utf-8"?>
+<p:notes xmlns:a="http://schemas.openxmlformats.org/drawingml/2006/main" xmlns:r="http://schemas.openxmlformats.org/officeDocument/2006/relationships" xmlns:p="http://schemas.openxmlformats.org/presentationml/2006/main">
+  <p:cSld>
+    <p:spTree>
+      <p:nvGrpSpPr>
+        <p:cNvPr id="1" name=""/>
+        <p:cNvGrpSpPr/>
+        <p:nvPr/>
+      </p:nvGrpSpPr>
+      <p:grpSpPr>
+        <a:xfrm>
+          <a:off x="0" y="0"/>
+          <a:ext cx="0" cy="0"/>
+          <a:chOff x="0" y="0"/>
+          <a:chExt cx="0" cy="0"/>
+        </a:xfrm>
+      </p:grpSpPr>
+      <p:sp>
+        <p:nvSpPr>
+          <p:cNvPr id="2" name="Slide Image Placeholder 1"/>
+          <p:cNvSpPr>
+            <a:spLocks noGrp="1" noRot="1" noChangeAspect="1"/>
+          </p:cNvSpPr>
+          <p:nvPr>
+            <p:ph type="sldImg"/>
+          </p:nvPr>
+        </p:nvSpPr>
+        <p:spPr/>
+      </p:sp>
+      <p:sp>
+        <p:nvSpPr>
+          <p:cNvPr id="3" name="Notes Placeholder 2"/>
+          <p:cNvSpPr>
+            <a:spLocks noGrp="1"/>
+          </p:cNvSpPr>
+          <p:nvPr>
+            <p:ph type="body" idx="1"/>
+          </p:nvPr>
+        </p:nvSpPr>
+        <p:spPr/>
+        <p:txBody>
+          <a:bodyPr/>
+          <a:lstStyle/>
+          <a:p>
+            <a:r>
+              <a:rPr lang="en-US" dirty="0"/>
+              <a:t>Ask what they would drop first and what has to survive. Their Stage 1 contract
+keeps the system instructions, the current request and the added file contents,
+and refuses an oversized required input instead of silently trimming it. That
+refusal is a design decision they have to write down and test.</a:t>
+            </a:r>
+            <a:endParaRPr lang="en-US" dirty="0"/>
+          </a:p>
+        </p:txBody>
+      </p:sp>
+      <p:sp>
+        <p:nvSpPr>
+          <p:cNvPr id="4" name="Slide Number Placeholder 3"/>
+          <p:cNvSpPr>
+            <a:spLocks noGrp="1"/>
+          </p:cNvSpPr>
+          <p:nvPr>
+            <p:ph type="sldNum" sz="quarter" idx="10"/>
+          </p:nvPr>
+        </p:nvSpPr>
+        <p:spPr/>
+        <p:txBody>
+          <a:bodyPr/>
+          <a:lstStyle/>
+          <a:p>
+            <a:fld id="{F7021451-1387-4CA6-816F-3879F97B5CBC}" type="slidenum">
+              <a:rPr lang="en-US"/>
+              <a:t>14</a:t>
+            </a:fld>
+            <a:endParaRPr lang="en-US"/>
+          </a:p>
+        </p:txBody>
+      </p:sp>
+    </p:spTree>
+    <p:extLst>
+      <p:ext uri="{BB962C8B-B14F-4D97-AF65-F5344CB8AC3E}">
+        <p14:creationId xmlns:p14="http://schemas.microsoft.com/office/powerpoint/2010/main" val="1024086991"/>
+      </p:ext>
+    </p:extLst>
+  </p:cSld>
+  <p:clrMapOvr>
+    <a:masterClrMapping/>
+  </p:clrMapOvr>
+</p:notes>
+</file>
+
+<file path=ppt/notesSlides/notesSlide15.xml><?xml version="1.0" encoding="utf-8"?>
+<p:notes xmlns:a="http://schemas.openxmlformats.org/drawingml/2006/main" xmlns:r="http://schemas.openxmlformats.org/officeDocument/2006/relationships" xmlns:p="http://schemas.openxmlformats.org/presentationml/2006/main">
+  <p:cSld>
+    <p:spTree>
+      <p:nvGrpSpPr>
+        <p:cNvPr id="1" name=""/>
+        <p:cNvGrpSpPr/>
+        <p:nvPr/>
+      </p:nvGrpSpPr>
+      <p:grpSpPr>
+        <a:xfrm>
+          <a:off x="0" y="0"/>
+          <a:ext cx="0" cy="0"/>
+          <a:chOff x="0" y="0"/>
+          <a:chExt cx="0" cy="0"/>
+        </a:xfrm>
+      </p:grpSpPr>
+      <p:sp>
+        <p:nvSpPr>
+          <p:cNvPr id="2" name="Slide Image Placeholder 1"/>
+          <p:cNvSpPr>
+            <a:spLocks noGrp="1" noRot="1" noChangeAspect="1"/>
+          </p:cNvSpPr>
+          <p:nvPr>
+            <p:ph type="sldImg"/>
+          </p:nvPr>
+        </p:nvSpPr>
+        <p:spPr/>
+      </p:sp>
+      <p:sp>
+        <p:nvSpPr>
+          <p:cNvPr id="3" name="Notes Placeholder 2"/>
+          <p:cNvSpPr>
+            <a:spLocks noGrp="1"/>
+          </p:cNvSpPr>
+          <p:nvPr>
+            <p:ph type="body" idx="1"/>
+          </p:nvPr>
+        </p:nvSpPr>
+        <p:spPr/>
+        <p:txBody>
+          <a:bodyPr/>
+          <a:lstStyle/>
+          <a:p>
+            <a:r>
+              <a:rPr lang="en-US" dirty="0"/>
               <a:t>Deliberately small and deliberately incomplete. Ask what is missing before you
 say it: task.py never gains the field, store.py never writes it. A student who
 reads only this block sees a finished feature.
@@ -662,7 +1116,7 @@
           <a:p>
             <a:fld id="{F7021451-1387-4CA6-816F-3879F97B5CBC}" type="slidenum">
               <a:rPr lang="en-US"/>
-              <a:t>10</a:t>
+              <a:t>15</a:t>
             </a:fld>
             <a:endParaRPr lang="en-US"/>
           </a:p>
@@ -681,7 +1135,7 @@
 </p:notes>
 </file>
 
-<file path=ppt/notesSlides/notesSlide11.xml><?xml version="1.0" encoding="utf-8"?>
+<file path=ppt/notesSlides/notesSlide16.xml><?xml version="1.0" encoding="utf-8"?>
 <p:notes xmlns:a="http://schemas.openxmlformats.org/drawingml/2006/main" xmlns:r="http://schemas.openxmlformats.org/officeDocument/2006/relationships" xmlns:p="http://schemas.openxmlformats.org/presentationml/2006/main">
   <p:cSld>
     <p:spTree>
@@ -752,7 +1206,7 @@
           <a:p>
             <a:fld id="{F7021451-1387-4CA6-816F-3879F97B5CBC}" type="slidenum">
               <a:rPr lang="en-US"/>
-              <a:t>11</a:t>
+              <a:t>16</a:t>
             </a:fld>
             <a:endParaRPr lang="en-US"/>
           </a:p>
@@ -771,7 +1225,7 @@
 </p:notes>
 </file>
 
-<file path=ppt/notesSlides/notesSlide12.xml><?xml version="1.0" encoding="utf-8"?>
+<file path=ppt/notesSlides/notesSlide17.xml><?xml version="1.0" encoding="utf-8"?>
 <p:notes xmlns:a="http://schemas.openxmlformats.org/drawingml/2006/main" xmlns:r="http://schemas.openxmlformats.org/officeDocument/2006/relationships" xmlns:p="http://schemas.openxmlformats.org/presentationml/2006/main">
   <p:cSld>
     <p:spTree>
@@ -844,7 +1298,7 @@
           <a:p>
             <a:fld id="{F7021451-1387-4CA6-816F-3879F97B5CBC}" type="slidenum">
               <a:rPr lang="en-US"/>
-              <a:t>12</a:t>
+              <a:t>17</a:t>
             </a:fld>
             <a:endParaRPr lang="en-US"/>
           </a:p>
@@ -863,7 +1317,7 @@
 </p:notes>
 </file>
 
-<file path=ppt/notesSlides/notesSlide13.xml><?xml version="1.0" encoding="utf-8"?>
+<file path=ppt/notesSlides/notesSlide18.xml><?xml version="1.0" encoding="utf-8"?>
 <p:notes xmlns:a="http://schemas.openxmlformats.org/drawingml/2006/main" xmlns:r="http://schemas.openxmlformats.org/officeDocument/2006/relationships" xmlns:p="http://schemas.openxmlformats.org/presentationml/2006/main">
   <p:cSld>
     <p:spTree>
@@ -936,7 +1390,7 @@
           <a:p>
             <a:fld id="{F7021451-1387-4CA6-816F-3879F97B5CBC}" type="slidenum">
               <a:rPr lang="en-US"/>
-              <a:t>13</a:t>
+              <a:t>18</a:t>
             </a:fld>
             <a:endParaRPr lang="en-US"/>
           </a:p>
@@ -955,7 +1409,7 @@
 </p:notes>
 </file>
 
-<file path=ppt/notesSlides/notesSlide14.xml><?xml version="1.0" encoding="utf-8"?>
+<file path=ppt/notesSlides/notesSlide19.xml><?xml version="1.0" encoding="utf-8"?>
 <p:notes xmlns:a="http://schemas.openxmlformats.org/drawingml/2006/main" xmlns:r="http://schemas.openxmlformats.org/officeDocument/2006/relationships" xmlns:p="http://schemas.openxmlformats.org/presentationml/2006/main">
   <p:cSld>
     <p:spTree>
@@ -1029,7 +1483,7 @@
           <a:p>
             <a:fld id="{F7021451-1387-4CA6-816F-3879F97B5CBC}" type="slidenum">
               <a:rPr lang="en-US"/>
-              <a:t>14</a:t>
+              <a:t>19</a:t>
             </a:fld>
             <a:endParaRPr lang="en-US"/>
           </a:p>
@@ -1048,7 +1502,102 @@
 </p:notes>
 </file>
 
-<file path=ppt/notesSlides/notesSlide15.xml><?xml version="1.0" encoding="utf-8"?>
+<file path=ppt/notesSlides/notesSlide2.xml><?xml version="1.0" encoding="utf-8"?>
+<p:notes xmlns:a="http://schemas.openxmlformats.org/drawingml/2006/main" xmlns:r="http://schemas.openxmlformats.org/officeDocument/2006/relationships" xmlns:p="http://schemas.openxmlformats.org/presentationml/2006/main">
+  <p:cSld>
+    <p:spTree>
+      <p:nvGrpSpPr>
+        <p:cNvPr id="1" name=""/>
+        <p:cNvGrpSpPr/>
+        <p:nvPr/>
+      </p:nvGrpSpPr>
+      <p:grpSpPr>
+        <a:xfrm>
+          <a:off x="0" y="0"/>
+          <a:ext cx="0" cy="0"/>
+          <a:chOff x="0" y="0"/>
+          <a:chExt cx="0" cy="0"/>
+        </a:xfrm>
+      </p:grpSpPr>
+      <p:sp>
+        <p:nvSpPr>
+          <p:cNvPr id="2" name="Slide Image Placeholder 1"/>
+          <p:cNvSpPr>
+            <a:spLocks noGrp="1" noRot="1" noChangeAspect="1"/>
+          </p:cNvSpPr>
+          <p:nvPr>
+            <p:ph type="sldImg"/>
+          </p:nvPr>
+        </p:nvSpPr>
+        <p:spPr/>
+      </p:sp>
+      <p:sp>
+        <p:nvSpPr>
+          <p:cNvPr id="3" name="Notes Placeholder 2"/>
+          <p:cNvSpPr>
+            <a:spLocks noGrp="1"/>
+          </p:cNvSpPr>
+          <p:nvPr>
+            <p:ph type="body" idx="1"/>
+          </p:nvPr>
+        </p:nvSpPr>
+        <p:spPr/>
+        <p:txBody>
+          <a:bodyPr/>
+          <a:lstStyle/>
+          <a:p>
+            <a:r>
+              <a:rPr lang="en-US" dirty="0"/>
+              <a:t>Put this up while the room settles and leave it up. The agenda is part of the
+first block, not an extra segment in front of it.
+Say out loud that the second half is genuinely office hours: they work, you
+circulate, and nobody hands anything in today. Students who have been told all
+term that labs end in a checkoff will not believe it unless you say it. The
+slide no longer says so, so this is on you to say.
+Do not preview the build past the word itself. The reveal is still yours to
+make in the third section.</a:t>
+            </a:r>
+            <a:endParaRPr lang="en-US" dirty="0"/>
+          </a:p>
+        </p:txBody>
+      </p:sp>
+      <p:sp>
+        <p:nvSpPr>
+          <p:cNvPr id="4" name="Slide Number Placeholder 3"/>
+          <p:cNvSpPr>
+            <a:spLocks noGrp="1"/>
+          </p:cNvSpPr>
+          <p:nvPr>
+            <p:ph type="sldNum" sz="quarter" idx="10"/>
+          </p:nvPr>
+        </p:nvSpPr>
+        <p:spPr/>
+        <p:txBody>
+          <a:bodyPr/>
+          <a:lstStyle/>
+          <a:p>
+            <a:fld id="{F7021451-1387-4CA6-816F-3879F97B5CBC}" type="slidenum">
+              <a:rPr lang="en-US"/>
+              <a:t>2</a:t>
+            </a:fld>
+            <a:endParaRPr lang="en-US"/>
+          </a:p>
+        </p:txBody>
+      </p:sp>
+    </p:spTree>
+    <p:extLst>
+      <p:ext uri="{BB962C8B-B14F-4D97-AF65-F5344CB8AC3E}">
+        <p14:creationId xmlns:p14="http://schemas.microsoft.com/office/powerpoint/2010/main" val="1024086991"/>
+      </p:ext>
+    </p:extLst>
+  </p:cSld>
+  <p:clrMapOvr>
+    <a:masterClrMapping/>
+  </p:clrMapOvr>
+</p:notes>
+</file>
+
+<file path=ppt/notesSlides/notesSlide20.xml><?xml version="1.0" encoding="utf-8"?>
 <p:notes xmlns:a="http://schemas.openxmlformats.org/drawingml/2006/main" xmlns:r="http://schemas.openxmlformats.org/officeDocument/2006/relationships" xmlns:p="http://schemas.openxmlformats.org/presentationml/2006/main">
   <p:cSld>
     <p:spTree>
@@ -1119,7 +1668,7 @@
           <a:p>
             <a:fld id="{F7021451-1387-4CA6-816F-3879F97B5CBC}" type="slidenum">
               <a:rPr lang="en-US"/>
-              <a:t>15</a:t>
+              <a:t>20</a:t>
             </a:fld>
             <a:endParaRPr lang="en-US"/>
           </a:p>
@@ -1138,7 +1687,7 @@
 </p:notes>
 </file>
 
-<file path=ppt/notesSlides/notesSlide16.xml><?xml version="1.0" encoding="utf-8"?>
+<file path=ppt/notesSlides/notesSlide21.xml><?xml version="1.0" encoding="utf-8"?>
 <p:notes xmlns:a="http://schemas.openxmlformats.org/drawingml/2006/main" xmlns:r="http://schemas.openxmlformats.org/officeDocument/2006/relationships" xmlns:p="http://schemas.openxmlformats.org/presentationml/2006/main">
   <p:cSld>
     <p:spTree>
@@ -1208,7 +1757,7 @@
           <a:p>
             <a:fld id="{F7021451-1387-4CA6-816F-3879F97B5CBC}" type="slidenum">
               <a:rPr lang="en-US"/>
-              <a:t>16</a:t>
+              <a:t>21</a:t>
             </a:fld>
             <a:endParaRPr lang="en-US"/>
           </a:p>
@@ -1227,7 +1776,7 @@
 </p:notes>
 </file>
 
-<file path=ppt/notesSlides/notesSlide17.xml><?xml version="1.0" encoding="utf-8"?>
+<file path=ppt/notesSlides/notesSlide22.xml><?xml version="1.0" encoding="utf-8"?>
 <p:notes xmlns:a="http://schemas.openxmlformats.org/drawingml/2006/main" xmlns:r="http://schemas.openxmlformats.org/officeDocument/2006/relationships" xmlns:p="http://schemas.openxmlformats.org/presentationml/2006/main">
   <p:cSld>
     <p:spTree>
@@ -1298,7 +1847,7 @@
           <a:p>
             <a:fld id="{F7021451-1387-4CA6-816F-3879F97B5CBC}" type="slidenum">
               <a:rPr lang="en-US"/>
-              <a:t>17</a:t>
+              <a:t>22</a:t>
             </a:fld>
             <a:endParaRPr lang="en-US"/>
           </a:p>
@@ -1317,7 +1866,7 @@
 </p:notes>
 </file>
 
-<file path=ppt/notesSlides/notesSlide18.xml><?xml version="1.0" encoding="utf-8"?>
+<file path=ppt/notesSlides/notesSlide23.xml><?xml version="1.0" encoding="utf-8"?>
 <p:notes xmlns:a="http://schemas.openxmlformats.org/drawingml/2006/main" xmlns:r="http://schemas.openxmlformats.org/officeDocument/2006/relationships" xmlns:p="http://schemas.openxmlformats.org/presentationml/2006/main">
   <p:cSld>
     <p:spTree>
@@ -1388,7 +1937,7 @@
           <a:p>
             <a:fld id="{F7021451-1387-4CA6-816F-3879F97B5CBC}" type="slidenum">
               <a:rPr lang="en-US"/>
-              <a:t>18</a:t>
+              <a:t>23</a:t>
             </a:fld>
             <a:endParaRPr lang="en-US"/>
           </a:p>
@@ -1407,7 +1956,7 @@
 </p:notes>
 </file>
 
-<file path=ppt/notesSlides/notesSlide19.xml><?xml version="1.0" encoding="utf-8"?>
+<file path=ppt/notesSlides/notesSlide24.xml><?xml version="1.0" encoding="utf-8"?>
 <p:notes xmlns:a="http://schemas.openxmlformats.org/drawingml/2006/main" xmlns:r="http://schemas.openxmlformats.org/officeDocument/2006/relationships" xmlns:p="http://schemas.openxmlformats.org/presentationml/2006/main">
   <p:cSld>
     <p:spTree>
@@ -1479,7 +2028,7 @@
           <a:p>
             <a:fld id="{F7021451-1387-4CA6-816F-3879F97B5CBC}" type="slidenum">
               <a:rPr lang="en-US"/>
-              <a:t>19</a:t>
+              <a:t>24</a:t>
             </a:fld>
             <a:endParaRPr lang="en-US"/>
           </a:p>
@@ -1498,7 +2047,7 @@
 </p:notes>
 </file>
 
-<file path=ppt/notesSlides/notesSlide2.xml><?xml version="1.0" encoding="utf-8"?>
+<file path=ppt/notesSlides/notesSlide25.xml><?xml version="1.0" encoding="utf-8"?>
 <p:notes xmlns:a="http://schemas.openxmlformats.org/drawingml/2006/main" xmlns:r="http://schemas.openxmlformats.org/officeDocument/2006/relationships" xmlns:p="http://schemas.openxmlformats.org/presentationml/2006/main">
   <p:cSld>
     <p:spTree>
@@ -1544,13 +2093,12 @@
           <a:p>
             <a:r>
               <a:rPr lang="en-US" dirty="0"/>
-              <a:t>Put this up while the room settles and leave it up. The agenda is part of the
-first block, not an extra segment in front of it.
-Say out loud that the second half is genuinely office hours: they work, you
-circulate, and nobody hands anything in today. Students who have been told all
-term that labs end in a checkoff will not believe it unless you say it.
-Do not preview the build past the word itself. The reveal is still yours to
-make in the third section.</a:t>
+              <a:t>Three minutes including logistics. Room, time and the model in the workspace are
+announced by staff. Do not invent any of them here.
+Say the accommodations line out loud: conflicts and accommodations go to staff
+now, not the week of.
+The caption is the only place in the deck a student sees the build deadline, now
+that the after-lab slide is gone. Do not skip past it.</a:t>
             </a:r>
             <a:endParaRPr lang="en-US" dirty="0"/>
           </a:p>
@@ -1573,7 +2121,7 @@
           <a:p>
             <a:fld id="{F7021451-1387-4CA6-816F-3879F97B5CBC}" type="slidenum">
               <a:rPr lang="en-US"/>
-              <a:t>2</a:t>
+              <a:t>25</a:t>
             </a:fld>
             <a:endParaRPr lang="en-US"/>
           </a:p>
@@ -1592,98 +2140,7 @@
 </p:notes>
 </file>
 
-<file path=ppt/notesSlides/notesSlide20.xml><?xml version="1.0" encoding="utf-8"?>
-<p:notes xmlns:a="http://schemas.openxmlformats.org/drawingml/2006/main" xmlns:r="http://schemas.openxmlformats.org/officeDocument/2006/relationships" xmlns:p="http://schemas.openxmlformats.org/presentationml/2006/main">
-  <p:cSld>
-    <p:spTree>
-      <p:nvGrpSpPr>
-        <p:cNvPr id="1" name=""/>
-        <p:cNvGrpSpPr/>
-        <p:nvPr/>
-      </p:nvGrpSpPr>
-      <p:grpSpPr>
-        <a:xfrm>
-          <a:off x="0" y="0"/>
-          <a:ext cx="0" cy="0"/>
-          <a:chOff x="0" y="0"/>
-          <a:chExt cx="0" cy="0"/>
-        </a:xfrm>
-      </p:grpSpPr>
-      <p:sp>
-        <p:nvSpPr>
-          <p:cNvPr id="2" name="Slide Image Placeholder 1"/>
-          <p:cNvSpPr>
-            <a:spLocks noGrp="1" noRot="1" noChangeAspect="1"/>
-          </p:cNvSpPr>
-          <p:nvPr>
-            <p:ph type="sldImg"/>
-          </p:nvPr>
-        </p:nvSpPr>
-        <p:spPr/>
-      </p:sp>
-      <p:sp>
-        <p:nvSpPr>
-          <p:cNvPr id="3" name="Notes Placeholder 2"/>
-          <p:cNvSpPr>
-            <a:spLocks noGrp="1"/>
-          </p:cNvSpPr>
-          <p:nvPr>
-            <p:ph type="body" idx="1"/>
-          </p:nvPr>
-        </p:nvSpPr>
-        <p:spPr/>
-        <p:txBody>
-          <a:bodyPr/>
-          <a:lstStyle/>
-          <a:p>
-            <a:r>
-              <a:rPr lang="en-US" dirty="0"/>
-              <a:t>Three minutes including logistics. Room, time and the model in the workspace are
-announced by staff. Do not invent any of them here.
-Say the accommodations line out loud: conflicts and accommodations go to staff
-now, not the week of. Build is due the next day, September 25.</a:t>
-            </a:r>
-            <a:endParaRPr lang="en-US" dirty="0"/>
-          </a:p>
-        </p:txBody>
-      </p:sp>
-      <p:sp>
-        <p:nvSpPr>
-          <p:cNvPr id="4" name="Slide Number Placeholder 3"/>
-          <p:cNvSpPr>
-            <a:spLocks noGrp="1"/>
-          </p:cNvSpPr>
-          <p:nvPr>
-            <p:ph type="sldNum" sz="quarter" idx="10"/>
-          </p:nvPr>
-        </p:nvSpPr>
-        <p:spPr/>
-        <p:txBody>
-          <a:bodyPr/>
-          <a:lstStyle/>
-          <a:p>
-            <a:fld id="{F7021451-1387-4CA6-816F-3879F97B5CBC}" type="slidenum">
-              <a:rPr lang="en-US"/>
-              <a:t>20</a:t>
-            </a:fld>
-            <a:endParaRPr lang="en-US"/>
-          </a:p>
-        </p:txBody>
-      </p:sp>
-    </p:spTree>
-    <p:extLst>
-      <p:ext uri="{BB962C8B-B14F-4D97-AF65-F5344CB8AC3E}">
-        <p14:creationId xmlns:p14="http://schemas.microsoft.com/office/powerpoint/2010/main" val="1024086991"/>
-      </p:ext>
-    </p:extLst>
-  </p:cSld>
-  <p:clrMapOvr>
-    <a:masterClrMapping/>
-  </p:clrMapOvr>
-</p:notes>
-</file>
-
-<file path=ppt/notesSlides/notesSlide21.xml><?xml version="1.0" encoding="utf-8"?>
+<file path=ppt/notesSlides/notesSlide26.xml><?xml version="1.0" encoding="utf-8"?>
 <p:notes xmlns:a="http://schemas.openxmlformats.org/drawingml/2006/main" xmlns:r="http://schemas.openxmlformats.org/officeDocument/2006/relationships" xmlns:p="http://schemas.openxmlformats.org/presentationml/2006/main">
   <p:cSld>
     <p:spTree>
@@ -1753,7 +2210,7 @@
           <a:p>
             <a:fld id="{F7021451-1387-4CA6-816F-3879F97B5CBC}" type="slidenum">
               <a:rPr lang="en-US"/>
-              <a:t>21</a:t>
+              <a:t>26</a:t>
             </a:fld>
             <a:endParaRPr lang="en-US"/>
           </a:p>
@@ -1772,7 +2229,7 @@
 </p:notes>
 </file>
 
-<file path=ppt/notesSlides/notesSlide22.xml><?xml version="1.0" encoding="utf-8"?>
+<file path=ppt/notesSlides/notesSlide27.xml><?xml version="1.0" encoding="utf-8"?>
 <p:notes xmlns:a="http://schemas.openxmlformats.org/drawingml/2006/main" xmlns:r="http://schemas.openxmlformats.org/officeDocument/2006/relationships" xmlns:p="http://schemas.openxmlformats.org/presentationml/2006/main">
   <p:cSld>
     <p:spTree>
@@ -1845,7 +2302,7 @@
           <a:p>
             <a:fld id="{F7021451-1387-4CA6-816F-3879F97B5CBC}" type="slidenum">
               <a:rPr lang="en-US"/>
-              <a:t>22</a:t>
+              <a:t>27</a:t>
             </a:fld>
             <a:endParaRPr lang="en-US"/>
           </a:p>
@@ -1864,7 +2321,7 @@
 </p:notes>
 </file>
 
-<file path=ppt/notesSlides/notesSlide23.xml><?xml version="1.0" encoding="utf-8"?>
+<file path=ppt/notesSlides/notesSlide28.xml><?xml version="1.0" encoding="utf-8"?>
 <p:notes xmlns:a="http://schemas.openxmlformats.org/drawingml/2006/main" xmlns:r="http://schemas.openxmlformats.org/officeDocument/2006/relationships" xmlns:p="http://schemas.openxmlformats.org/presentationml/2006/main">
   <p:cSld>
     <p:spTree>
@@ -1938,7 +2395,7 @@
           <a:p>
             <a:fld id="{F7021451-1387-4CA6-816F-3879F97B5CBC}" type="slidenum">
               <a:rPr lang="en-US"/>
-              <a:t>23</a:t>
+              <a:t>28</a:t>
             </a:fld>
             <a:endParaRPr lang="en-US"/>
           </a:p>
@@ -1957,7 +2414,7 @@
 </p:notes>
 </file>
 
-<file path=ppt/notesSlides/notesSlide24.xml><?xml version="1.0" encoding="utf-8"?>
+<file path=ppt/notesSlides/notesSlide29.xml><?xml version="1.0" encoding="utf-8"?>
 <p:notes xmlns:a="http://schemas.openxmlformats.org/drawingml/2006/main" xmlns:r="http://schemas.openxmlformats.org/officeDocument/2006/relationships" xmlns:p="http://schemas.openxmlformats.org/presentationml/2006/main">
   <p:cSld>
     <p:spTree>
@@ -2030,7 +2487,7 @@
           <a:p>
             <a:fld id="{F7021451-1387-4CA6-816F-3879F97B5CBC}" type="slidenum">
               <a:rPr lang="en-US"/>
-              <a:t>24</a:t>
+              <a:t>29</a:t>
             </a:fld>
             <a:endParaRPr lang="en-US"/>
           </a:p>
@@ -2049,7 +2506,99 @@
 </p:notes>
 </file>
 
-<file path=ppt/notesSlides/notesSlide25.xml><?xml version="1.0" encoding="utf-8"?>
+<file path=ppt/notesSlides/notesSlide3.xml><?xml version="1.0" encoding="utf-8"?>
+<p:notes xmlns:a="http://schemas.openxmlformats.org/drawingml/2006/main" xmlns:r="http://schemas.openxmlformats.org/officeDocument/2006/relationships" xmlns:p="http://schemas.openxmlformats.org/presentationml/2006/main">
+  <p:cSld>
+    <p:spTree>
+      <p:nvGrpSpPr>
+        <p:cNvPr id="1" name=""/>
+        <p:cNvGrpSpPr/>
+        <p:nvPr/>
+      </p:nvGrpSpPr>
+      <p:grpSpPr>
+        <a:xfrm>
+          <a:off x="0" y="0"/>
+          <a:ext cx="0" cy="0"/>
+          <a:chOff x="0" y="0"/>
+          <a:chExt cx="0" cy="0"/>
+        </a:xfrm>
+      </p:grpSpPr>
+      <p:sp>
+        <p:nvSpPr>
+          <p:cNvPr id="2" name="Slide Image Placeholder 1"/>
+          <p:cNvSpPr>
+            <a:spLocks noGrp="1" noRot="1" noChangeAspect="1"/>
+          </p:cNvSpPr>
+          <p:nvPr>
+            <p:ph type="sldImg"/>
+          </p:nvPr>
+        </p:nvSpPr>
+        <p:spPr/>
+      </p:sp>
+      <p:sp>
+        <p:nvSpPr>
+          <p:cNvPr id="3" name="Notes Placeholder 2"/>
+          <p:cNvSpPr>
+            <a:spLocks noGrp="1"/>
+          </p:cNvSpPr>
+          <p:nvPr>
+            <p:ph type="body" idx="1"/>
+          </p:nvPr>
+        </p:nvSpPr>
+        <p:spPr/>
+        <p:txBody>
+          <a:bodyPr/>
+          <a:lstStyle/>
+          <a:p>
+            <a:r>
+              <a:rPr lang="en-US" dirty="0"/>
+              <a:t>Two weeks of practice lessons have given them the muscle memory and none of the
+model. This is the slide that names the thing.
+The three cards are the six steps in summary, so do not elaborate here. The
+point to land is the last one: it is a program on their machine, which is why
+they can read its behavior, and why they are about to write one.</a:t>
+            </a:r>
+            <a:endParaRPr lang="en-US" dirty="0"/>
+          </a:p>
+        </p:txBody>
+      </p:sp>
+      <p:sp>
+        <p:nvSpPr>
+          <p:cNvPr id="4" name="Slide Number Placeholder 3"/>
+          <p:cNvSpPr>
+            <a:spLocks noGrp="1"/>
+          </p:cNvSpPr>
+          <p:nvPr>
+            <p:ph type="sldNum" sz="quarter" idx="10"/>
+          </p:nvPr>
+        </p:nvSpPr>
+        <p:spPr/>
+        <p:txBody>
+          <a:bodyPr/>
+          <a:lstStyle/>
+          <a:p>
+            <a:fld id="{F7021451-1387-4CA6-816F-3879F97B5CBC}" type="slidenum">
+              <a:rPr lang="en-US"/>
+              <a:t>3</a:t>
+            </a:fld>
+            <a:endParaRPr lang="en-US"/>
+          </a:p>
+        </p:txBody>
+      </p:sp>
+    </p:spTree>
+    <p:extLst>
+      <p:ext uri="{BB962C8B-B14F-4D97-AF65-F5344CB8AC3E}">
+        <p14:creationId xmlns:p14="http://schemas.microsoft.com/office/powerpoint/2010/main" val="1024086991"/>
+      </p:ext>
+    </p:extLst>
+  </p:cSld>
+  <p:clrMapOvr>
+    <a:masterClrMapping/>
+  </p:clrMapOvr>
+</p:notes>
+</file>
+
+<file path=ppt/notesSlides/notesSlide30.xml><?xml version="1.0" encoding="utf-8"?>
 <p:notes xmlns:a="http://schemas.openxmlformats.org/drawingml/2006/main" xmlns:r="http://schemas.openxmlformats.org/officeDocument/2006/relationships" xmlns:p="http://schemas.openxmlformats.org/presentationml/2006/main">
   <p:cSld>
     <p:spTree>
@@ -2119,7 +2668,7 @@
           <a:p>
             <a:fld id="{F7021451-1387-4CA6-816F-3879F97B5CBC}" type="slidenum">
               <a:rPr lang="en-US"/>
-              <a:t>25</a:t>
+              <a:t>30</a:t>
             </a:fld>
             <a:endParaRPr lang="en-US"/>
           </a:p>
@@ -2138,7 +2687,7 @@
 </p:notes>
 </file>
 
-<file path=ppt/notesSlides/notesSlide26.xml><?xml version="1.0" encoding="utf-8"?>
+<file path=ppt/notesSlides/notesSlide31.xml><?xml version="1.0" encoding="utf-8"?>
 <p:notes xmlns:a="http://schemas.openxmlformats.org/drawingml/2006/main" xmlns:r="http://schemas.openxmlformats.org/officeDocument/2006/relationships" xmlns:p="http://schemas.openxmlformats.org/presentationml/2006/main">
   <p:cSld>
     <p:spTree>
@@ -2185,7 +2734,11 @@
             <a:r>
               <a:rPr lang="en-US" dirty="0"/>
               <a:t>base_url can carry any path prefix. Their client appends /chat/completions and
-nothing else. Aider's own YAML config is a separate file and unrelated.
+nothing else.
+Say explicitly that this is not the .aider.conf.yml from the first ten minutes.
+Two YAML files, two owners: that one configures the tool they use, this one is
+a schema their own program has to implement. The deck now teaches both, so the
+collision is live.
 No Ollama-specific dependency belongs anywhere in the application. Provider
 independence is a requirement, not a preference.</a:t>
             </a:r>
@@ -2210,7 +2763,7 @@
           <a:p>
             <a:fld id="{F7021451-1387-4CA6-816F-3879F97B5CBC}" type="slidenum">
               <a:rPr lang="en-US"/>
-              <a:t>26</a:t>
+              <a:t>31</a:t>
             </a:fld>
             <a:endParaRPr lang="en-US"/>
           </a:p>
@@ -2229,7 +2782,7 @@
 </p:notes>
 </file>
 
-<file path=ppt/notesSlides/notesSlide27.xml><?xml version="1.0" encoding="utf-8"?>
+<file path=ppt/notesSlides/notesSlide32.xml><?xml version="1.0" encoding="utf-8"?>
 <p:notes xmlns:a="http://schemas.openxmlformats.org/drawingml/2006/main" xmlns:r="http://schemas.openxmlformats.org/officeDocument/2006/relationships" xmlns:p="http://schemas.openxmlformats.org/presentationml/2006/main">
   <p:cSld>
     <p:spTree>
@@ -2300,7 +2853,7 @@
           <a:p>
             <a:fld id="{F7021451-1387-4CA6-816F-3879F97B5CBC}" type="slidenum">
               <a:rPr lang="en-US"/>
-              <a:t>27</a:t>
+              <a:t>32</a:t>
             </a:fld>
             <a:endParaRPr lang="en-US"/>
           </a:p>
@@ -2319,7 +2872,7 @@
 </p:notes>
 </file>
 
-<file path=ppt/notesSlides/notesSlide28.xml><?xml version="1.0" encoding="utf-8"?>
+<file path=ppt/notesSlides/notesSlide33.xml><?xml version="1.0" encoding="utf-8"?>
 <p:notes xmlns:a="http://schemas.openxmlformats.org/drawingml/2006/main" xmlns:r="http://schemas.openxmlformats.org/officeDocument/2006/relationships" xmlns:p="http://schemas.openxmlformats.org/presentationml/2006/main">
   <p:cSld>
     <p:spTree>
@@ -2391,7 +2944,7 @@
           <a:p>
             <a:fld id="{F7021451-1387-4CA6-816F-3879F97B5CBC}" type="slidenum">
               <a:rPr lang="en-US"/>
-              <a:t>28</a:t>
+              <a:t>33</a:t>
             </a:fld>
             <a:endParaRPr lang="en-US"/>
           </a:p>
@@ -2410,7 +2963,7 @@
 </p:notes>
 </file>
 
-<file path=ppt/notesSlides/notesSlide29.xml><?xml version="1.0" encoding="utf-8"?>
+<file path=ppt/notesSlides/notesSlide34.xml><?xml version="1.0" encoding="utf-8"?>
 <p:notes xmlns:a="http://schemas.openxmlformats.org/drawingml/2006/main" xmlns:r="http://schemas.openxmlformats.org/officeDocument/2006/relationships" xmlns:p="http://schemas.openxmlformats.org/presentationml/2006/main">
   <p:cSld>
     <p:spTree>
@@ -2481,7 +3034,7 @@
           <a:p>
             <a:fld id="{F7021451-1387-4CA6-816F-3879F97B5CBC}" type="slidenum">
               <a:rPr lang="en-US"/>
-              <a:t>29</a:t>
+              <a:t>34</a:t>
             </a:fld>
             <a:endParaRPr lang="en-US"/>
           </a:p>
@@ -2500,7 +3053,7 @@
 </p:notes>
 </file>
 
-<file path=ppt/notesSlides/notesSlide3.xml><?xml version="1.0" encoding="utf-8"?>
+<file path=ppt/notesSlides/notesSlide35.xml><?xml version="1.0" encoding="utf-8"?>
 <p:notes xmlns:a="http://schemas.openxmlformats.org/drawingml/2006/main" xmlns:r="http://schemas.openxmlformats.org/officeDocument/2006/relationships" xmlns:p="http://schemas.openxmlformats.org/presentationml/2006/main">
   <p:cSld>
     <p:spTree>
@@ -2546,10 +3099,21 @@
           <a:p>
             <a:r>
               <a:rPr lang="en-US" dirty="0"/>
-              <a:t>They met this request in the practice lessons, in whole-file mode. Today's
-trace is diff mode and it is illustrative: a simplified turn, not a captured
-transcript of a particular model. The three files matter later, when the
-feature half-works.</a:t>
+              <a:t>These are points inside the build grade, not percentages of the course grade.
+The build is 4.5% of the course and is due September 25.
+Do not read the table out. Send them to RUBRIC.md, which carries the
+per-criterion breakdown this slide summarizes, and spend the time on the four
+things worth saying out loud instead:
+- Completeness and usefulness are graded. Document length is not.
+- A correct failing test can earn test credit while exposing an unfinished
+  feature. Only one point in the whole rubric depends on the live model
+  actually succeeding, and honest evidence of a failed run still earns the
+  reporting points.
+- Design keeps its credit when the implementation falls short, as long as the
+  design's claims and the final status are honest. No repeated deductions for
+  one missing feature across otherwise sound artifacts.
+- Evidence means a pointer someone can follow. Volume of logs is not evidence.
+Policy violations go through academic integrity procedures, not the rubric.</a:t>
             </a:r>
             <a:endParaRPr lang="en-US" dirty="0"/>
           </a:p>
@@ -2572,7 +3136,7 @@
           <a:p>
             <a:fld id="{F7021451-1387-4CA6-816F-3879F97B5CBC}" type="slidenum">
               <a:rPr lang="en-US"/>
-              <a:t>3</a:t>
+              <a:t>35</a:t>
             </a:fld>
             <a:endParaRPr lang="en-US"/>
           </a:p>
@@ -2591,279 +3155,7 @@
 </p:notes>
 </file>
 
-<file path=ppt/notesSlides/notesSlide30.xml><?xml version="1.0" encoding="utf-8"?>
-<p:notes xmlns:a="http://schemas.openxmlformats.org/drawingml/2006/main" xmlns:r="http://schemas.openxmlformats.org/officeDocument/2006/relationships" xmlns:p="http://schemas.openxmlformats.org/presentationml/2006/main">
-  <p:cSld>
-    <p:spTree>
-      <p:nvGrpSpPr>
-        <p:cNvPr id="1" name=""/>
-        <p:cNvGrpSpPr/>
-        <p:nvPr/>
-      </p:nvGrpSpPr>
-      <p:grpSpPr>
-        <a:xfrm>
-          <a:off x="0" y="0"/>
-          <a:ext cx="0" cy="0"/>
-          <a:chOff x="0" y="0"/>
-          <a:chExt cx="0" cy="0"/>
-        </a:xfrm>
-      </p:grpSpPr>
-      <p:sp>
-        <p:nvSpPr>
-          <p:cNvPr id="2" name="Slide Image Placeholder 1"/>
-          <p:cNvSpPr>
-            <a:spLocks noGrp="1" noRot="1" noChangeAspect="1"/>
-          </p:cNvSpPr>
-          <p:nvPr>
-            <p:ph type="sldImg"/>
-          </p:nvPr>
-        </p:nvSpPr>
-        <p:spPr/>
-      </p:sp>
-      <p:sp>
-        <p:nvSpPr>
-          <p:cNvPr id="3" name="Notes Placeholder 2"/>
-          <p:cNvSpPr>
-            <a:spLocks noGrp="1"/>
-          </p:cNvSpPr>
-          <p:nvPr>
-            <p:ph type="body" idx="1"/>
-          </p:nvPr>
-        </p:nvSpPr>
-        <p:spPr/>
-        <p:txBody>
-          <a:bodyPr/>
-          <a:lstStyle/>
-          <a:p>
-            <a:r>
-              <a:rPr lang="en-US" dirty="0"/>
-              <a:t>These are points inside the build grade, not percentages of the course grade.
-The build is 4.5% of the course and is due September 25.
-Design keeps its credit when the implementation falls short, as long as the
-design's claims and the final status are honest.</a:t>
-            </a:r>
-            <a:endParaRPr lang="en-US" dirty="0"/>
-          </a:p>
-        </p:txBody>
-      </p:sp>
-      <p:sp>
-        <p:nvSpPr>
-          <p:cNvPr id="4" name="Slide Number Placeholder 3"/>
-          <p:cNvSpPr>
-            <a:spLocks noGrp="1"/>
-          </p:cNvSpPr>
-          <p:nvPr>
-            <p:ph type="sldNum" sz="quarter" idx="10"/>
-          </p:nvPr>
-        </p:nvSpPr>
-        <p:spPr/>
-        <p:txBody>
-          <a:bodyPr/>
-          <a:lstStyle/>
-          <a:p>
-            <a:fld id="{F7021451-1387-4CA6-816F-3879F97B5CBC}" type="slidenum">
-              <a:rPr lang="en-US"/>
-              <a:t>30</a:t>
-            </a:fld>
-            <a:endParaRPr lang="en-US"/>
-          </a:p>
-        </p:txBody>
-      </p:sp>
-    </p:spTree>
-    <p:extLst>
-      <p:ext uri="{BB962C8B-B14F-4D97-AF65-F5344CB8AC3E}">
-        <p14:creationId xmlns:p14="http://schemas.microsoft.com/office/powerpoint/2010/main" val="1024086991"/>
-      </p:ext>
-    </p:extLst>
-  </p:cSld>
-  <p:clrMapOvr>
-    <a:masterClrMapping/>
-  </p:clrMapOvr>
-</p:notes>
-</file>
-
-<file path=ppt/notesSlides/notesSlide31.xml><?xml version="1.0" encoding="utf-8"?>
-<p:notes xmlns:a="http://schemas.openxmlformats.org/drawingml/2006/main" xmlns:r="http://schemas.openxmlformats.org/officeDocument/2006/relationships" xmlns:p="http://schemas.openxmlformats.org/presentationml/2006/main">
-  <p:cSld>
-    <p:spTree>
-      <p:nvGrpSpPr>
-        <p:cNvPr id="1" name=""/>
-        <p:cNvGrpSpPr/>
-        <p:nvPr/>
-      </p:nvGrpSpPr>
-      <p:grpSpPr>
-        <a:xfrm>
-          <a:off x="0" y="0"/>
-          <a:ext cx="0" cy="0"/>
-          <a:chOff x="0" y="0"/>
-          <a:chExt cx="0" cy="0"/>
-        </a:xfrm>
-      </p:grpSpPr>
-      <p:sp>
-        <p:nvSpPr>
-          <p:cNvPr id="2" name="Slide Image Placeholder 1"/>
-          <p:cNvSpPr>
-            <a:spLocks noGrp="1" noRot="1" noChangeAspect="1"/>
-          </p:cNvSpPr>
-          <p:nvPr>
-            <p:ph type="sldImg"/>
-          </p:nvPr>
-        </p:nvSpPr>
-        <p:spPr/>
-      </p:sp>
-      <p:sp>
-        <p:nvSpPr>
-          <p:cNvPr id="3" name="Notes Placeholder 2"/>
-          <p:cNvSpPr>
-            <a:spLocks noGrp="1"/>
-          </p:cNvSpPr>
-          <p:nvPr>
-            <p:ph type="body" idx="1"/>
-          </p:nvPr>
-        </p:nvSpPr>
-        <p:spPr/>
-        <p:txBody>
-          <a:bodyPr/>
-          <a:lstStyle/>
-          <a:p>
-            <a:r>
-              <a:rPr lang="en-US" dirty="0"/>
-              <a:t>The per-feature split is in RUBRIC.md. Only one F4 point depends on the live
-model actually succeeding, and honest evidence of an unsuccessful run still
-earns the reporting points.
-They write every test, including the client protocol checks.</a:t>
-            </a:r>
-            <a:endParaRPr lang="en-US" dirty="0"/>
-          </a:p>
-        </p:txBody>
-      </p:sp>
-      <p:sp>
-        <p:nvSpPr>
-          <p:cNvPr id="4" name="Slide Number Placeholder 3"/>
-          <p:cNvSpPr>
-            <a:spLocks noGrp="1"/>
-          </p:cNvSpPr>
-          <p:nvPr>
-            <p:ph type="sldNum" sz="quarter" idx="10"/>
-          </p:nvPr>
-        </p:nvSpPr>
-        <p:spPr/>
-        <p:txBody>
-          <a:bodyPr/>
-          <a:lstStyle/>
-          <a:p>
-            <a:fld id="{F7021451-1387-4CA6-816F-3879F97B5CBC}" type="slidenum">
-              <a:rPr lang="en-US"/>
-              <a:t>31</a:t>
-            </a:fld>
-            <a:endParaRPr lang="en-US"/>
-          </a:p>
-        </p:txBody>
-      </p:sp>
-    </p:spTree>
-    <p:extLst>
-      <p:ext uri="{BB962C8B-B14F-4D97-AF65-F5344CB8AC3E}">
-        <p14:creationId xmlns:p14="http://schemas.microsoft.com/office/powerpoint/2010/main" val="1024086991"/>
-      </p:ext>
-    </p:extLst>
-  </p:cSld>
-  <p:clrMapOvr>
-    <a:masterClrMapping/>
-  </p:clrMapOvr>
-</p:notes>
-</file>
-
-<file path=ppt/notesSlides/notesSlide32.xml><?xml version="1.0" encoding="utf-8"?>
-<p:notes xmlns:a="http://schemas.openxmlformats.org/drawingml/2006/main" xmlns:r="http://schemas.openxmlformats.org/officeDocument/2006/relationships" xmlns:p="http://schemas.openxmlformats.org/presentationml/2006/main">
-  <p:cSld>
-    <p:spTree>
-      <p:nvGrpSpPr>
-        <p:cNvPr id="1" name=""/>
-        <p:cNvGrpSpPr/>
-        <p:nvPr/>
-      </p:nvGrpSpPr>
-      <p:grpSpPr>
-        <a:xfrm>
-          <a:off x="0" y="0"/>
-          <a:ext cx="0" cy="0"/>
-          <a:chOff x="0" y="0"/>
-          <a:chExt cx="0" cy="0"/>
-        </a:xfrm>
-      </p:grpSpPr>
-      <p:sp>
-        <p:nvSpPr>
-          <p:cNvPr id="2" name="Slide Image Placeholder 1"/>
-          <p:cNvSpPr>
-            <a:spLocks noGrp="1" noRot="1" noChangeAspect="1"/>
-          </p:cNvSpPr>
-          <p:nvPr>
-            <p:ph type="sldImg"/>
-          </p:nvPr>
-        </p:nvSpPr>
-        <p:spPr/>
-      </p:sp>
-      <p:sp>
-        <p:nvSpPr>
-          <p:cNvPr id="3" name="Notes Placeholder 2"/>
-          <p:cNvSpPr>
-            <a:spLocks noGrp="1"/>
-          </p:cNvSpPr>
-          <p:nvPr>
-            <p:ph type="body" idx="1"/>
-          </p:nvPr>
-        </p:nvSpPr>
-        <p:spPr/>
-        <p:txBody>
-          <a:bodyPr/>
-          <a:lstStyle/>
-          <a:p>
-            <a:r>
-              <a:rPr lang="en-US" dirty="0"/>
-              <a:t>No points for suffering, and no repeated deductions for one missing feature
-across otherwise sound artifacts.
-Policy violations go through academic integrity procedures, not the rubric.</a:t>
-            </a:r>
-            <a:endParaRPr lang="en-US" dirty="0"/>
-          </a:p>
-        </p:txBody>
-      </p:sp>
-      <p:sp>
-        <p:nvSpPr>
-          <p:cNvPr id="4" name="Slide Number Placeholder 3"/>
-          <p:cNvSpPr>
-            <a:spLocks noGrp="1"/>
-          </p:cNvSpPr>
-          <p:nvPr>
-            <p:ph type="sldNum" sz="quarter" idx="10"/>
-          </p:nvPr>
-        </p:nvSpPr>
-        <p:spPr/>
-        <p:txBody>
-          <a:bodyPr/>
-          <a:lstStyle/>
-          <a:p>
-            <a:fld id="{F7021451-1387-4CA6-816F-3879F97B5CBC}" type="slidenum">
-              <a:rPr lang="en-US"/>
-              <a:t>32</a:t>
-            </a:fld>
-            <a:endParaRPr lang="en-US"/>
-          </a:p>
-        </p:txBody>
-      </p:sp>
-    </p:spTree>
-    <p:extLst>
-      <p:ext uri="{BB962C8B-B14F-4D97-AF65-F5344CB8AC3E}">
-        <p14:creationId xmlns:p14="http://schemas.microsoft.com/office/powerpoint/2010/main" val="1024086991"/>
-      </p:ext>
-    </p:extLst>
-  </p:cSld>
-  <p:clrMapOvr>
-    <a:masterClrMapping/>
-  </p:clrMapOvr>
-</p:notes>
-</file>
-
-<file path=ppt/notesSlides/notesSlide33.xml><?xml version="1.0" encoding="utf-8"?>
+<file path=ppt/notesSlides/notesSlide36.xml><?xml version="1.0" encoding="utf-8"?>
 <p:notes xmlns:a="http://schemas.openxmlformats.org/drawingml/2006/main" xmlns:r="http://schemas.openxmlformats.org/officeDocument/2006/relationships" xmlns:p="http://schemas.openxmlformats.org/presentationml/2006/main">
   <p:cSld>
     <p:spTree>
@@ -2936,7 +3228,7 @@
           <a:p>
             <a:fld id="{F7021451-1387-4CA6-816F-3879F97B5CBC}" type="slidenum">
               <a:rPr lang="en-US"/>
-              <a:t>33</a:t>
+              <a:t>36</a:t>
             </a:fld>
             <a:endParaRPr lang="en-US"/>
           </a:p>
@@ -2955,7 +3247,7 @@
 </p:notes>
 </file>
 
-<file path=ppt/notesSlides/notesSlide34.xml><?xml version="1.0" encoding="utf-8"?>
+<file path=ppt/notesSlides/notesSlide37.xml><?xml version="1.0" encoding="utf-8"?>
 <p:notes xmlns:a="http://schemas.openxmlformats.org/drawingml/2006/main" xmlns:r="http://schemas.openxmlformats.org/officeDocument/2006/relationships" xmlns:p="http://schemas.openxmlformats.org/presentationml/2006/main">
   <p:cSld>
     <p:spTree>
@@ -3026,7 +3318,7 @@
           <a:p>
             <a:fld id="{F7021451-1387-4CA6-816F-3879F97B5CBC}" type="slidenum">
               <a:rPr lang="en-US"/>
-              <a:t>34</a:t>
+              <a:t>37</a:t>
             </a:fld>
             <a:endParaRPr lang="en-US"/>
           </a:p>
@@ -3045,7 +3337,7 @@
 </p:notes>
 </file>
 
-<file path=ppt/notesSlides/notesSlide35.xml><?xml version="1.0" encoding="utf-8"?>
+<file path=ppt/notesSlides/notesSlide38.xml><?xml version="1.0" encoding="utf-8"?>
 <p:notes xmlns:a="http://schemas.openxmlformats.org/drawingml/2006/main" xmlns:r="http://schemas.openxmlformats.org/officeDocument/2006/relationships" xmlns:p="http://schemas.openxmlformats.org/presentationml/2006/main">
   <p:cSld>
     <p:spTree>
@@ -3116,7 +3408,7 @@
           <a:p>
             <a:fld id="{F7021451-1387-4CA6-816F-3879F97B5CBC}" type="slidenum">
               <a:rPr lang="en-US"/>
-              <a:t>35</a:t>
+              <a:t>38</a:t>
             </a:fld>
             <a:endParaRPr lang="en-US"/>
           </a:p>
@@ -3135,7 +3427,7 @@
 </p:notes>
 </file>
 
-<file path=ppt/notesSlides/notesSlide36.xml><?xml version="1.0" encoding="utf-8"?>
+<file path=ppt/notesSlides/notesSlide39.xml><?xml version="1.0" encoding="utf-8"?>
 <p:notes xmlns:a="http://schemas.openxmlformats.org/drawingml/2006/main" xmlns:r="http://schemas.openxmlformats.org/officeDocument/2006/relationships" xmlns:p="http://schemas.openxmlformats.org/presentationml/2006/main">
   <p:cSld>
     <p:spTree>
@@ -3206,7 +3498,7 @@
           <a:p>
             <a:fld id="{F7021451-1387-4CA6-816F-3879F97B5CBC}" type="slidenum">
               <a:rPr lang="en-US"/>
-              <a:t>36</a:t>
+              <a:t>39</a:t>
             </a:fld>
             <a:endParaRPr lang="en-US"/>
           </a:p>
@@ -3225,7 +3517,7 @@
 </p:notes>
 </file>
 
-<file path=ppt/notesSlides/notesSlide37.xml><?xml version="1.0" encoding="utf-8"?>
+<file path=ppt/notesSlides/notesSlide4.xml><?xml version="1.0" encoding="utf-8"?>
 <p:notes xmlns:a="http://schemas.openxmlformats.org/drawingml/2006/main" xmlns:r="http://schemas.openxmlformats.org/officeDocument/2006/relationships" xmlns:p="http://schemas.openxmlformats.org/presentationml/2006/main">
   <p:cSld>
     <p:spTree>
@@ -3271,10 +3563,13 @@
           <a:p>
             <a:r>
               <a:rPr lang="en-US" dirty="0"/>
-              <a:t>Label this a hypothetical trace. You have not run it and it is not a product
-demonstration.
-The model can only choose from what the harness exposes and what permissions
-allow. That sentence is the whole design problem, and they build it in Analyze.</a:t>
+              <a:t>The prefix confuses people every term. It tells Aider which wire format to
+speak. Nothing about that line sends anything to OpenAI.
+Say the policy sentence plainly: any compatible endpoint is fine, the permitted
+models are fixed, and the two decisions are unrelated. The full policy is
+MODEL-POLICY.md and the rubric has disclosure points for getting it right.
+Course baseline is Aider 0.86.2. If a student reports behavior that contradicts
+this deck, ask their version before doubting the deck.</a:t>
             </a:r>
             <a:endParaRPr lang="en-US" dirty="0"/>
           </a:p>
@@ -3297,7 +3592,7 @@
           <a:p>
             <a:fld id="{F7021451-1387-4CA6-816F-3879F97B5CBC}" type="slidenum">
               <a:rPr lang="en-US"/>
-              <a:t>37</a:t>
+              <a:t>4</a:t>
             </a:fld>
             <a:endParaRPr lang="en-US"/>
           </a:p>
@@ -3316,7 +3611,7 @@
 </p:notes>
 </file>
 
-<file path=ppt/notesSlides/notesSlide38.xml><?xml version="1.0" encoding="utf-8"?>
+<file path=ppt/notesSlides/notesSlide40.xml><?xml version="1.0" encoding="utf-8"?>
 <p:notes xmlns:a="http://schemas.openxmlformats.org/drawingml/2006/main" xmlns:r="http://schemas.openxmlformats.org/officeDocument/2006/relationships" xmlns:p="http://schemas.openxmlformats.org/presentationml/2006/main">
   <p:cSld>
     <p:spTree>
@@ -3387,7 +3682,7 @@
           <a:p>
             <a:fld id="{F7021451-1387-4CA6-816F-3879F97B5CBC}" type="slidenum">
               <a:rPr lang="en-US"/>
-              <a:t>38</a:t>
+              <a:t>40</a:t>
             </a:fld>
             <a:endParaRPr lang="en-US"/>
           </a:p>
@@ -3406,187 +3701,7 @@
 </p:notes>
 </file>
 
-<file path=ppt/notesSlides/notesSlide39.xml><?xml version="1.0" encoding="utf-8"?>
-<p:notes xmlns:a="http://schemas.openxmlformats.org/drawingml/2006/main" xmlns:r="http://schemas.openxmlformats.org/officeDocument/2006/relationships" xmlns:p="http://schemas.openxmlformats.org/presentationml/2006/main">
-  <p:cSld>
-    <p:spTree>
-      <p:nvGrpSpPr>
-        <p:cNvPr id="1" name=""/>
-        <p:cNvGrpSpPr/>
-        <p:nvPr/>
-      </p:nvGrpSpPr>
-      <p:grpSpPr>
-        <a:xfrm>
-          <a:off x="0" y="0"/>
-          <a:ext cx="0" cy="0"/>
-          <a:chOff x="0" y="0"/>
-          <a:chExt cx="0" cy="0"/>
-        </a:xfrm>
-      </p:grpSpPr>
-      <p:sp>
-        <p:nvSpPr>
-          <p:cNvPr id="2" name="Slide Image Placeholder 1"/>
-          <p:cNvSpPr>
-            <a:spLocks noGrp="1" noRot="1" noChangeAspect="1"/>
-          </p:cNvSpPr>
-          <p:nvPr>
-            <p:ph type="sldImg"/>
-          </p:nvPr>
-        </p:nvSpPr>
-        <p:spPr/>
-      </p:sp>
-      <p:sp>
-        <p:nvSpPr>
-          <p:cNvPr id="3" name="Notes Placeholder 2"/>
-          <p:cNvSpPr>
-            <a:spLocks noGrp="1"/>
-          </p:cNvSpPr>
-          <p:nvPr>
-            <p:ph type="body" idx="1"/>
-          </p:nvPr>
-        </p:nvSpPr>
-        <p:spPr/>
-        <p:txBody>
-          <a:bodyPr/>
-          <a:lstStyle/>
-          <a:p>
-            <a:r>
-              <a:rPr lang="en-US" dirty="0"/>
-              <a:t>Your terminal is one entry point. A gateway is what makes it several.
-Keep the client connections separate from the agent runtime in their heads. This
-is not several agents working on one task. OpenClaw is a comparison, not a
-library anyone here has to adopt.
-Source: https://docs.openclaw.ai/concepts/architecture</a:t>
-            </a:r>
-            <a:endParaRPr lang="en-US" dirty="0"/>
-          </a:p>
-        </p:txBody>
-      </p:sp>
-      <p:sp>
-        <p:nvSpPr>
-          <p:cNvPr id="4" name="Slide Number Placeholder 3"/>
-          <p:cNvSpPr>
-            <a:spLocks noGrp="1"/>
-          </p:cNvSpPr>
-          <p:nvPr>
-            <p:ph type="sldNum" sz="quarter" idx="10"/>
-          </p:nvPr>
-        </p:nvSpPr>
-        <p:spPr/>
-        <p:txBody>
-          <a:bodyPr/>
-          <a:lstStyle/>
-          <a:p>
-            <a:fld id="{F7021451-1387-4CA6-816F-3879F97B5CBC}" type="slidenum">
-              <a:rPr lang="en-US"/>
-              <a:t>39</a:t>
-            </a:fld>
-            <a:endParaRPr lang="en-US"/>
-          </a:p>
-        </p:txBody>
-      </p:sp>
-    </p:spTree>
-    <p:extLst>
-      <p:ext uri="{BB962C8B-B14F-4D97-AF65-F5344CB8AC3E}">
-        <p14:creationId xmlns:p14="http://schemas.microsoft.com/office/powerpoint/2010/main" val="1024086991"/>
-      </p:ext>
-    </p:extLst>
-  </p:cSld>
-  <p:clrMapOvr>
-    <a:masterClrMapping/>
-  </p:clrMapOvr>
-</p:notes>
-</file>
-
-<file path=ppt/notesSlides/notesSlide4.xml><?xml version="1.0" encoding="utf-8"?>
-<p:notes xmlns:a="http://schemas.openxmlformats.org/drawingml/2006/main" xmlns:r="http://schemas.openxmlformats.org/officeDocument/2006/relationships" xmlns:p="http://schemas.openxmlformats.org/presentationml/2006/main">
-  <p:cSld>
-    <p:spTree>
-      <p:nvGrpSpPr>
-        <p:cNvPr id="1" name=""/>
-        <p:cNvGrpSpPr/>
-        <p:nvPr/>
-      </p:nvGrpSpPr>
-      <p:grpSpPr>
-        <a:xfrm>
-          <a:off x="0" y="0"/>
-          <a:ext cx="0" cy="0"/>
-          <a:chOff x="0" y="0"/>
-          <a:chExt cx="0" cy="0"/>
-        </a:xfrm>
-      </p:grpSpPr>
-      <p:sp>
-        <p:nvSpPr>
-          <p:cNvPr id="2" name="Slide Image Placeholder 1"/>
-          <p:cNvSpPr>
-            <a:spLocks noGrp="1" noRot="1" noChangeAspect="1"/>
-          </p:cNvSpPr>
-          <p:nvPr>
-            <p:ph type="sldImg"/>
-          </p:nvPr>
-        </p:nvSpPr>
-        <p:spPr/>
-      </p:sp>
-      <p:sp>
-        <p:nvSpPr>
-          <p:cNvPr id="3" name="Notes Placeholder 2"/>
-          <p:cNvSpPr>
-            <a:spLocks noGrp="1"/>
-          </p:cNvSpPr>
-          <p:nvPr>
-            <p:ph type="body" idx="1"/>
-          </p:nvPr>
-        </p:nvSpPr>
-        <p:spPr/>
-        <p:txBody>
-          <a:bodyPr/>
-          <a:lstStyle/>
-          <a:p>
-            <a:r>
-              <a:rPr lang="en-US" dirty="0"/>
-              <a:t>Six steps. Say up front that only step 2 belongs to the model.</a:t>
-            </a:r>
-            <a:endParaRPr lang="en-US" dirty="0"/>
-          </a:p>
-        </p:txBody>
-      </p:sp>
-      <p:sp>
-        <p:nvSpPr>
-          <p:cNvPr id="4" name="Slide Number Placeholder 3"/>
-          <p:cNvSpPr>
-            <a:spLocks noGrp="1"/>
-          </p:cNvSpPr>
-          <p:nvPr>
-            <p:ph type="sldNum" sz="quarter" idx="10"/>
-          </p:nvPr>
-        </p:nvSpPr>
-        <p:spPr/>
-        <p:txBody>
-          <a:bodyPr/>
-          <a:lstStyle/>
-          <a:p>
-            <a:fld id="{F7021451-1387-4CA6-816F-3879F97B5CBC}" type="slidenum">
-              <a:rPr lang="en-US"/>
-              <a:t>4</a:t>
-            </a:fld>
-            <a:endParaRPr lang="en-US"/>
-          </a:p>
-        </p:txBody>
-      </p:sp>
-    </p:spTree>
-    <p:extLst>
-      <p:ext uri="{BB962C8B-B14F-4D97-AF65-F5344CB8AC3E}">
-        <p14:creationId xmlns:p14="http://schemas.microsoft.com/office/powerpoint/2010/main" val="1024086991"/>
-      </p:ext>
-    </p:extLst>
-  </p:cSld>
-  <p:clrMapOvr>
-    <a:masterClrMapping/>
-  </p:clrMapOvr>
-</p:notes>
-</file>
-
-<file path=ppt/notesSlides/notesSlide40.xml><?xml version="1.0" encoding="utf-8"?>
+<file path=ppt/notesSlides/notesSlide41.xml><?xml version="1.0" encoding="utf-8"?>
 <p:notes xmlns:a="http://schemas.openxmlformats.org/drawingml/2006/main" xmlns:r="http://schemas.openxmlformats.org/officeDocument/2006/relationships" xmlns:p="http://schemas.openxmlformats.org/presentationml/2006/main">
   <p:cSld>
     <p:spTree>
@@ -3656,7 +3771,7 @@
           <a:p>
             <a:fld id="{F7021451-1387-4CA6-816F-3879F97B5CBC}" type="slidenum">
               <a:rPr lang="en-US"/>
-              <a:t>40</a:t>
+              <a:t>41</a:t>
             </a:fld>
             <a:endParaRPr lang="en-US"/>
           </a:p>
@@ -3675,7 +3790,7 @@
 </p:notes>
 </file>
 
-<file path=ppt/notesSlides/notesSlide41.xml><?xml version="1.0" encoding="utf-8"?>
+<file path=ppt/notesSlides/notesSlide42.xml><?xml version="1.0" encoding="utf-8"?>
 <p:notes xmlns:a="http://schemas.openxmlformats.org/drawingml/2006/main" xmlns:r="http://schemas.openxmlformats.org/officeDocument/2006/relationships" xmlns:p="http://schemas.openxmlformats.org/presentationml/2006/main">
   <p:cSld>
     <p:spTree>
@@ -3747,7 +3862,7 @@
           <a:p>
             <a:fld id="{F7021451-1387-4CA6-816F-3879F97B5CBC}" type="slidenum">
               <a:rPr lang="en-US"/>
-              <a:t>41</a:t>
+              <a:t>42</a:t>
             </a:fld>
             <a:endParaRPr lang="en-US"/>
           </a:p>
@@ -3766,7 +3881,7 @@
 </p:notes>
 </file>
 
-<file path=ppt/notesSlides/notesSlide42.xml><?xml version="1.0" encoding="utf-8"?>
+<file path=ppt/notesSlides/notesSlide43.xml><?xml version="1.0" encoding="utf-8"?>
 <p:notes xmlns:a="http://schemas.openxmlformats.org/drawingml/2006/main" xmlns:r="http://schemas.openxmlformats.org/officeDocument/2006/relationships" xmlns:p="http://schemas.openxmlformats.org/presentationml/2006/main">
   <p:cSld>
     <p:spTree>
@@ -3812,13 +3927,7 @@
           <a:p>
             <a:r>
               <a:rPr lang="en-US" dirty="0"/>
-              <a:t>No application exists to run yet. They launch aider directly with .env and the
-supplied configuration, and they write bin/assistant themselves.
-If someone lacks repository access, fix it immediately and let them read the
-packet while you do. Do not hand them an unrelated clone as a substitute.
-That one is worth hunting for rather than waiting to be asked about.
-The list is a menu, not an order of work. A student who spends the whole time
-reading SPEC.md has used it correctly.</a:t>
+              <a:t/>
             </a:r>
             <a:endParaRPr lang="en-US" dirty="0"/>
           </a:p>
@@ -3841,7 +3950,7 @@
           <a:p>
             <a:fld id="{F7021451-1387-4CA6-816F-3879F97B5CBC}" type="slidenum">
               <a:rPr lang="en-US"/>
-              <a:t>42</a:t>
+              <a:t>43</a:t>
             </a:fld>
             <a:endParaRPr lang="en-US"/>
           </a:p>
@@ -3860,7 +3969,7 @@
 </p:notes>
 </file>
 
-<file path=ppt/notesSlides/notesSlide43.xml><?xml version="1.0" encoding="utf-8"?>
+<file path=ppt/notesSlides/notesSlide5.xml><?xml version="1.0" encoding="utf-8"?>
 <p:notes xmlns:a="http://schemas.openxmlformats.org/drawingml/2006/main" xmlns:r="http://schemas.openxmlformats.org/officeDocument/2006/relationships" xmlns:p="http://schemas.openxmlformats.org/presentationml/2006/main">
   <p:cSld>
     <p:spTree>
@@ -3906,13 +4015,13 @@
           <a:p>
             <a:r>
               <a:rPr lang="en-US" dirty="0"/>
-              <a:t>Fifty students at five minutes each is 250 staff-minutes, so there is no full
-design review queue today and do not promise one.
-Peer review is about contracts and verification. It is not code sharing. A
-blocking question gets a concrete follow-up through Ed or office hours.
-What you are looking for as you circulate: an observable outcome, named state
-ownership, explicit error behavior, and one meaningful test. Accept different
-architectures. Do not require a particular file, class or module count.</a:t>
+              <a:t>This is the slide that explains why their practice lessons looked different
+from today's trace: whole-file mode on the 4B, diff mode on the 9B. Ask who ran
+which. The ones on the 4B have never seen a diff block.
+Per-model settings beat the general config, which is the part people get wrong
+when they switch models and nothing changes.
+Never commit .env. It is gitignored in the starter and the rubric treats a
+committed credential as an integrity matter, not a style nit.</a:t>
             </a:r>
             <a:endParaRPr lang="en-US" dirty="0"/>
           </a:p>
@@ -3935,7 +4044,7 @@
           <a:p>
             <a:fld id="{F7021451-1387-4CA6-816F-3879F97B5CBC}" type="slidenum">
               <a:rPr lang="en-US"/>
-              <a:t>43</a:t>
+              <a:t>5</a:t>
             </a:fld>
             <a:endParaRPr lang="en-US"/>
           </a:p>
@@ -3954,7 +4063,7 @@
 </p:notes>
 </file>
 
-<file path=ppt/notesSlides/notesSlide44.xml><?xml version="1.0" encoding="utf-8"?>
+<file path=ppt/notesSlides/notesSlide6.xml><?xml version="1.0" encoding="utf-8"?>
 <p:notes xmlns:a="http://schemas.openxmlformats.org/drawingml/2006/main" xmlns:r="http://schemas.openxmlformats.org/officeDocument/2006/relationships" xmlns:p="http://schemas.openxmlformats.org/presentationml/2006/main">
   <p:cSld>
     <p:spTree>
@@ -4000,15 +4109,11 @@
           <a:p>
             <a:r>
               <a:rPr lang="en-US" dirty="0"/>
-              <a:t>Say the distinction out loud. Nothing on this slide is due because of today;
-it is the order of work for a project that has been due Sep 25 all along, and
-a room that has just been told the lab collects nothing can hear this list as
-a lab assignment if you let it.
-Read the packet list once: design, diagrams, specs, code and tests,
-configuration example, DEVELOPMENT.md, operating README, evidence, AI_LOG.md,
-reflection, and the preserved sessions.
-Lab02 is supported implementation and verification time. September 25 does not
-move.</a:t>
+              <a:t>Make them read the banner. Most setup problems announce themselves here: wrong
+model because .env overrode the config, no git repo because they are one
+directory too high, repo map off when they expected it on.
+The banner text shifts between releases. Treat the shape as the lesson, not the
+exact lines, and tell them to check their own.</a:t>
             </a:r>
             <a:endParaRPr lang="en-US" dirty="0"/>
           </a:p>
@@ -4031,7 +4136,7 @@
           <a:p>
             <a:fld id="{F7021451-1387-4CA6-816F-3879F97B5CBC}" type="slidenum">
               <a:rPr lang="en-US"/>
-              <a:t>44</a:t>
+              <a:t>6</a:t>
             </a:fld>
             <a:endParaRPr lang="en-US"/>
           </a:p>
@@ -4050,7 +4155,7 @@
 </p:notes>
 </file>
 
-<file path=ppt/notesSlides/notesSlide45.xml><?xml version="1.0" encoding="utf-8"?>
+<file path=ppt/notesSlides/notesSlide7.xml><?xml version="1.0" encoding="utf-8"?>
 <p:notes xmlns:a="http://schemas.openxmlformats.org/drawingml/2006/main" xmlns:r="http://schemas.openxmlformats.org/officeDocument/2006/relationships" xmlns:p="http://schemas.openxmlformats.org/presentationml/2006/main">
   <p:cSld>
     <p:spTree>
@@ -4096,7 +4201,11 @@
           <a:p>
             <a:r>
               <a:rPr lang="en-US" dirty="0"/>
-              <a:t/>
+              <a:t>The two in the right-hand column are the whole safety story at this rung: one
+command writes, one takes it back, and everything else is arranging context.
+They will rebuild exactly that distinction in their own approval layer.
+/help lists the full set and it is longer than this. Run it live if anyone
+asks, rather than reciting from the slide; the set moves between versions.</a:t>
             </a:r>
             <a:endParaRPr lang="en-US" dirty="0"/>
           </a:p>
@@ -4119,7 +4228,7 @@
           <a:p>
             <a:fld id="{F7021451-1387-4CA6-816F-3879F97B5CBC}" type="slidenum">
               <a:rPr lang="en-US"/>
-              <a:t>45</a:t>
+              <a:t>7</a:t>
             </a:fld>
             <a:endParaRPr lang="en-US"/>
           </a:p>
@@ -4138,7 +4247,7 @@
 </p:notes>
 </file>
 
-<file path=ppt/notesSlides/notesSlide5.xml><?xml version="1.0" encoding="utf-8"?>
+<file path=ppt/notesSlides/notesSlide8.xml><?xml version="1.0" encoding="utf-8"?>
 <p:notes xmlns:a="http://schemas.openxmlformats.org/drawingml/2006/main" xmlns:r="http://schemas.openxmlformats.org/officeDocument/2006/relationships" xmlns:p="http://schemas.openxmlformats.org/presentationml/2006/main">
   <p:cSld>
     <p:spTree>
@@ -4184,10 +4293,10 @@
           <a:p>
             <a:r>
               <a:rPr lang="en-US" dirty="0"/>
-              <a:t>Ask the room to find the arrow that writes a file. There is not one leaving the
-amber box. The model produced text, and a program decided what to do with it.
-This is a picture of Aider, not a required architecture for their build. They
-will draw their own version of this in a week.</a:t>
+              <a:t>They met this request in the practice lessons, in whole-file mode. Today's
+trace is diff mode and it is illustrative: a simplified turn, not a captured
+transcript of a particular model. The three files matter later, when the
+feature half-works.</a:t>
             </a:r>
             <a:endParaRPr lang="en-US" dirty="0"/>
           </a:p>
@@ -4210,7 +4319,7 @@
           <a:p>
             <a:fld id="{F7021451-1387-4CA6-816F-3879F97B5CBC}" type="slidenum">
               <a:rPr lang="en-US"/>
-              <a:t>5</a:t>
+              <a:t>8</a:t>
             </a:fld>
             <a:endParaRPr lang="en-US"/>
           </a:p>
@@ -4229,280 +4338,6 @@
 </p:notes>
 </file>
 
-<file path=ppt/notesSlides/notesSlide6.xml><?xml version="1.0" encoding="utf-8"?>
-<p:notes xmlns:a="http://schemas.openxmlformats.org/drawingml/2006/main" xmlns:r="http://schemas.openxmlformats.org/officeDocument/2006/relationships" xmlns:p="http://schemas.openxmlformats.org/presentationml/2006/main">
-  <p:cSld>
-    <p:spTree>
-      <p:nvGrpSpPr>
-        <p:cNvPr id="1" name=""/>
-        <p:cNvGrpSpPr/>
-        <p:nvPr/>
-      </p:nvGrpSpPr>
-      <p:grpSpPr>
-        <a:xfrm>
-          <a:off x="0" y="0"/>
-          <a:ext cx="0" cy="0"/>
-          <a:chOff x="0" y="0"/>
-          <a:chExt cx="0" cy="0"/>
-        </a:xfrm>
-      </p:grpSpPr>
-      <p:sp>
-        <p:nvSpPr>
-          <p:cNvPr id="2" name="Slide Image Placeholder 1"/>
-          <p:cNvSpPr>
-            <a:spLocks noGrp="1" noRot="1" noChangeAspect="1"/>
-          </p:cNvSpPr>
-          <p:nvPr>
-            <p:ph type="sldImg"/>
-          </p:nvPr>
-        </p:nvSpPr>
-        <p:spPr/>
-      </p:sp>
-      <p:sp>
-        <p:nvSpPr>
-          <p:cNvPr id="3" name="Notes Placeholder 2"/>
-          <p:cNvSpPr>
-            <a:spLocks noGrp="1"/>
-          </p:cNvSpPr>
-          <p:nvPr>
-            <p:ph type="body" idx="1"/>
-          </p:nvPr>
-        </p:nvSpPr>
-        <p:spPr/>
-        <p:txBody>
-          <a:bodyPr/>
-          <a:lstStyle/>
-          <a:p>
-            <a:r>
-              <a:rPr lang="en-US" dirty="0"/>
-              <a:t>Do not claim a fixed seven-part ordering. What actually goes into the prompt
-depends on the coder, the model and the settings, and it changes between
-releases. The list above is the shape, not the wire format.
-Ask what the model would need in order to add priority consistently to the CLI,
-the task and the store. That question sets up the next two slides.</a:t>
-            </a:r>
-            <a:endParaRPr lang="en-US" dirty="0"/>
-          </a:p>
-        </p:txBody>
-      </p:sp>
-      <p:sp>
-        <p:nvSpPr>
-          <p:cNvPr id="4" name="Slide Number Placeholder 3"/>
-          <p:cNvSpPr>
-            <a:spLocks noGrp="1"/>
-          </p:cNvSpPr>
-          <p:nvPr>
-            <p:ph type="sldNum" sz="quarter" idx="10"/>
-          </p:nvPr>
-        </p:nvSpPr>
-        <p:spPr/>
-        <p:txBody>
-          <a:bodyPr/>
-          <a:lstStyle/>
-          <a:p>
-            <a:fld id="{F7021451-1387-4CA6-816F-3879F97B5CBC}" type="slidenum">
-              <a:rPr lang="en-US"/>
-              <a:t>6</a:t>
-            </a:fld>
-            <a:endParaRPr lang="en-US"/>
-          </a:p>
-        </p:txBody>
-      </p:sp>
-    </p:spTree>
-    <p:extLst>
-      <p:ext uri="{BB962C8B-B14F-4D97-AF65-F5344CB8AC3E}">
-        <p14:creationId xmlns:p14="http://schemas.microsoft.com/office/powerpoint/2010/main" val="1024086991"/>
-      </p:ext>
-    </p:extLst>
-  </p:cSld>
-  <p:clrMapOvr>
-    <a:masterClrMapping/>
-  </p:clrMapOvr>
-</p:notes>
-</file>
-
-<file path=ppt/notesSlides/notesSlide7.xml><?xml version="1.0" encoding="utf-8"?>
-<p:notes xmlns:a="http://schemas.openxmlformats.org/drawingml/2006/main" xmlns:r="http://schemas.openxmlformats.org/officeDocument/2006/relationships" xmlns:p="http://schemas.openxmlformats.org/presentationml/2006/main">
-  <p:cSld>
-    <p:spTree>
-      <p:nvGrpSpPr>
-        <p:cNvPr id="1" name=""/>
-        <p:cNvGrpSpPr/>
-        <p:nvPr/>
-      </p:nvGrpSpPr>
-      <p:grpSpPr>
-        <a:xfrm>
-          <a:off x="0" y="0"/>
-          <a:ext cx="0" cy="0"/>
-          <a:chOff x="0" y="0"/>
-          <a:chExt cx="0" cy="0"/>
-        </a:xfrm>
-      </p:grpSpPr>
-      <p:sp>
-        <p:nvSpPr>
-          <p:cNvPr id="2" name="Slide Image Placeholder 1"/>
-          <p:cNvSpPr>
-            <a:spLocks noGrp="1" noRot="1" noChangeAspect="1"/>
-          </p:cNvSpPr>
-          <p:nvPr>
-            <p:ph type="sldImg"/>
-          </p:nvPr>
-        </p:nvSpPr>
-        <p:spPr/>
-      </p:sp>
-      <p:sp>
-        <p:nvSpPr>
-          <p:cNvPr id="3" name="Notes Placeholder 2"/>
-          <p:cNvSpPr>
-            <a:spLocks noGrp="1"/>
-          </p:cNvSpPr>
-          <p:nvPr>
-            <p:ph type="body" idx="1"/>
-          </p:nvPr>
-        </p:nvSpPr>
-        <p:spPr/>
-        <p:txBody>
-          <a:bodyPr/>
-          <a:lstStyle/>
-          <a:p>
-            <a:r>
-              <a:rPr lang="en-US" dirty="0"/>
-              <a:t>Walk through why these three files and not the whole package. This is one
-sensible selection, not a rule to add everything. Read-only context still
-costs budget. /tokens tells you what you are spending, and nothing about
-whether the edit will be correct.</a:t>
-            </a:r>
-            <a:endParaRPr lang="en-US" dirty="0"/>
-          </a:p>
-        </p:txBody>
-      </p:sp>
-      <p:sp>
-        <p:nvSpPr>
-          <p:cNvPr id="4" name="Slide Number Placeholder 3"/>
-          <p:cNvSpPr>
-            <a:spLocks noGrp="1"/>
-          </p:cNvSpPr>
-          <p:nvPr>
-            <p:ph type="sldNum" sz="quarter" idx="10"/>
-          </p:nvPr>
-        </p:nvSpPr>
-        <p:spPr/>
-        <p:txBody>
-          <a:bodyPr/>
-          <a:lstStyle/>
-          <a:p>
-            <a:fld id="{F7021451-1387-4CA6-816F-3879F97B5CBC}" type="slidenum">
-              <a:rPr lang="en-US"/>
-              <a:t>7</a:t>
-            </a:fld>
-            <a:endParaRPr lang="en-US"/>
-          </a:p>
-        </p:txBody>
-      </p:sp>
-    </p:spTree>
-    <p:extLst>
-      <p:ext uri="{BB962C8B-B14F-4D97-AF65-F5344CB8AC3E}">
-        <p14:creationId xmlns:p14="http://schemas.microsoft.com/office/powerpoint/2010/main" val="1024086991"/>
-      </p:ext>
-    </p:extLst>
-  </p:cSld>
-  <p:clrMapOvr>
-    <a:masterClrMapping/>
-  </p:clrMapOvr>
-</p:notes>
-</file>
-
-<file path=ppt/notesSlides/notesSlide8.xml><?xml version="1.0" encoding="utf-8"?>
-<p:notes xmlns:a="http://schemas.openxmlformats.org/drawingml/2006/main" xmlns:r="http://schemas.openxmlformats.org/officeDocument/2006/relationships" xmlns:p="http://schemas.openxmlformats.org/presentationml/2006/main">
-  <p:cSld>
-    <p:spTree>
-      <p:nvGrpSpPr>
-        <p:cNvPr id="1" name=""/>
-        <p:cNvGrpSpPr/>
-        <p:nvPr/>
-      </p:nvGrpSpPr>
-      <p:grpSpPr>
-        <a:xfrm>
-          <a:off x="0" y="0"/>
-          <a:ext cx="0" cy="0"/>
-          <a:chOff x="0" y="0"/>
-          <a:chExt cx="0" cy="0"/>
-        </a:xfrm>
-      </p:grpSpPr>
-      <p:sp>
-        <p:nvSpPr>
-          <p:cNvPr id="2" name="Slide Image Placeholder 1"/>
-          <p:cNvSpPr>
-            <a:spLocks noGrp="1" noRot="1" noChangeAspect="1"/>
-          </p:cNvSpPr>
-          <p:nvPr>
-            <p:ph type="sldImg"/>
-          </p:nvPr>
-        </p:nvSpPr>
-        <p:spPr/>
-      </p:sp>
-      <p:sp>
-        <p:nvSpPr>
-          <p:cNvPr id="3" name="Notes Placeholder 2"/>
-          <p:cNvSpPr>
-            <a:spLocks noGrp="1"/>
-          </p:cNvSpPr>
-          <p:nvPr>
-            <p:ph type="body" idx="1"/>
-          </p:nvPr>
-        </p:nvSpPr>
-        <p:spPr/>
-        <p:txBody>
-          <a:bodyPr/>
-          <a:lstStyle/>
-          <a:p>
-            <a:r>
-              <a:rPr lang="en-US" dirty="0"/>
-              <a:t>The excerpt is illustrative. Do not promise the map contains every file, and do
-not use its silence as proof that a dependency is absent. When a student says
-"the model should have known," check whether they added the file or only let the
-map mention it. Source: https://aider.chat/docs/repomap.html</a:t>
-            </a:r>
-            <a:endParaRPr lang="en-US" dirty="0"/>
-          </a:p>
-        </p:txBody>
-      </p:sp>
-      <p:sp>
-        <p:nvSpPr>
-          <p:cNvPr id="4" name="Slide Number Placeholder 3"/>
-          <p:cNvSpPr>
-            <a:spLocks noGrp="1"/>
-          </p:cNvSpPr>
-          <p:nvPr>
-            <p:ph type="sldNum" sz="quarter" idx="10"/>
-          </p:nvPr>
-        </p:nvSpPr>
-        <p:spPr/>
-        <p:txBody>
-          <a:bodyPr/>
-          <a:lstStyle/>
-          <a:p>
-            <a:fld id="{F7021451-1387-4CA6-816F-3879F97B5CBC}" type="slidenum">
-              <a:rPr lang="en-US"/>
-              <a:t>8</a:t>
-            </a:fld>
-            <a:endParaRPr lang="en-US"/>
-          </a:p>
-        </p:txBody>
-      </p:sp>
-    </p:spTree>
-    <p:extLst>
-      <p:ext uri="{BB962C8B-B14F-4D97-AF65-F5344CB8AC3E}">
-        <p14:creationId xmlns:p14="http://schemas.microsoft.com/office/powerpoint/2010/main" val="1024086991"/>
-      </p:ext>
-    </p:extLst>
-  </p:cSld>
-  <p:clrMapOvr>
-    <a:masterClrMapping/>
-  </p:clrMapOvr>
-</p:notes>
-</file>
-
 <file path=ppt/notesSlides/notesSlide9.xml><?xml version="1.0" encoding="utf-8"?>
 <p:notes xmlns:a="http://schemas.openxmlformats.org/drawingml/2006/main" xmlns:r="http://schemas.openxmlformats.org/officeDocument/2006/relationships" xmlns:p="http://schemas.openxmlformats.org/presentationml/2006/main">
   <p:cSld>
@@ -4549,10 +4384,7 @@
           <a:p>
             <a:r>
               <a:rPr lang="en-US" dirty="0"/>
-              <a:t>Ask what they would drop first and what has to survive. Their Stage 1 contract
-keeps the system instructions, the current request and the added file contents,
-and refuses an oversized required input instead of silently trimming it. That
-refusal is a design decision they have to write down and test.</a:t>
+              <a:t>Six steps. Say up front that only step 2 belongs to the model.</a:t>
             </a:r>
             <a:endParaRPr lang="en-US" dirty="0"/>
           </a:p>
@@ -6347,84 +6179,6 @@
 <file path=ppt/slides/slide43.xml><?xml version="1.0" encoding="utf-8"?>
 <p:sld xmlns:a="http://schemas.openxmlformats.org/drawingml/2006/main" xmlns:r="http://schemas.openxmlformats.org/officeDocument/2006/relationships" xmlns:p="http://schemas.openxmlformats.org/presentationml/2006/main">
   <p:cSld name="Slide 43">
-    <p:bg>
-      <p:bgPr>
-        <a:blipFill dpi="0" rotWithShape="1">
-          <a:blip r:embed="rId1">
-            <a:lum/>
-          </a:blip>
-          <a:srcRect/>
-          <a:stretch>
-            <a:fillRect/>
-          </a:stretch>
-        </a:blipFill>
-        <a:effectLst/>
-      </p:bgPr>
-    </p:bg>
-    <p:spTree>
-      <p:nvGrpSpPr>
-        <p:cNvPr id="1" name=""/>
-        <p:cNvGrpSpPr/>
-        <p:nvPr/>
-      </p:nvGrpSpPr>
-      <p:grpSpPr>
-        <a:xfrm>
-          <a:off x="0" y="0"/>
-          <a:ext cx="0" cy="0"/>
-          <a:chOff x="0" y="0"/>
-          <a:chExt cx="0" cy="0"/>
-        </a:xfrm>
-      </p:grpSpPr>
-    </p:spTree>
-  </p:cSld>
-  <p:clrMapOvr>
-    <a:masterClrMapping/>
-  </p:clrMapOvr>
-</p:sld>
-</file>
-
-<file path=ppt/slides/slide44.xml><?xml version="1.0" encoding="utf-8"?>
-<p:sld xmlns:a="http://schemas.openxmlformats.org/drawingml/2006/main" xmlns:r="http://schemas.openxmlformats.org/officeDocument/2006/relationships" xmlns:p="http://schemas.openxmlformats.org/presentationml/2006/main">
-  <p:cSld name="Slide 44">
-    <p:bg>
-      <p:bgPr>
-        <a:blipFill dpi="0" rotWithShape="1">
-          <a:blip r:embed="rId1">
-            <a:lum/>
-          </a:blip>
-          <a:srcRect/>
-          <a:stretch>
-            <a:fillRect/>
-          </a:stretch>
-        </a:blipFill>
-        <a:effectLst/>
-      </p:bgPr>
-    </p:bg>
-    <p:spTree>
-      <p:nvGrpSpPr>
-        <p:cNvPr id="1" name=""/>
-        <p:cNvGrpSpPr/>
-        <p:nvPr/>
-      </p:nvGrpSpPr>
-      <p:grpSpPr>
-        <a:xfrm>
-          <a:off x="0" y="0"/>
-          <a:ext cx="0" cy="0"/>
-          <a:chOff x="0" y="0"/>
-          <a:chExt cx="0" cy="0"/>
-        </a:xfrm>
-      </p:grpSpPr>
-    </p:spTree>
-  </p:cSld>
-  <p:clrMapOvr>
-    <a:masterClrMapping/>
-  </p:clrMapOvr>
-</p:sld>
-</file>
-
-<file path=ppt/slides/slide45.xml><?xml version="1.0" encoding="utf-8"?>
-<p:sld xmlns:a="http://schemas.openxmlformats.org/drawingml/2006/main" xmlns:r="http://schemas.openxmlformats.org/officeDocument/2006/relationships" xmlns:p="http://schemas.openxmlformats.org/presentationml/2006/main">
-  <p:cSld name="Slide 45">
     <p:bg>
       <p:bgPr>
         <a:blipFill dpi="0" rotWithShape="1">

</xml_diff>

<commit_message>
Lab01: reship the deck with the harness opening
Matches eecs498-aase/aase-f26 at 6456090. The opening block is now
about what a harness does rather than about Aider's configuration
files, and every title and bullet follows the two style-guide sections
added today.

41 slides.

Co-Authored-By: Claude Opus 5 (1M context) <noreply@anthropic.com>
Claude-Session: https://claude.ai/code/session_015pu78gNF4378sH81fTPKSc
</commit_message>
<xml_diff>
--- a/labs/Lab01/slides.pptx
+++ b/labs/Lab01/slides.pptx
@@ -46,11 +46,9 @@
     <p:sldId id="294" r:id="rId40"/>
     <p:sldId id="295" r:id="rId41"/>
     <p:sldId id="296" r:id="rId42"/>
-    <p:sldId id="297" r:id="rId43"/>
-    <p:sldId id="298" r:id="rId44"/>
   </p:sldIdLst>
   <p:notesMasterIdLst>
-    <p:notesMasterId r:id="rId45"/>
+    <p:notesMasterId r:id="rId43"/>
   </p:notesMasterIdLst>
   <p:sldSz cx="9334500" cy="5248275"/>
   <p:notesSz cx="5248275" cy="9334500"/>
@@ -634,189 +632,6 @@
           <a:p>
             <a:r>
               <a:rPr lang="en-US" dirty="0"/>
-              <a:t>Ask the room to find the arrow that writes a file. There is not one leaving the
-amber box. The model produced text, and a program decided what to do with it.
-This is a picture of Aider, not a required architecture for their build. They
-will draw their own version of this in a week.</a:t>
-            </a:r>
-            <a:endParaRPr lang="en-US" dirty="0"/>
-          </a:p>
-        </p:txBody>
-      </p:sp>
-      <p:sp>
-        <p:nvSpPr>
-          <p:cNvPr id="4" name="Slide Number Placeholder 3"/>
-          <p:cNvSpPr>
-            <a:spLocks noGrp="1"/>
-          </p:cNvSpPr>
-          <p:nvPr>
-            <p:ph type="sldNum" sz="quarter" idx="10"/>
-          </p:nvPr>
-        </p:nvSpPr>
-        <p:spPr/>
-        <p:txBody>
-          <a:bodyPr/>
-          <a:lstStyle/>
-          <a:p>
-            <a:fld id="{F7021451-1387-4CA6-816F-3879F97B5CBC}" type="slidenum">
-              <a:rPr lang="en-US"/>
-              <a:t>10</a:t>
-            </a:fld>
-            <a:endParaRPr lang="en-US"/>
-          </a:p>
-        </p:txBody>
-      </p:sp>
-    </p:spTree>
-    <p:extLst>
-      <p:ext uri="{BB962C8B-B14F-4D97-AF65-F5344CB8AC3E}">
-        <p14:creationId xmlns:p14="http://schemas.microsoft.com/office/powerpoint/2010/main" val="1024086991"/>
-      </p:ext>
-    </p:extLst>
-  </p:cSld>
-  <p:clrMapOvr>
-    <a:masterClrMapping/>
-  </p:clrMapOvr>
-</p:notes>
-</file>
-
-<file path=ppt/notesSlides/notesSlide11.xml><?xml version="1.0" encoding="utf-8"?>
-<p:notes xmlns:a="http://schemas.openxmlformats.org/drawingml/2006/main" xmlns:r="http://schemas.openxmlformats.org/officeDocument/2006/relationships" xmlns:p="http://schemas.openxmlformats.org/presentationml/2006/main">
-  <p:cSld>
-    <p:spTree>
-      <p:nvGrpSpPr>
-        <p:cNvPr id="1" name=""/>
-        <p:cNvGrpSpPr/>
-        <p:nvPr/>
-      </p:nvGrpSpPr>
-      <p:grpSpPr>
-        <a:xfrm>
-          <a:off x="0" y="0"/>
-          <a:ext cx="0" cy="0"/>
-          <a:chOff x="0" y="0"/>
-          <a:chExt cx="0" cy="0"/>
-        </a:xfrm>
-      </p:grpSpPr>
-      <p:sp>
-        <p:nvSpPr>
-          <p:cNvPr id="2" name="Slide Image Placeholder 1"/>
-          <p:cNvSpPr>
-            <a:spLocks noGrp="1" noRot="1" noChangeAspect="1"/>
-          </p:cNvSpPr>
-          <p:nvPr>
-            <p:ph type="sldImg"/>
-          </p:nvPr>
-        </p:nvSpPr>
-        <p:spPr/>
-      </p:sp>
-      <p:sp>
-        <p:nvSpPr>
-          <p:cNvPr id="3" name="Notes Placeholder 2"/>
-          <p:cNvSpPr>
-            <a:spLocks noGrp="1"/>
-          </p:cNvSpPr>
-          <p:nvPr>
-            <p:ph type="body" idx="1"/>
-          </p:nvPr>
-        </p:nvSpPr>
-        <p:spPr/>
-        <p:txBody>
-          <a:bodyPr/>
-          <a:lstStyle/>
-          <a:p>
-            <a:r>
-              <a:rPr lang="en-US" dirty="0"/>
-              <a:t>Do not claim a fixed seven-part ordering. What actually goes into the prompt
-depends on the coder, the model and the settings, and it changes between
-releases. The list above is the shape, not the wire format.
-Ask what the model would need in order to add priority consistently to the CLI,
-the task and the store. That question sets up the next two slides.</a:t>
-            </a:r>
-            <a:endParaRPr lang="en-US" dirty="0"/>
-          </a:p>
-        </p:txBody>
-      </p:sp>
-      <p:sp>
-        <p:nvSpPr>
-          <p:cNvPr id="4" name="Slide Number Placeholder 3"/>
-          <p:cNvSpPr>
-            <a:spLocks noGrp="1"/>
-          </p:cNvSpPr>
-          <p:nvPr>
-            <p:ph type="sldNum" sz="quarter" idx="10"/>
-          </p:nvPr>
-        </p:nvSpPr>
-        <p:spPr/>
-        <p:txBody>
-          <a:bodyPr/>
-          <a:lstStyle/>
-          <a:p>
-            <a:fld id="{F7021451-1387-4CA6-816F-3879F97B5CBC}" type="slidenum">
-              <a:rPr lang="en-US"/>
-              <a:t>11</a:t>
-            </a:fld>
-            <a:endParaRPr lang="en-US"/>
-          </a:p>
-        </p:txBody>
-      </p:sp>
-    </p:spTree>
-    <p:extLst>
-      <p:ext uri="{BB962C8B-B14F-4D97-AF65-F5344CB8AC3E}">
-        <p14:creationId xmlns:p14="http://schemas.microsoft.com/office/powerpoint/2010/main" val="1024086991"/>
-      </p:ext>
-    </p:extLst>
-  </p:cSld>
-  <p:clrMapOvr>
-    <a:masterClrMapping/>
-  </p:clrMapOvr>
-</p:notes>
-</file>
-
-<file path=ppt/notesSlides/notesSlide12.xml><?xml version="1.0" encoding="utf-8"?>
-<p:notes xmlns:a="http://schemas.openxmlformats.org/drawingml/2006/main" xmlns:r="http://schemas.openxmlformats.org/officeDocument/2006/relationships" xmlns:p="http://schemas.openxmlformats.org/presentationml/2006/main">
-  <p:cSld>
-    <p:spTree>
-      <p:nvGrpSpPr>
-        <p:cNvPr id="1" name=""/>
-        <p:cNvGrpSpPr/>
-        <p:nvPr/>
-      </p:nvGrpSpPr>
-      <p:grpSpPr>
-        <a:xfrm>
-          <a:off x="0" y="0"/>
-          <a:ext cx="0" cy="0"/>
-          <a:chOff x="0" y="0"/>
-          <a:chExt cx="0" cy="0"/>
-        </a:xfrm>
-      </p:grpSpPr>
-      <p:sp>
-        <p:nvSpPr>
-          <p:cNvPr id="2" name="Slide Image Placeholder 1"/>
-          <p:cNvSpPr>
-            <a:spLocks noGrp="1" noRot="1" noChangeAspect="1"/>
-          </p:cNvSpPr>
-          <p:nvPr>
-            <p:ph type="sldImg"/>
-          </p:nvPr>
-        </p:nvSpPr>
-        <p:spPr/>
-      </p:sp>
-      <p:sp>
-        <p:nvSpPr>
-          <p:cNvPr id="3" name="Notes Placeholder 2"/>
-          <p:cNvSpPr>
-            <a:spLocks noGrp="1"/>
-          </p:cNvSpPr>
-          <p:nvPr>
-            <p:ph type="body" idx="1"/>
-          </p:nvPr>
-        </p:nvSpPr>
-        <p:spPr/>
-        <p:txBody>
-          <a:bodyPr/>
-          <a:lstStyle/>
-          <a:p>
-            <a:r>
-              <a:rPr lang="en-US" dirty="0"/>
               <a:t>Walk through why these three files and not the whole package. This is one
 sensible selection, not a rule to add everything. Read-only context still
 costs budget. /tokens tells you what you are spending, and nothing about
@@ -843,7 +658,7 @@
           <a:p>
             <a:fld id="{F7021451-1387-4CA6-816F-3879F97B5CBC}" type="slidenum">
               <a:rPr lang="en-US"/>
-              <a:t>12</a:t>
+              <a:t>10</a:t>
             </a:fld>
             <a:endParaRPr lang="en-US"/>
           </a:p>
@@ -862,7 +677,7 @@
 </p:notes>
 </file>
 
-<file path=ppt/notesSlides/notesSlide13.xml><?xml version="1.0" encoding="utf-8"?>
+<file path=ppt/notesSlides/notesSlide11.xml><?xml version="1.0" encoding="utf-8"?>
 <p:notes xmlns:a="http://schemas.openxmlformats.org/drawingml/2006/main" xmlns:r="http://schemas.openxmlformats.org/officeDocument/2006/relationships" xmlns:p="http://schemas.openxmlformats.org/presentationml/2006/main">
   <p:cSld>
     <p:spTree>
@@ -911,7 +726,10 @@
               <a:t>The excerpt is illustrative. Do not promise the map contains every file, and do
 not use its silence as proof that a dependency is absent. When a student says
 "the model should have known," check whether they added the file or only let the
-map mention it. Source: https://aider.chat/docs/repomap.html</a:t>
+map mention it. Source: https://aider.chat/docs/repomap.html
+Cut from the slide and worth saying: a signature tells you where to look, it
+does not tell the model how the function works. Students read a map line as
+evidence the model understands the function.</a:t>
             </a:r>
             <a:endParaRPr lang="en-US" dirty="0"/>
           </a:p>
@@ -934,7 +752,7 @@
           <a:p>
             <a:fld id="{F7021451-1387-4CA6-816F-3879F97B5CBC}" type="slidenum">
               <a:rPr lang="en-US"/>
-              <a:t>13</a:t>
+              <a:t>11</a:t>
             </a:fld>
             <a:endParaRPr lang="en-US"/>
           </a:p>
@@ -953,7 +771,7 @@
 </p:notes>
 </file>
 
-<file path=ppt/notesSlides/notesSlide14.xml><?xml version="1.0" encoding="utf-8"?>
+<file path=ppt/notesSlides/notesSlide12.xml><?xml version="1.0" encoding="utf-8"?>
 <p:notes xmlns:a="http://schemas.openxmlformats.org/drawingml/2006/main" xmlns:r="http://schemas.openxmlformats.org/officeDocument/2006/relationships" xmlns:p="http://schemas.openxmlformats.org/presentationml/2006/main">
   <p:cSld>
     <p:spTree>
@@ -1025,7 +843,7 @@
           <a:p>
             <a:fld id="{F7021451-1387-4CA6-816F-3879F97B5CBC}" type="slidenum">
               <a:rPr lang="en-US"/>
-              <a:t>14</a:t>
+              <a:t>12</a:t>
             </a:fld>
             <a:endParaRPr lang="en-US"/>
           </a:p>
@@ -1044,7 +862,7 @@
 </p:notes>
 </file>
 
-<file path=ppt/notesSlides/notesSlide15.xml><?xml version="1.0" encoding="utf-8"?>
+<file path=ppt/notesSlides/notesSlide13.xml><?xml version="1.0" encoding="utf-8"?>
 <p:notes xmlns:a="http://schemas.openxmlformats.org/drawingml/2006/main" xmlns:r="http://schemas.openxmlformats.org/officeDocument/2006/relationships" xmlns:p="http://schemas.openxmlformats.org/presentationml/2006/main">
   <p:cSld>
     <p:spTree>
@@ -1116,7 +934,7 @@
           <a:p>
             <a:fld id="{F7021451-1387-4CA6-816F-3879F97B5CBC}" type="slidenum">
               <a:rPr lang="en-US"/>
-              <a:t>15</a:t>
+              <a:t>13</a:t>
             </a:fld>
             <a:endParaRPr lang="en-US"/>
           </a:p>
@@ -1135,7 +953,7 @@
 </p:notes>
 </file>
 
-<file path=ppt/notesSlides/notesSlide16.xml><?xml version="1.0" encoding="utf-8"?>
+<file path=ppt/notesSlides/notesSlide14.xml><?xml version="1.0" encoding="utf-8"?>
 <p:notes xmlns:a="http://schemas.openxmlformats.org/drawingml/2006/main" xmlns:r="http://schemas.openxmlformats.org/officeDocument/2006/relationships" xmlns:p="http://schemas.openxmlformats.org/presentationml/2006/main">
   <p:cSld>
     <p:spTree>
@@ -1206,7 +1024,7 @@
           <a:p>
             <a:fld id="{F7021451-1387-4CA6-816F-3879F97B5CBC}" type="slidenum">
               <a:rPr lang="en-US"/>
-              <a:t>16</a:t>
+              <a:t>14</a:t>
             </a:fld>
             <a:endParaRPr lang="en-US"/>
           </a:p>
@@ -1225,7 +1043,7 @@
 </p:notes>
 </file>
 
-<file path=ppt/notesSlides/notesSlide17.xml><?xml version="1.0" encoding="utf-8"?>
+<file path=ppt/notesSlides/notesSlide15.xml><?xml version="1.0" encoding="utf-8"?>
 <p:notes xmlns:a="http://schemas.openxmlformats.org/drawingml/2006/main" xmlns:r="http://schemas.openxmlformats.org/officeDocument/2006/relationships" xmlns:p="http://schemas.openxmlformats.org/presentationml/2006/main">
   <p:cSld>
     <p:spTree>
@@ -1275,7 +1093,10 @@
 Partial application is not untestable, it is testable against a different
 contract. Do not tell them one policy is the only defensible one. The stricter
 rule is here because it makes the state after a failure trivial to state and
-to assert.</a:t>
+to assert.
+Cut from the slide: Aider itself can fall back to looser matching and can keep
+the blocks that did apply. Their Stage 1 contract does neither, and that is the
+contrast worth drawing out loud.</a:t>
             </a:r>
             <a:endParaRPr lang="en-US" dirty="0"/>
           </a:p>
@@ -1298,7 +1119,7 @@
           <a:p>
             <a:fld id="{F7021451-1387-4CA6-816F-3879F97B5CBC}" type="slidenum">
               <a:rPr lang="en-US"/>
-              <a:t>17</a:t>
+              <a:t>15</a:t>
             </a:fld>
             <a:endParaRPr lang="en-US"/>
           </a:p>
@@ -1317,7 +1138,7 @@
 </p:notes>
 </file>
 
-<file path=ppt/notesSlides/notesSlide18.xml><?xml version="1.0" encoding="utf-8"?>
+<file path=ppt/notesSlides/notesSlide16.xml><?xml version="1.0" encoding="utf-8"?>
 <p:notes xmlns:a="http://schemas.openxmlformats.org/drawingml/2006/main" xmlns:r="http://schemas.openxmlformats.org/officeDocument/2006/relationships" xmlns:p="http://schemas.openxmlformats.org/presentationml/2006/main">
   <p:cSld>
     <p:spTree>
@@ -1390,7 +1211,7 @@
           <a:p>
             <a:fld id="{F7021451-1387-4CA6-816F-3879F97B5CBC}" type="slidenum">
               <a:rPr lang="en-US"/>
-              <a:t>18</a:t>
+              <a:t>16</a:t>
             </a:fld>
             <a:endParaRPr lang="en-US"/>
           </a:p>
@@ -1409,7 +1230,7 @@
 </p:notes>
 </file>
 
-<file path=ppt/notesSlides/notesSlide19.xml><?xml version="1.0" encoding="utf-8"?>
+<file path=ppt/notesSlides/notesSlide17.xml><?xml version="1.0" encoding="utf-8"?>
 <p:notes xmlns:a="http://schemas.openxmlformats.org/drawingml/2006/main" xmlns:r="http://schemas.openxmlformats.org/officeDocument/2006/relationships" xmlns:p="http://schemas.openxmlformats.org/presentationml/2006/main">
   <p:cSld>
     <p:spTree>
@@ -1460,7 +1281,188 @@
 disposable and clean, so an owned HEAD commit can be undone safely. A human
 commit on top, or a dirty tree, means their tool has to refuse.
 Running shell commands arrives in the Analyze phase and brings consequences git
-cannot undo.</a:t>
+cannot undo.
+Undo means resetting to the parent of a commit their own session created. It
+will not touch a commit someone else made, which is the guard in "guarded undo".</a:t>
+            </a:r>
+            <a:endParaRPr lang="en-US" dirty="0"/>
+          </a:p>
+        </p:txBody>
+      </p:sp>
+      <p:sp>
+        <p:nvSpPr>
+          <p:cNvPr id="4" name="Slide Number Placeholder 3"/>
+          <p:cNvSpPr>
+            <a:spLocks noGrp="1"/>
+          </p:cNvSpPr>
+          <p:nvPr>
+            <p:ph type="sldNum" sz="quarter" idx="10"/>
+          </p:nvPr>
+        </p:nvSpPr>
+        <p:spPr/>
+        <p:txBody>
+          <a:bodyPr/>
+          <a:lstStyle/>
+          <a:p>
+            <a:fld id="{F7021451-1387-4CA6-816F-3879F97B5CBC}" type="slidenum">
+              <a:rPr lang="en-US"/>
+              <a:t>17</a:t>
+            </a:fld>
+            <a:endParaRPr lang="en-US"/>
+          </a:p>
+        </p:txBody>
+      </p:sp>
+    </p:spTree>
+    <p:extLst>
+      <p:ext uri="{BB962C8B-B14F-4D97-AF65-F5344CB8AC3E}">
+        <p14:creationId xmlns:p14="http://schemas.microsoft.com/office/powerpoint/2010/main" val="1024086991"/>
+      </p:ext>
+    </p:extLst>
+  </p:cSld>
+  <p:clrMapOvr>
+    <a:masterClrMapping/>
+  </p:clrMapOvr>
+</p:notes>
+</file>
+
+<file path=ppt/notesSlides/notesSlide18.xml><?xml version="1.0" encoding="utf-8"?>
+<p:notes xmlns:a="http://schemas.openxmlformats.org/drawingml/2006/main" xmlns:r="http://schemas.openxmlformats.org/officeDocument/2006/relationships" xmlns:p="http://schemas.openxmlformats.org/presentationml/2006/main">
+  <p:cSld>
+    <p:spTree>
+      <p:nvGrpSpPr>
+        <p:cNvPr id="1" name=""/>
+        <p:cNvGrpSpPr/>
+        <p:nvPr/>
+      </p:nvGrpSpPr>
+      <p:grpSpPr>
+        <a:xfrm>
+          <a:off x="0" y="0"/>
+          <a:ext cx="0" cy="0"/>
+          <a:chOff x="0" y="0"/>
+          <a:chExt cx="0" cy="0"/>
+        </a:xfrm>
+      </p:grpSpPr>
+      <p:sp>
+        <p:nvSpPr>
+          <p:cNvPr id="2" name="Slide Image Placeholder 1"/>
+          <p:cNvSpPr>
+            <a:spLocks noGrp="1" noRot="1" noChangeAspect="1"/>
+          </p:cNvSpPr>
+          <p:nvPr>
+            <p:ph type="sldImg"/>
+          </p:nvPr>
+        </p:nvSpPr>
+        <p:spPr/>
+      </p:sp>
+      <p:sp>
+        <p:nvSpPr>
+          <p:cNvPr id="3" name="Notes Placeholder 2"/>
+          <p:cNvSpPr>
+            <a:spLocks noGrp="1"/>
+          </p:cNvSpPr>
+          <p:nvPr>
+            <p:ph type="body" idx="1"/>
+          </p:nvPr>
+        </p:nvSpPr>
+        <p:spPr/>
+        <p:txBody>
+          <a:bodyPr/>
+          <a:lstStyle/>
+          <a:p>
+            <a:r>
+              <a:rPr lang="en-US" dirty="0"/>
+              <a:t>Pairs for two minutes, then take two answers. You are listening for the missing
+storage write or the missing persistence test. Do not reward naming a source
+file inside aider.</a:t>
+            </a:r>
+            <a:endParaRPr lang="en-US" dirty="0"/>
+          </a:p>
+        </p:txBody>
+      </p:sp>
+      <p:sp>
+        <p:nvSpPr>
+          <p:cNvPr id="4" name="Slide Number Placeholder 3"/>
+          <p:cNvSpPr>
+            <a:spLocks noGrp="1"/>
+          </p:cNvSpPr>
+          <p:nvPr>
+            <p:ph type="sldNum" sz="quarter" idx="10"/>
+          </p:nvPr>
+        </p:nvSpPr>
+        <p:spPr/>
+        <p:txBody>
+          <a:bodyPr/>
+          <a:lstStyle/>
+          <a:p>
+            <a:fld id="{F7021451-1387-4CA6-816F-3879F97B5CBC}" type="slidenum">
+              <a:rPr lang="en-US"/>
+              <a:t>18</a:t>
+            </a:fld>
+            <a:endParaRPr lang="en-US"/>
+          </a:p>
+        </p:txBody>
+      </p:sp>
+    </p:spTree>
+    <p:extLst>
+      <p:ext uri="{BB962C8B-B14F-4D97-AF65-F5344CB8AC3E}">
+        <p14:creationId xmlns:p14="http://schemas.microsoft.com/office/powerpoint/2010/main" val="1024086991"/>
+      </p:ext>
+    </p:extLst>
+  </p:cSld>
+  <p:clrMapOvr>
+    <a:masterClrMapping/>
+  </p:clrMapOvr>
+</p:notes>
+</file>
+
+<file path=ppt/notesSlides/notesSlide19.xml><?xml version="1.0" encoding="utf-8"?>
+<p:notes xmlns:a="http://schemas.openxmlformats.org/drawingml/2006/main" xmlns:r="http://schemas.openxmlformats.org/officeDocument/2006/relationships" xmlns:p="http://schemas.openxmlformats.org/presentationml/2006/main">
+  <p:cSld>
+    <p:spTree>
+      <p:nvGrpSpPr>
+        <p:cNvPr id="1" name=""/>
+        <p:cNvGrpSpPr/>
+        <p:nvPr/>
+      </p:nvGrpSpPr>
+      <p:grpSpPr>
+        <a:xfrm>
+          <a:off x="0" y="0"/>
+          <a:ext cx="0" cy="0"/>
+          <a:chOff x="0" y="0"/>
+          <a:chExt cx="0" cy="0"/>
+        </a:xfrm>
+      </p:grpSpPr>
+      <p:sp>
+        <p:nvSpPr>
+          <p:cNvPr id="2" name="Slide Image Placeholder 1"/>
+          <p:cNvSpPr>
+            <a:spLocks noGrp="1" noRot="1" noChangeAspect="1"/>
+          </p:cNvSpPr>
+          <p:nvPr>
+            <p:ph type="sldImg"/>
+          </p:nvPr>
+        </p:nvSpPr>
+        <p:spPr/>
+      </p:sp>
+      <p:sp>
+        <p:nvSpPr>
+          <p:cNvPr id="3" name="Notes Placeholder 2"/>
+          <p:cNvSpPr>
+            <a:spLocks noGrp="1"/>
+          </p:cNvSpPr>
+          <p:nvPr>
+            <p:ph type="body" idx="1"/>
+          </p:nvPr>
+        </p:nvSpPr>
+        <p:spPr/>
+        <p:txBody>
+          <a:bodyPr/>
+          <a:lstStyle/>
+          <a:p>
+            <a:r>
+              <a:rPr lang="en-US" dirty="0"/>
+              <a:t>Ten minutes. The habit to build: a symptom is evidence about which of the three
+levers is wrong, and re-running the same prompt tests nothing.</a:t>
             </a:r>
             <a:endParaRPr lang="en-US" dirty="0"/>
           </a:p>
@@ -1643,9 +1645,9 @@
           <a:p>
             <a:r>
               <a:rPr lang="en-US" dirty="0"/>
-              <a:t>Pairs for two minutes, then take two answers. You are listening for the missing
-storage write or the missing persistence test. Do not reward naming a source
-file inside aider.</a:t>
+              <a:t>Push back on "the model is too weak" every time it comes up today. Ask what
+observation would distinguish a weak model from a missing file, and make them
+answer before they change models.</a:t>
             </a:r>
             <a:endParaRPr lang="en-US" dirty="0"/>
           </a:p>
@@ -1688,185 +1690,6 @@
 </file>
 
 <file path=ppt/notesSlides/notesSlide21.xml><?xml version="1.0" encoding="utf-8"?>
-<p:notes xmlns:a="http://schemas.openxmlformats.org/drawingml/2006/main" xmlns:r="http://schemas.openxmlformats.org/officeDocument/2006/relationships" xmlns:p="http://schemas.openxmlformats.org/presentationml/2006/main">
-  <p:cSld>
-    <p:spTree>
-      <p:nvGrpSpPr>
-        <p:cNvPr id="1" name=""/>
-        <p:cNvGrpSpPr/>
-        <p:nvPr/>
-      </p:nvGrpSpPr>
-      <p:grpSpPr>
-        <a:xfrm>
-          <a:off x="0" y="0"/>
-          <a:ext cx="0" cy="0"/>
-          <a:chOff x="0" y="0"/>
-          <a:chExt cx="0" cy="0"/>
-        </a:xfrm>
-      </p:grpSpPr>
-      <p:sp>
-        <p:nvSpPr>
-          <p:cNvPr id="2" name="Slide Image Placeholder 1"/>
-          <p:cNvSpPr>
-            <a:spLocks noGrp="1" noRot="1" noChangeAspect="1"/>
-          </p:cNvSpPr>
-          <p:nvPr>
-            <p:ph type="sldImg"/>
-          </p:nvPr>
-        </p:nvSpPr>
-        <p:spPr/>
-      </p:sp>
-      <p:sp>
-        <p:nvSpPr>
-          <p:cNvPr id="3" name="Notes Placeholder 2"/>
-          <p:cNvSpPr>
-            <a:spLocks noGrp="1"/>
-          </p:cNvSpPr>
-          <p:nvPr>
-            <p:ph type="body" idx="1"/>
-          </p:nvPr>
-        </p:nvSpPr>
-        <p:spPr/>
-        <p:txBody>
-          <a:bodyPr/>
-          <a:lstStyle/>
-          <a:p>
-            <a:r>
-              <a:rPr lang="en-US" dirty="0"/>
-              <a:t>Ten minutes. The habit to build: a symptom is evidence about which of the three
-levers is wrong, and re-running the same prompt tests nothing.</a:t>
-            </a:r>
-            <a:endParaRPr lang="en-US" dirty="0"/>
-          </a:p>
-        </p:txBody>
-      </p:sp>
-      <p:sp>
-        <p:nvSpPr>
-          <p:cNvPr id="4" name="Slide Number Placeholder 3"/>
-          <p:cNvSpPr>
-            <a:spLocks noGrp="1"/>
-          </p:cNvSpPr>
-          <p:nvPr>
-            <p:ph type="sldNum" sz="quarter" idx="10"/>
-          </p:nvPr>
-        </p:nvSpPr>
-        <p:spPr/>
-        <p:txBody>
-          <a:bodyPr/>
-          <a:lstStyle/>
-          <a:p>
-            <a:fld id="{F7021451-1387-4CA6-816F-3879F97B5CBC}" type="slidenum">
-              <a:rPr lang="en-US"/>
-              <a:t>21</a:t>
-            </a:fld>
-            <a:endParaRPr lang="en-US"/>
-          </a:p>
-        </p:txBody>
-      </p:sp>
-    </p:spTree>
-    <p:extLst>
-      <p:ext uri="{BB962C8B-B14F-4D97-AF65-F5344CB8AC3E}">
-        <p14:creationId xmlns:p14="http://schemas.microsoft.com/office/powerpoint/2010/main" val="1024086991"/>
-      </p:ext>
-    </p:extLst>
-  </p:cSld>
-  <p:clrMapOvr>
-    <a:masterClrMapping/>
-  </p:clrMapOvr>
-</p:notes>
-</file>
-
-<file path=ppt/notesSlides/notesSlide22.xml><?xml version="1.0" encoding="utf-8"?>
-<p:notes xmlns:a="http://schemas.openxmlformats.org/drawingml/2006/main" xmlns:r="http://schemas.openxmlformats.org/officeDocument/2006/relationships" xmlns:p="http://schemas.openxmlformats.org/presentationml/2006/main">
-  <p:cSld>
-    <p:spTree>
-      <p:nvGrpSpPr>
-        <p:cNvPr id="1" name=""/>
-        <p:cNvGrpSpPr/>
-        <p:nvPr/>
-      </p:nvGrpSpPr>
-      <p:grpSpPr>
-        <a:xfrm>
-          <a:off x="0" y="0"/>
-          <a:ext cx="0" cy="0"/>
-          <a:chOff x="0" y="0"/>
-          <a:chExt cx="0" cy="0"/>
-        </a:xfrm>
-      </p:grpSpPr>
-      <p:sp>
-        <p:nvSpPr>
-          <p:cNvPr id="2" name="Slide Image Placeholder 1"/>
-          <p:cNvSpPr>
-            <a:spLocks noGrp="1" noRot="1" noChangeAspect="1"/>
-          </p:cNvSpPr>
-          <p:nvPr>
-            <p:ph type="sldImg"/>
-          </p:nvPr>
-        </p:nvSpPr>
-        <p:spPr/>
-      </p:sp>
-      <p:sp>
-        <p:nvSpPr>
-          <p:cNvPr id="3" name="Notes Placeholder 2"/>
-          <p:cNvSpPr>
-            <a:spLocks noGrp="1"/>
-          </p:cNvSpPr>
-          <p:nvPr>
-            <p:ph type="body" idx="1"/>
-          </p:nvPr>
-        </p:nvSpPr>
-        <p:spPr/>
-        <p:txBody>
-          <a:bodyPr/>
-          <a:lstStyle/>
-          <a:p>
-            <a:r>
-              <a:rPr lang="en-US" dirty="0"/>
-              <a:t>Push back on "the model is too weak" every time it comes up today. Ask what
-observation would distinguish a weak model from a missing file, and make them
-answer before they change models.</a:t>
-            </a:r>
-            <a:endParaRPr lang="en-US" dirty="0"/>
-          </a:p>
-        </p:txBody>
-      </p:sp>
-      <p:sp>
-        <p:nvSpPr>
-          <p:cNvPr id="4" name="Slide Number Placeholder 3"/>
-          <p:cNvSpPr>
-            <a:spLocks noGrp="1"/>
-          </p:cNvSpPr>
-          <p:nvPr>
-            <p:ph type="sldNum" sz="quarter" idx="10"/>
-          </p:nvPr>
-        </p:nvSpPr>
-        <p:spPr/>
-        <p:txBody>
-          <a:bodyPr/>
-          <a:lstStyle/>
-          <a:p>
-            <a:fld id="{F7021451-1387-4CA6-816F-3879F97B5CBC}" type="slidenum">
-              <a:rPr lang="en-US"/>
-              <a:t>22</a:t>
-            </a:fld>
-            <a:endParaRPr lang="en-US"/>
-          </a:p>
-        </p:txBody>
-      </p:sp>
-    </p:spTree>
-    <p:extLst>
-      <p:ext uri="{BB962C8B-B14F-4D97-AF65-F5344CB8AC3E}">
-        <p14:creationId xmlns:p14="http://schemas.microsoft.com/office/powerpoint/2010/main" val="1024086991"/>
-      </p:ext>
-    </p:extLst>
-  </p:cSld>
-  <p:clrMapOvr>
-    <a:masterClrMapping/>
-  </p:clrMapOvr>
-</p:notes>
-</file>
-
-<file path=ppt/notesSlides/notesSlide23.xml><?xml version="1.0" encoding="utf-8"?>
 <p:notes xmlns:a="http://schemas.openxmlformats.org/drawingml/2006/main" xmlns:r="http://schemas.openxmlformats.org/officeDocument/2006/relationships" xmlns:p="http://schemas.openxmlformats.org/presentationml/2006/main">
   <p:cSld>
     <p:spTree>
@@ -1937,7 +1760,7 @@
           <a:p>
             <a:fld id="{F7021451-1387-4CA6-816F-3879F97B5CBC}" type="slidenum">
               <a:rPr lang="en-US"/>
-              <a:t>23</a:t>
+              <a:t>21</a:t>
             </a:fld>
             <a:endParaRPr lang="en-US"/>
           </a:p>
@@ -1956,7 +1779,7 @@
 </p:notes>
 </file>
 
-<file path=ppt/notesSlides/notesSlide24.xml><?xml version="1.0" encoding="utf-8"?>
+<file path=ppt/notesSlides/notesSlide22.xml><?xml version="1.0" encoding="utf-8"?>
 <p:notes xmlns:a="http://schemas.openxmlformats.org/drawingml/2006/main" xmlns:r="http://schemas.openxmlformats.org/officeDocument/2006/relationships" xmlns:p="http://schemas.openxmlformats.org/presentationml/2006/main">
   <p:cSld>
     <p:spTree>
@@ -2005,7 +1828,10 @@
               <a:t>Four minutes in pairs, two for answers. A persistence round trip is the answer
 you are hoping for: write it, restart, read it back.
 Watch for the two reflexes you want to break. Adding every file in the package
-is not diagnosis, and switching models is not diagnosis.</a:t>
+is not diagnosis, and switching models is not diagnosis.
+The exercise, which is no longer written on the slide: write the acceptance
+criterion that was missing, and the test that would have caught it. Say it
+twice; it is the whole point of the six minutes.</a:t>
             </a:r>
             <a:endParaRPr lang="en-US" dirty="0"/>
           </a:p>
@@ -2028,7 +1854,7 @@
           <a:p>
             <a:fld id="{F7021451-1387-4CA6-816F-3879F97B5CBC}" type="slidenum">
               <a:rPr lang="en-US"/>
-              <a:t>24</a:t>
+              <a:t>22</a:t>
             </a:fld>
             <a:endParaRPr lang="en-US"/>
           </a:p>
@@ -2047,7 +1873,7 @@
 </p:notes>
 </file>
 
-<file path=ppt/notesSlides/notesSlide25.xml><?xml version="1.0" encoding="utf-8"?>
+<file path=ppt/notesSlides/notesSlide23.xml><?xml version="1.0" encoding="utf-8"?>
 <p:notes xmlns:a="http://schemas.openxmlformats.org/drawingml/2006/main" xmlns:r="http://schemas.openxmlformats.org/officeDocument/2006/relationships" xmlns:p="http://schemas.openxmlformats.org/presentationml/2006/main">
   <p:cSld>
     <p:spTree>
@@ -2121,7 +1947,7 @@
           <a:p>
             <a:fld id="{F7021451-1387-4CA6-816F-3879F97B5CBC}" type="slidenum">
               <a:rPr lang="en-US"/>
-              <a:t>25</a:t>
+              <a:t>23</a:t>
             </a:fld>
             <a:endParaRPr lang="en-US"/>
           </a:p>
@@ -2140,7 +1966,7 @@
 </p:notes>
 </file>
 
-<file path=ppt/notesSlides/notesSlide26.xml><?xml version="1.0" encoding="utf-8"?>
+<file path=ppt/notesSlides/notesSlide24.xml><?xml version="1.0" encoding="utf-8"?>
 <p:notes xmlns:a="http://schemas.openxmlformats.org/drawingml/2006/main" xmlns:r="http://schemas.openxmlformats.org/officeDocument/2006/relationships" xmlns:p="http://schemas.openxmlformats.org/presentationml/2006/main">
   <p:cSld>
     <p:spTree>
@@ -2210,7 +2036,7 @@
           <a:p>
             <a:fld id="{F7021451-1387-4CA6-816F-3879F97B5CBC}" type="slidenum">
               <a:rPr lang="en-US"/>
-              <a:t>26</a:t>
+              <a:t>24</a:t>
             </a:fld>
             <a:endParaRPr lang="en-US"/>
           </a:p>
@@ -2229,7 +2055,7 @@
 </p:notes>
 </file>
 
-<file path=ppt/notesSlides/notesSlide27.xml><?xml version="1.0" encoding="utf-8"?>
+<file path=ppt/notesSlides/notesSlide25.xml><?xml version="1.0" encoding="utf-8"?>
 <p:notes xmlns:a="http://schemas.openxmlformats.org/drawingml/2006/main" xmlns:r="http://schemas.openxmlformats.org/officeDocument/2006/relationships" xmlns:p="http://schemas.openxmlformats.org/presentationml/2006/main">
   <p:cSld>
     <p:spTree>
@@ -2275,11 +2101,15 @@
           <a:p>
             <a:r>
               <a:rPr lang="en-US" dirty="0"/>
-              <a:t>This is the slide that answers the question every student is holding. No
-starter application, no supplied session module, no TOML to edit, no two
-prescribed specs.
+              <a:t>This is the slide that answers the question every student is holding: no
+starter application and no supplied session module.
+Point at CHECKLIST.md by name and say it is the submission list, so nobody
+reconstructs one from these slides. GLOSSARY.md is where a word has a Stage 1
+meaning that differs from its everyday one, and that meaning is the graded one.
 They implement the endpoint client in Stage 1 and extend it for function
-calling in Analyze.</a:t>
+calling in Analyze.
+Say the division out loud, since the slide no longer carries it: they run
+`aider` to build the thing, and they write `bin/assistant` as the thing.</a:t>
             </a:r>
             <a:endParaRPr lang="en-US" dirty="0"/>
           </a:p>
@@ -2302,7 +2132,7 @@
           <a:p>
             <a:fld id="{F7021451-1387-4CA6-816F-3879F97B5CBC}" type="slidenum">
               <a:rPr lang="en-US"/>
-              <a:t>27</a:t>
+              <a:t>25</a:t>
             </a:fld>
             <a:endParaRPr lang="en-US"/>
           </a:p>
@@ -2321,7 +2151,7 @@
 </p:notes>
 </file>
 
-<file path=ppt/notesSlides/notesSlide28.xml><?xml version="1.0" encoding="utf-8"?>
+<file path=ppt/notesSlides/notesSlide26.xml><?xml version="1.0" encoding="utf-8"?>
 <p:notes xmlns:a="http://schemas.openxmlformats.org/drawingml/2006/main" xmlns:r="http://schemas.openxmlformats.org/officeDocument/2006/relationships" xmlns:p="http://schemas.openxmlformats.org/presentationml/2006/main">
   <p:cSld>
     <p:spTree>
@@ -2395,7 +2225,7 @@
           <a:p>
             <a:fld id="{F7021451-1387-4CA6-816F-3879F97B5CBC}" type="slidenum">
               <a:rPr lang="en-US"/>
-              <a:t>28</a:t>
+              <a:t>26</a:t>
             </a:fld>
             <a:endParaRPr lang="en-US"/>
           </a:p>
@@ -2414,7 +2244,7 @@
 </p:notes>
 </file>
 
-<file path=ppt/notesSlides/notesSlide29.xml><?xml version="1.0" encoding="utf-8"?>
+<file path=ppt/notesSlides/notesSlide27.xml><?xml version="1.0" encoding="utf-8"?>
 <p:notes xmlns:a="http://schemas.openxmlformats.org/drawingml/2006/main" xmlns:r="http://schemas.openxmlformats.org/officeDocument/2006/relationships" xmlns:p="http://schemas.openxmlformats.org/presentationml/2006/main">
   <p:cSld>
     <p:spTree>
@@ -2487,7 +2317,7 @@
           <a:p>
             <a:fld id="{F7021451-1387-4CA6-816F-3879F97B5CBC}" type="slidenum">
               <a:rPr lang="en-US"/>
-              <a:t>29</a:t>
+              <a:t>27</a:t>
             </a:fld>
             <a:endParaRPr lang="en-US"/>
           </a:p>
@@ -2506,7 +2336,7 @@
 </p:notes>
 </file>
 
-<file path=ppt/notesSlides/notesSlide3.xml><?xml version="1.0" encoding="utf-8"?>
+<file path=ppt/notesSlides/notesSlide28.xml><?xml version="1.0" encoding="utf-8"?>
 <p:notes xmlns:a="http://schemas.openxmlformats.org/drawingml/2006/main" xmlns:r="http://schemas.openxmlformats.org/officeDocument/2006/relationships" xmlns:p="http://schemas.openxmlformats.org/presentationml/2006/main">
   <p:cSld>
     <p:spTree>
@@ -2552,11 +2382,11 @@
           <a:p>
             <a:r>
               <a:rPr lang="en-US" dirty="0"/>
-              <a:t>Two weeks of practice lessons have given them the muscle memory and none of the
-model. This is the slide that names the thing.
-The three cards are the six steps in summary, so do not elaborate here. The
-point to land is the last one: it is a program on their machine, which is why
-they can read its behavior, and why they are about to write one.</a:t>
+              <a:t>Configuration and lifecycle are not a hidden eighth feature, and there is no
+scope cut this term. Where they score, from RUBRIC.md: configuration sits
+inside F1's four points and is not a gate, so unfinished configuration does not
+zero the rest of F1. The lifecycle commands score separately, under Operating
+instructions in the evidence group. Every edge case is in SPEC.md.</a:t>
             </a:r>
             <a:endParaRPr lang="en-US" dirty="0"/>
           </a:p>
@@ -2579,7 +2409,7 @@
           <a:p>
             <a:fld id="{F7021451-1387-4CA6-816F-3879F97B5CBC}" type="slidenum">
               <a:rPr lang="en-US"/>
-              <a:t>3</a:t>
+              <a:t>28</a:t>
             </a:fld>
             <a:endParaRPr lang="en-US"/>
           </a:p>
@@ -2598,96 +2428,7 @@
 </p:notes>
 </file>
 
-<file path=ppt/notesSlides/notesSlide30.xml><?xml version="1.0" encoding="utf-8"?>
-<p:notes xmlns:a="http://schemas.openxmlformats.org/drawingml/2006/main" xmlns:r="http://schemas.openxmlformats.org/officeDocument/2006/relationships" xmlns:p="http://schemas.openxmlformats.org/presentationml/2006/main">
-  <p:cSld>
-    <p:spTree>
-      <p:nvGrpSpPr>
-        <p:cNvPr id="1" name=""/>
-        <p:cNvGrpSpPr/>
-        <p:nvPr/>
-      </p:nvGrpSpPr>
-      <p:grpSpPr>
-        <a:xfrm>
-          <a:off x="0" y="0"/>
-          <a:ext cx="0" cy="0"/>
-          <a:chOff x="0" y="0"/>
-          <a:chExt cx="0" cy="0"/>
-        </a:xfrm>
-      </p:grpSpPr>
-      <p:sp>
-        <p:nvSpPr>
-          <p:cNvPr id="2" name="Slide Image Placeholder 1"/>
-          <p:cNvSpPr>
-            <a:spLocks noGrp="1" noRot="1" noChangeAspect="1"/>
-          </p:cNvSpPr>
-          <p:nvPr>
-            <p:ph type="sldImg"/>
-          </p:nvPr>
-        </p:nvSpPr>
-        <p:spPr/>
-      </p:sp>
-      <p:sp>
-        <p:nvSpPr>
-          <p:cNvPr id="3" name="Notes Placeholder 2"/>
-          <p:cNvSpPr>
-            <a:spLocks noGrp="1"/>
-          </p:cNvSpPr>
-          <p:nvPr>
-            <p:ph type="body" idx="1"/>
-          </p:nvPr>
-        </p:nvSpPr>
-        <p:spPr/>
-        <p:txBody>
-          <a:bodyPr/>
-          <a:lstStyle/>
-          <a:p>
-            <a:r>
-              <a:rPr lang="en-US" dirty="0"/>
-              <a:t>Configuration and lifecycle run across all seven. They are not a hidden eighth
-feature and there is no scope cut this term. Every edge case is in SPEC.md.</a:t>
-            </a:r>
-            <a:endParaRPr lang="en-US" dirty="0"/>
-          </a:p>
-        </p:txBody>
-      </p:sp>
-      <p:sp>
-        <p:nvSpPr>
-          <p:cNvPr id="4" name="Slide Number Placeholder 3"/>
-          <p:cNvSpPr>
-            <a:spLocks noGrp="1"/>
-          </p:cNvSpPr>
-          <p:nvPr>
-            <p:ph type="sldNum" sz="quarter" idx="10"/>
-          </p:nvPr>
-        </p:nvSpPr>
-        <p:spPr/>
-        <p:txBody>
-          <a:bodyPr/>
-          <a:lstStyle/>
-          <a:p>
-            <a:fld id="{F7021451-1387-4CA6-816F-3879F97B5CBC}" type="slidenum">
-              <a:rPr lang="en-US"/>
-              <a:t>30</a:t>
-            </a:fld>
-            <a:endParaRPr lang="en-US"/>
-          </a:p>
-        </p:txBody>
-      </p:sp>
-    </p:spTree>
-    <p:extLst>
-      <p:ext uri="{BB962C8B-B14F-4D97-AF65-F5344CB8AC3E}">
-        <p14:creationId xmlns:p14="http://schemas.microsoft.com/office/powerpoint/2010/main" val="1024086991"/>
-      </p:ext>
-    </p:extLst>
-  </p:cSld>
-  <p:clrMapOvr>
-    <a:masterClrMapping/>
-  </p:clrMapOvr>
-</p:notes>
-</file>
-
-<file path=ppt/notesSlides/notesSlide31.xml><?xml version="1.0" encoding="utf-8"?>
+<file path=ppt/notesSlides/notesSlide29.xml><?xml version="1.0" encoding="utf-8"?>
 <p:notes xmlns:a="http://schemas.openxmlformats.org/drawingml/2006/main" xmlns:r="http://schemas.openxmlformats.org/officeDocument/2006/relationships" xmlns:p="http://schemas.openxmlformats.org/presentationml/2006/main">
   <p:cSld>
     <p:spTree>
@@ -2763,7 +2504,7 @@
           <a:p>
             <a:fld id="{F7021451-1387-4CA6-816F-3879F97B5CBC}" type="slidenum">
               <a:rPr lang="en-US"/>
-              <a:t>31</a:t>
+              <a:t>29</a:t>
             </a:fld>
             <a:endParaRPr lang="en-US"/>
           </a:p>
@@ -2782,7 +2523,102 @@
 </p:notes>
 </file>
 
-<file path=ppt/notesSlides/notesSlide32.xml><?xml version="1.0" encoding="utf-8"?>
+<file path=ppt/notesSlides/notesSlide3.xml><?xml version="1.0" encoding="utf-8"?>
+<p:notes xmlns:a="http://schemas.openxmlformats.org/drawingml/2006/main" xmlns:r="http://schemas.openxmlformats.org/officeDocument/2006/relationships" xmlns:p="http://schemas.openxmlformats.org/presentationml/2006/main">
+  <p:cSld>
+    <p:spTree>
+      <p:nvGrpSpPr>
+        <p:cNvPr id="1" name=""/>
+        <p:cNvGrpSpPr/>
+        <p:nvPr/>
+      </p:nvGrpSpPr>
+      <p:grpSpPr>
+        <a:xfrm>
+          <a:off x="0" y="0"/>
+          <a:ext cx="0" cy="0"/>
+          <a:chOff x="0" y="0"/>
+          <a:chExt cx="0" cy="0"/>
+        </a:xfrm>
+      </p:grpSpPr>
+      <p:sp>
+        <p:nvSpPr>
+          <p:cNvPr id="2" name="Slide Image Placeholder 1"/>
+          <p:cNvSpPr>
+            <a:spLocks noGrp="1" noRot="1" noChangeAspect="1"/>
+          </p:cNvSpPr>
+          <p:nvPr>
+            <p:ph type="sldImg"/>
+          </p:nvPr>
+        </p:nvSpPr>
+        <p:spPr/>
+      </p:sp>
+      <p:sp>
+        <p:nvSpPr>
+          <p:cNvPr id="3" name="Notes Placeholder 2"/>
+          <p:cNvSpPr>
+            <a:spLocks noGrp="1"/>
+          </p:cNvSpPr>
+          <p:nvPr>
+            <p:ph type="body" idx="1"/>
+          </p:nvPr>
+        </p:nvSpPr>
+        <p:spPr/>
+        <p:txBody>
+          <a:bodyPr/>
+          <a:lstStyle/>
+          <a:p>
+            <a:r>
+              <a:rPr lang="en-US" dirty="0"/>
+              <a:t>This is the slide the deck was missing. Sixteen practice lessons gave them the
+muscle memory and none of the model, and the word "harness" is the one they
+need, because it is the thing they build in Stage 1 and extend in Analyze.
+Say the right-hand column out loud. The model's entire contribution is one
+block of text. Every effect on their machine is the left column acting on it.
+If anyone asks about models, endpoints or config: MODEL-POLICY.md, and it is
+not today's subject. qwen3.5:9b recommended, 4B permitted, any compatible
+endpoint.</a:t>
+            </a:r>
+            <a:endParaRPr lang="en-US" dirty="0"/>
+          </a:p>
+        </p:txBody>
+      </p:sp>
+      <p:sp>
+        <p:nvSpPr>
+          <p:cNvPr id="4" name="Slide Number Placeholder 3"/>
+          <p:cNvSpPr>
+            <a:spLocks noGrp="1"/>
+          </p:cNvSpPr>
+          <p:nvPr>
+            <p:ph type="sldNum" sz="quarter" idx="10"/>
+          </p:nvPr>
+        </p:nvSpPr>
+        <p:spPr/>
+        <p:txBody>
+          <a:bodyPr/>
+          <a:lstStyle/>
+          <a:p>
+            <a:fld id="{F7021451-1387-4CA6-816F-3879F97B5CBC}" type="slidenum">
+              <a:rPr lang="en-US"/>
+              <a:t>3</a:t>
+            </a:fld>
+            <a:endParaRPr lang="en-US"/>
+          </a:p>
+        </p:txBody>
+      </p:sp>
+    </p:spTree>
+    <p:extLst>
+      <p:ext uri="{BB962C8B-B14F-4D97-AF65-F5344CB8AC3E}">
+        <p14:creationId xmlns:p14="http://schemas.microsoft.com/office/powerpoint/2010/main" val="1024086991"/>
+      </p:ext>
+    </p:extLst>
+  </p:cSld>
+  <p:clrMapOvr>
+    <a:masterClrMapping/>
+  </p:clrMapOvr>
+</p:notes>
+</file>
+
+<file path=ppt/notesSlides/notesSlide30.xml><?xml version="1.0" encoding="utf-8"?>
 <p:notes xmlns:a="http://schemas.openxmlformats.org/drawingml/2006/main" xmlns:r="http://schemas.openxmlformats.org/officeDocument/2006/relationships" xmlns:p="http://schemas.openxmlformats.org/presentationml/2006/main">
   <p:cSld>
     <p:spTree>
@@ -2853,7 +2689,7 @@
           <a:p>
             <a:fld id="{F7021451-1387-4CA6-816F-3879F97B5CBC}" type="slidenum">
               <a:rPr lang="en-US"/>
-              <a:t>32</a:t>
+              <a:t>30</a:t>
             </a:fld>
             <a:endParaRPr lang="en-US"/>
           </a:p>
@@ -2872,7 +2708,7 @@
 </p:notes>
 </file>
 
-<file path=ppt/notesSlides/notesSlide33.xml><?xml version="1.0" encoding="utf-8"?>
+<file path=ppt/notesSlides/notesSlide31.xml><?xml version="1.0" encoding="utf-8"?>
 <p:notes xmlns:a="http://schemas.openxmlformats.org/drawingml/2006/main" xmlns:r="http://schemas.openxmlformats.org/officeDocument/2006/relationships" xmlns:p="http://schemas.openxmlformats.org/presentationml/2006/main">
   <p:cSld>
     <p:spTree>
@@ -2944,7 +2780,7 @@
           <a:p>
             <a:fld id="{F7021451-1387-4CA6-816F-3879F97B5CBC}" type="slidenum">
               <a:rPr lang="en-US"/>
-              <a:t>33</a:t>
+              <a:t>31</a:t>
             </a:fld>
             <a:endParaRPr lang="en-US"/>
           </a:p>
@@ -2963,7 +2799,7 @@
 </p:notes>
 </file>
 
-<file path=ppt/notesSlides/notesSlide34.xml><?xml version="1.0" encoding="utf-8"?>
+<file path=ppt/notesSlides/notesSlide32.xml><?xml version="1.0" encoding="utf-8"?>
 <p:notes xmlns:a="http://schemas.openxmlformats.org/drawingml/2006/main" xmlns:r="http://schemas.openxmlformats.org/officeDocument/2006/relationships" xmlns:p="http://schemas.openxmlformats.org/presentationml/2006/main">
   <p:cSld>
     <p:spTree>
@@ -3034,7 +2870,7 @@
           <a:p>
             <a:fld id="{F7021451-1387-4CA6-816F-3879F97B5CBC}" type="slidenum">
               <a:rPr lang="en-US"/>
-              <a:t>34</a:t>
+              <a:t>32</a:t>
             </a:fld>
             <a:endParaRPr lang="en-US"/>
           </a:p>
@@ -3053,7 +2889,7 @@
 </p:notes>
 </file>
 
-<file path=ppt/notesSlides/notesSlide35.xml><?xml version="1.0" encoding="utf-8"?>
+<file path=ppt/notesSlides/notesSlide33.xml><?xml version="1.0" encoding="utf-8"?>
 <p:notes xmlns:a="http://schemas.openxmlformats.org/drawingml/2006/main" xmlns:r="http://schemas.openxmlformats.org/officeDocument/2006/relationships" xmlns:p="http://schemas.openxmlformats.org/presentationml/2006/main">
   <p:cSld>
     <p:spTree>
@@ -3136,7 +2972,7 @@
           <a:p>
             <a:fld id="{F7021451-1387-4CA6-816F-3879F97B5CBC}" type="slidenum">
               <a:rPr lang="en-US"/>
-              <a:t>35</a:t>
+              <a:t>33</a:t>
             </a:fld>
             <a:endParaRPr lang="en-US"/>
           </a:p>
@@ -3155,7 +2991,7 @@
 </p:notes>
 </file>
 
-<file path=ppt/notesSlides/notesSlide36.xml><?xml version="1.0" encoding="utf-8"?>
+<file path=ppt/notesSlides/notesSlide34.xml><?xml version="1.0" encoding="utf-8"?>
 <p:notes xmlns:a="http://schemas.openxmlformats.org/drawingml/2006/main" xmlns:r="http://schemas.openxmlformats.org/officeDocument/2006/relationships" xmlns:p="http://schemas.openxmlformats.org/presentationml/2006/main">
   <p:cSld>
     <p:spTree>
@@ -3228,7 +3064,7 @@
           <a:p>
             <a:fld id="{F7021451-1387-4CA6-816F-3879F97B5CBC}" type="slidenum">
               <a:rPr lang="en-US"/>
-              <a:t>36</a:t>
+              <a:t>34</a:t>
             </a:fld>
             <a:endParaRPr lang="en-US"/>
           </a:p>
@@ -3247,7 +3083,7 @@
 </p:notes>
 </file>
 
-<file path=ppt/notesSlides/notesSlide37.xml><?xml version="1.0" encoding="utf-8"?>
+<file path=ppt/notesSlides/notesSlide35.xml><?xml version="1.0" encoding="utf-8"?>
 <p:notes xmlns:a="http://schemas.openxmlformats.org/drawingml/2006/main" xmlns:r="http://schemas.openxmlformats.org/officeDocument/2006/relationships" xmlns:p="http://schemas.openxmlformats.org/presentationml/2006/main">
   <p:cSld>
     <p:spTree>
@@ -3318,7 +3154,7 @@
           <a:p>
             <a:fld id="{F7021451-1387-4CA6-816F-3879F97B5CBC}" type="slidenum">
               <a:rPr lang="en-US"/>
-              <a:t>37</a:t>
+              <a:t>35</a:t>
             </a:fld>
             <a:endParaRPr lang="en-US"/>
           </a:p>
@@ -3337,7 +3173,7 @@
 </p:notes>
 </file>
 
-<file path=ppt/notesSlides/notesSlide38.xml><?xml version="1.0" encoding="utf-8"?>
+<file path=ppt/notesSlides/notesSlide36.xml><?xml version="1.0" encoding="utf-8"?>
 <p:notes xmlns:a="http://schemas.openxmlformats.org/drawingml/2006/main" xmlns:r="http://schemas.openxmlformats.org/officeDocument/2006/relationships" xmlns:p="http://schemas.openxmlformats.org/presentationml/2006/main">
   <p:cSld>
     <p:spTree>
@@ -3408,7 +3244,7 @@
           <a:p>
             <a:fld id="{F7021451-1387-4CA6-816F-3879F97B5CBC}" type="slidenum">
               <a:rPr lang="en-US"/>
-              <a:t>38</a:t>
+              <a:t>36</a:t>
             </a:fld>
             <a:endParaRPr lang="en-US"/>
           </a:p>
@@ -3427,7 +3263,7 @@
 </p:notes>
 </file>
 
-<file path=ppt/notesSlides/notesSlide39.xml><?xml version="1.0" encoding="utf-8"?>
+<file path=ppt/notesSlides/notesSlide37.xml><?xml version="1.0" encoding="utf-8"?>
 <p:notes xmlns:a="http://schemas.openxmlformats.org/drawingml/2006/main" xmlns:r="http://schemas.openxmlformats.org/officeDocument/2006/relationships" xmlns:p="http://schemas.openxmlformats.org/presentationml/2006/main">
   <p:cSld>
     <p:spTree>
@@ -3498,7 +3334,7 @@
           <a:p>
             <a:fld id="{F7021451-1387-4CA6-816F-3879F97B5CBC}" type="slidenum">
               <a:rPr lang="en-US"/>
-              <a:t>39</a:t>
+              <a:t>37</a:t>
             </a:fld>
             <a:endParaRPr lang="en-US"/>
           </a:p>
@@ -3517,101 +3353,7 @@
 </p:notes>
 </file>
 
-<file path=ppt/notesSlides/notesSlide4.xml><?xml version="1.0" encoding="utf-8"?>
-<p:notes xmlns:a="http://schemas.openxmlformats.org/drawingml/2006/main" xmlns:r="http://schemas.openxmlformats.org/officeDocument/2006/relationships" xmlns:p="http://schemas.openxmlformats.org/presentationml/2006/main">
-  <p:cSld>
-    <p:spTree>
-      <p:nvGrpSpPr>
-        <p:cNvPr id="1" name=""/>
-        <p:cNvGrpSpPr/>
-        <p:nvPr/>
-      </p:nvGrpSpPr>
-      <p:grpSpPr>
-        <a:xfrm>
-          <a:off x="0" y="0"/>
-          <a:ext cx="0" cy="0"/>
-          <a:chOff x="0" y="0"/>
-          <a:chExt cx="0" cy="0"/>
-        </a:xfrm>
-      </p:grpSpPr>
-      <p:sp>
-        <p:nvSpPr>
-          <p:cNvPr id="2" name="Slide Image Placeholder 1"/>
-          <p:cNvSpPr>
-            <a:spLocks noGrp="1" noRot="1" noChangeAspect="1"/>
-          </p:cNvSpPr>
-          <p:nvPr>
-            <p:ph type="sldImg"/>
-          </p:nvPr>
-        </p:nvSpPr>
-        <p:spPr/>
-      </p:sp>
-      <p:sp>
-        <p:nvSpPr>
-          <p:cNvPr id="3" name="Notes Placeholder 2"/>
-          <p:cNvSpPr>
-            <a:spLocks noGrp="1"/>
-          </p:cNvSpPr>
-          <p:nvPr>
-            <p:ph type="body" idx="1"/>
-          </p:nvPr>
-        </p:nvSpPr>
-        <p:spPr/>
-        <p:txBody>
-          <a:bodyPr/>
-          <a:lstStyle/>
-          <a:p>
-            <a:r>
-              <a:rPr lang="en-US" dirty="0"/>
-              <a:t>The prefix confuses people every term. It tells Aider which wire format to
-speak. Nothing about that line sends anything to OpenAI.
-Say the policy sentence plainly: any compatible endpoint is fine, the permitted
-models are fixed, and the two decisions are unrelated. The full policy is
-MODEL-POLICY.md and the rubric has disclosure points for getting it right.
-Course baseline is Aider 0.86.2. If a student reports behavior that contradicts
-this deck, ask their version before doubting the deck.</a:t>
-            </a:r>
-            <a:endParaRPr lang="en-US" dirty="0"/>
-          </a:p>
-        </p:txBody>
-      </p:sp>
-      <p:sp>
-        <p:nvSpPr>
-          <p:cNvPr id="4" name="Slide Number Placeholder 3"/>
-          <p:cNvSpPr>
-            <a:spLocks noGrp="1"/>
-          </p:cNvSpPr>
-          <p:nvPr>
-            <p:ph type="sldNum" sz="quarter" idx="10"/>
-          </p:nvPr>
-        </p:nvSpPr>
-        <p:spPr/>
-        <p:txBody>
-          <a:bodyPr/>
-          <a:lstStyle/>
-          <a:p>
-            <a:fld id="{F7021451-1387-4CA6-816F-3879F97B5CBC}" type="slidenum">
-              <a:rPr lang="en-US"/>
-              <a:t>4</a:t>
-            </a:fld>
-            <a:endParaRPr lang="en-US"/>
-          </a:p>
-        </p:txBody>
-      </p:sp>
-    </p:spTree>
-    <p:extLst>
-      <p:ext uri="{BB962C8B-B14F-4D97-AF65-F5344CB8AC3E}">
-        <p14:creationId xmlns:p14="http://schemas.microsoft.com/office/powerpoint/2010/main" val="1024086991"/>
-      </p:ext>
-    </p:extLst>
-  </p:cSld>
-  <p:clrMapOvr>
-    <a:masterClrMapping/>
-  </p:clrMapOvr>
-</p:notes>
-</file>
-
-<file path=ppt/notesSlides/notesSlide40.xml><?xml version="1.0" encoding="utf-8"?>
+<file path=ppt/notesSlides/notesSlide38.xml><?xml version="1.0" encoding="utf-8"?>
 <p:notes xmlns:a="http://schemas.openxmlformats.org/drawingml/2006/main" xmlns:r="http://schemas.openxmlformats.org/officeDocument/2006/relationships" xmlns:p="http://schemas.openxmlformats.org/presentationml/2006/main">
   <p:cSld>
     <p:spTree>
@@ -3682,7 +3424,7 @@
           <a:p>
             <a:fld id="{F7021451-1387-4CA6-816F-3879F97B5CBC}" type="slidenum">
               <a:rPr lang="en-US"/>
-              <a:t>40</a:t>
+              <a:t>38</a:t>
             </a:fld>
             <a:endParaRPr lang="en-US"/>
           </a:p>
@@ -3701,7 +3443,7 @@
 </p:notes>
 </file>
 
-<file path=ppt/notesSlides/notesSlide41.xml><?xml version="1.0" encoding="utf-8"?>
+<file path=ppt/notesSlides/notesSlide39.xml><?xml version="1.0" encoding="utf-8"?>
 <p:notes xmlns:a="http://schemas.openxmlformats.org/drawingml/2006/main" xmlns:r="http://schemas.openxmlformats.org/officeDocument/2006/relationships" xmlns:p="http://schemas.openxmlformats.org/presentationml/2006/main">
   <p:cSld>
     <p:spTree>
@@ -3771,7 +3513,7 @@
           <a:p>
             <a:fld id="{F7021451-1387-4CA6-816F-3879F97B5CBC}" type="slidenum">
               <a:rPr lang="en-US"/>
-              <a:t>41</a:t>
+              <a:t>39</a:t>
             </a:fld>
             <a:endParaRPr lang="en-US"/>
           </a:p>
@@ -3790,7 +3532,103 @@
 </p:notes>
 </file>
 
-<file path=ppt/notesSlides/notesSlide42.xml><?xml version="1.0" encoding="utf-8"?>
+<file path=ppt/notesSlides/notesSlide4.xml><?xml version="1.0" encoding="utf-8"?>
+<p:notes xmlns:a="http://schemas.openxmlformats.org/drawingml/2006/main" xmlns:r="http://schemas.openxmlformats.org/officeDocument/2006/relationships" xmlns:p="http://schemas.openxmlformats.org/presentationml/2006/main">
+  <p:cSld>
+    <p:spTree>
+      <p:nvGrpSpPr>
+        <p:cNvPr id="1" name=""/>
+        <p:cNvGrpSpPr/>
+        <p:nvPr/>
+      </p:nvGrpSpPr>
+      <p:grpSpPr>
+        <a:xfrm>
+          <a:off x="0" y="0"/>
+          <a:ext cx="0" cy="0"/>
+          <a:chOff x="0" y="0"/>
+          <a:chExt cx="0" cy="0"/>
+        </a:xfrm>
+      </p:grpSpPr>
+      <p:sp>
+        <p:nvSpPr>
+          <p:cNvPr id="2" name="Slide Image Placeholder 1"/>
+          <p:cNvSpPr>
+            <a:spLocks noGrp="1" noRot="1" noChangeAspect="1"/>
+          </p:cNvSpPr>
+          <p:nvPr>
+            <p:ph type="sldImg"/>
+          </p:nvPr>
+        </p:nvSpPr>
+        <p:spPr/>
+      </p:sp>
+      <p:sp>
+        <p:nvSpPr>
+          <p:cNvPr id="3" name="Notes Placeholder 2"/>
+          <p:cNvSpPr>
+            <a:spLocks noGrp="1"/>
+          </p:cNvSpPr>
+          <p:nvPr>
+            <p:ph type="body" idx="1"/>
+          </p:nvPr>
+        </p:nvSpPr>
+        <p:spPr/>
+        <p:txBody>
+          <a:bodyPr/>
+          <a:lstStyle/>
+          <a:p>
+            <a:r>
+              <a:rPr lang="en-US" dirty="0"/>
+              <a:t>Three negatives, and each one is a design decision somebody made rather than a
+limitation of the model.
+The third is the one that surprises people: there is no memory between
+sessions. Continuity is the harness resending the history, which is why
+history spends their token budget later in the deck.
+The 4B and the 9B are asked for different reply shapes, whole files against
+diffs. That is why a classmate's session looks different from theirs, and why
+the trace in the next ten minutes may not match what they ran in practice.
+Worth saying here, not worth a slide.</a:t>
+            </a:r>
+            <a:endParaRPr lang="en-US" dirty="0"/>
+          </a:p>
+        </p:txBody>
+      </p:sp>
+      <p:sp>
+        <p:nvSpPr>
+          <p:cNvPr id="4" name="Slide Number Placeholder 3"/>
+          <p:cNvSpPr>
+            <a:spLocks noGrp="1"/>
+          </p:cNvSpPr>
+          <p:nvPr>
+            <p:ph type="sldNum" sz="quarter" idx="10"/>
+          </p:nvPr>
+        </p:nvSpPr>
+        <p:spPr/>
+        <p:txBody>
+          <a:bodyPr/>
+          <a:lstStyle/>
+          <a:p>
+            <a:fld id="{F7021451-1387-4CA6-816F-3879F97B5CBC}" type="slidenum">
+              <a:rPr lang="en-US"/>
+              <a:t>4</a:t>
+            </a:fld>
+            <a:endParaRPr lang="en-US"/>
+          </a:p>
+        </p:txBody>
+      </p:sp>
+    </p:spTree>
+    <p:extLst>
+      <p:ext uri="{BB962C8B-B14F-4D97-AF65-F5344CB8AC3E}">
+        <p14:creationId xmlns:p14="http://schemas.microsoft.com/office/powerpoint/2010/main" val="1024086991"/>
+      </p:ext>
+    </p:extLst>
+  </p:cSld>
+  <p:clrMapOvr>
+    <a:masterClrMapping/>
+  </p:clrMapOvr>
+</p:notes>
+</file>
+
+<file path=ppt/notesSlides/notesSlide40.xml><?xml version="1.0" encoding="utf-8"?>
 <p:notes xmlns:a="http://schemas.openxmlformats.org/drawingml/2006/main" xmlns:r="http://schemas.openxmlformats.org/officeDocument/2006/relationships" xmlns:p="http://schemas.openxmlformats.org/presentationml/2006/main">
   <p:cSld>
     <p:spTree>
@@ -3862,7 +3700,7 @@
           <a:p>
             <a:fld id="{F7021451-1387-4CA6-816F-3879F97B5CBC}" type="slidenum">
               <a:rPr lang="en-US"/>
-              <a:t>42</a:t>
+              <a:t>40</a:t>
             </a:fld>
             <a:endParaRPr lang="en-US"/>
           </a:p>
@@ -3881,7 +3719,7 @@
 </p:notes>
 </file>
 
-<file path=ppt/notesSlides/notesSlide43.xml><?xml version="1.0" encoding="utf-8"?>
+<file path=ppt/notesSlides/notesSlide41.xml><?xml version="1.0" encoding="utf-8"?>
 <p:notes xmlns:a="http://schemas.openxmlformats.org/drawingml/2006/main" xmlns:r="http://schemas.openxmlformats.org/officeDocument/2006/relationships" xmlns:p="http://schemas.openxmlformats.org/presentationml/2006/main">
   <p:cSld>
     <p:spTree>
@@ -3950,7 +3788,7 @@
           <a:p>
             <a:fld id="{F7021451-1387-4CA6-816F-3879F97B5CBC}" type="slidenum">
               <a:rPr lang="en-US"/>
-              <a:t>43</a:t>
+              <a:t>41</a:t>
             </a:fld>
             <a:endParaRPr lang="en-US"/>
           </a:p>
@@ -4015,13 +3853,11 @@
           <a:p>
             <a:r>
               <a:rPr lang="en-US" dirty="0"/>
-              <a:t>This is the slide that explains why their practice lessons looked different
-from today's trace: whole-file mode on the 4B, diff mode on the 9B. Ask who ran
-which. The ones on the 4B have never seen a diff block.
-Per-model settings beat the general config, which is the part people get wrong
-when they switch models and nothing changes.
-Never commit .env. It is gitignored in the starter and the rubric treats a
-committed credential as an integrity matter, not a style nit.</a:t>
+              <a:t>Two commands in the whole set touch the repository, and one of those is the
+undo. That asymmetry is the approval layer they are about to build, visible in
+a tool they already use.
+/help lists more than this and the set moves between versions. Run it live if
+asked rather than reciting.</a:t>
             </a:r>
             <a:endParaRPr lang="en-US" dirty="0"/>
           </a:p>
@@ -4064,190 +3900,6 @@
 </file>
 
 <file path=ppt/notesSlides/notesSlide6.xml><?xml version="1.0" encoding="utf-8"?>
-<p:notes xmlns:a="http://schemas.openxmlformats.org/drawingml/2006/main" xmlns:r="http://schemas.openxmlformats.org/officeDocument/2006/relationships" xmlns:p="http://schemas.openxmlformats.org/presentationml/2006/main">
-  <p:cSld>
-    <p:spTree>
-      <p:nvGrpSpPr>
-        <p:cNvPr id="1" name=""/>
-        <p:cNvGrpSpPr/>
-        <p:nvPr/>
-      </p:nvGrpSpPr>
-      <p:grpSpPr>
-        <a:xfrm>
-          <a:off x="0" y="0"/>
-          <a:ext cx="0" cy="0"/>
-          <a:chOff x="0" y="0"/>
-          <a:chExt cx="0" cy="0"/>
-        </a:xfrm>
-      </p:grpSpPr>
-      <p:sp>
-        <p:nvSpPr>
-          <p:cNvPr id="2" name="Slide Image Placeholder 1"/>
-          <p:cNvSpPr>
-            <a:spLocks noGrp="1" noRot="1" noChangeAspect="1"/>
-          </p:cNvSpPr>
-          <p:nvPr>
-            <p:ph type="sldImg"/>
-          </p:nvPr>
-        </p:nvSpPr>
-        <p:spPr/>
-      </p:sp>
-      <p:sp>
-        <p:nvSpPr>
-          <p:cNvPr id="3" name="Notes Placeholder 2"/>
-          <p:cNvSpPr>
-            <a:spLocks noGrp="1"/>
-          </p:cNvSpPr>
-          <p:nvPr>
-            <p:ph type="body" idx="1"/>
-          </p:nvPr>
-        </p:nvSpPr>
-        <p:spPr/>
-        <p:txBody>
-          <a:bodyPr/>
-          <a:lstStyle/>
-          <a:p>
-            <a:r>
-              <a:rPr lang="en-US" dirty="0"/>
-              <a:t>Make them read the banner. Most setup problems announce themselves here: wrong
-model because .env overrode the config, no git repo because they are one
-directory too high, repo map off when they expected it on.
-The banner text shifts between releases. Treat the shape as the lesson, not the
-exact lines, and tell them to check their own.</a:t>
-            </a:r>
-            <a:endParaRPr lang="en-US" dirty="0"/>
-          </a:p>
-        </p:txBody>
-      </p:sp>
-      <p:sp>
-        <p:nvSpPr>
-          <p:cNvPr id="4" name="Slide Number Placeholder 3"/>
-          <p:cNvSpPr>
-            <a:spLocks noGrp="1"/>
-          </p:cNvSpPr>
-          <p:nvPr>
-            <p:ph type="sldNum" sz="quarter" idx="10"/>
-          </p:nvPr>
-        </p:nvSpPr>
-        <p:spPr/>
-        <p:txBody>
-          <a:bodyPr/>
-          <a:lstStyle/>
-          <a:p>
-            <a:fld id="{F7021451-1387-4CA6-816F-3879F97B5CBC}" type="slidenum">
-              <a:rPr lang="en-US"/>
-              <a:t>6</a:t>
-            </a:fld>
-            <a:endParaRPr lang="en-US"/>
-          </a:p>
-        </p:txBody>
-      </p:sp>
-    </p:spTree>
-    <p:extLst>
-      <p:ext uri="{BB962C8B-B14F-4D97-AF65-F5344CB8AC3E}">
-        <p14:creationId xmlns:p14="http://schemas.microsoft.com/office/powerpoint/2010/main" val="1024086991"/>
-      </p:ext>
-    </p:extLst>
-  </p:cSld>
-  <p:clrMapOvr>
-    <a:masterClrMapping/>
-  </p:clrMapOvr>
-</p:notes>
-</file>
-
-<file path=ppt/notesSlides/notesSlide7.xml><?xml version="1.0" encoding="utf-8"?>
-<p:notes xmlns:a="http://schemas.openxmlformats.org/drawingml/2006/main" xmlns:r="http://schemas.openxmlformats.org/officeDocument/2006/relationships" xmlns:p="http://schemas.openxmlformats.org/presentationml/2006/main">
-  <p:cSld>
-    <p:spTree>
-      <p:nvGrpSpPr>
-        <p:cNvPr id="1" name=""/>
-        <p:cNvGrpSpPr/>
-        <p:nvPr/>
-      </p:nvGrpSpPr>
-      <p:grpSpPr>
-        <a:xfrm>
-          <a:off x="0" y="0"/>
-          <a:ext cx="0" cy="0"/>
-          <a:chOff x="0" y="0"/>
-          <a:chExt cx="0" cy="0"/>
-        </a:xfrm>
-      </p:grpSpPr>
-      <p:sp>
-        <p:nvSpPr>
-          <p:cNvPr id="2" name="Slide Image Placeholder 1"/>
-          <p:cNvSpPr>
-            <a:spLocks noGrp="1" noRot="1" noChangeAspect="1"/>
-          </p:cNvSpPr>
-          <p:nvPr>
-            <p:ph type="sldImg"/>
-          </p:nvPr>
-        </p:nvSpPr>
-        <p:spPr/>
-      </p:sp>
-      <p:sp>
-        <p:nvSpPr>
-          <p:cNvPr id="3" name="Notes Placeholder 2"/>
-          <p:cNvSpPr>
-            <a:spLocks noGrp="1"/>
-          </p:cNvSpPr>
-          <p:nvPr>
-            <p:ph type="body" idx="1"/>
-          </p:nvPr>
-        </p:nvSpPr>
-        <p:spPr/>
-        <p:txBody>
-          <a:bodyPr/>
-          <a:lstStyle/>
-          <a:p>
-            <a:r>
-              <a:rPr lang="en-US" dirty="0"/>
-              <a:t>The two in the right-hand column are the whole safety story at this rung: one
-command writes, one takes it back, and everything else is arranging context.
-They will rebuild exactly that distinction in their own approval layer.
-/help lists the full set and it is longer than this. Run it live if anyone
-asks, rather than reciting from the slide; the set moves between versions.</a:t>
-            </a:r>
-            <a:endParaRPr lang="en-US" dirty="0"/>
-          </a:p>
-        </p:txBody>
-      </p:sp>
-      <p:sp>
-        <p:nvSpPr>
-          <p:cNvPr id="4" name="Slide Number Placeholder 3"/>
-          <p:cNvSpPr>
-            <a:spLocks noGrp="1"/>
-          </p:cNvSpPr>
-          <p:nvPr>
-            <p:ph type="sldNum" sz="quarter" idx="10"/>
-          </p:nvPr>
-        </p:nvSpPr>
-        <p:spPr/>
-        <p:txBody>
-          <a:bodyPr/>
-          <a:lstStyle/>
-          <a:p>
-            <a:fld id="{F7021451-1387-4CA6-816F-3879F97B5CBC}" type="slidenum">
-              <a:rPr lang="en-US"/>
-              <a:t>7</a:t>
-            </a:fld>
-            <a:endParaRPr lang="en-US"/>
-          </a:p>
-        </p:txBody>
-      </p:sp>
-    </p:spTree>
-    <p:extLst>
-      <p:ext uri="{BB962C8B-B14F-4D97-AF65-F5344CB8AC3E}">
-        <p14:creationId xmlns:p14="http://schemas.microsoft.com/office/powerpoint/2010/main" val="1024086991"/>
-      </p:ext>
-    </p:extLst>
-  </p:cSld>
-  <p:clrMapOvr>
-    <a:masterClrMapping/>
-  </p:clrMapOvr>
-</p:notes>
-</file>
-
-<file path=ppt/notesSlides/notesSlide8.xml><?xml version="1.0" encoding="utf-8"?>
 <p:notes xmlns:a="http://schemas.openxmlformats.org/drawingml/2006/main" xmlns:r="http://schemas.openxmlformats.org/officeDocument/2006/relationships" xmlns:p="http://schemas.openxmlformats.org/presentationml/2006/main">
   <p:cSld>
     <p:spTree>
@@ -4319,7 +3971,7 @@
           <a:p>
             <a:fld id="{F7021451-1387-4CA6-816F-3879F97B5CBC}" type="slidenum">
               <a:rPr lang="en-US"/>
-              <a:t>8</a:t>
+              <a:t>6</a:t>
             </a:fld>
             <a:endParaRPr lang="en-US"/>
           </a:p>
@@ -4338,6 +3990,185 @@
 </p:notes>
 </file>
 
+<file path=ppt/notesSlides/notesSlide7.xml><?xml version="1.0" encoding="utf-8"?>
+<p:notes xmlns:a="http://schemas.openxmlformats.org/drawingml/2006/main" xmlns:r="http://schemas.openxmlformats.org/officeDocument/2006/relationships" xmlns:p="http://schemas.openxmlformats.org/presentationml/2006/main">
+  <p:cSld>
+    <p:spTree>
+      <p:nvGrpSpPr>
+        <p:cNvPr id="1" name=""/>
+        <p:cNvGrpSpPr/>
+        <p:nvPr/>
+      </p:nvGrpSpPr>
+      <p:grpSpPr>
+        <a:xfrm>
+          <a:off x="0" y="0"/>
+          <a:ext cx="0" cy="0"/>
+          <a:chOff x="0" y="0"/>
+          <a:chExt cx="0" cy="0"/>
+        </a:xfrm>
+      </p:grpSpPr>
+      <p:sp>
+        <p:nvSpPr>
+          <p:cNvPr id="2" name="Slide Image Placeholder 1"/>
+          <p:cNvSpPr>
+            <a:spLocks noGrp="1" noRot="1" noChangeAspect="1"/>
+          </p:cNvSpPr>
+          <p:nvPr>
+            <p:ph type="sldImg"/>
+          </p:nvPr>
+        </p:nvSpPr>
+        <p:spPr/>
+      </p:sp>
+      <p:sp>
+        <p:nvSpPr>
+          <p:cNvPr id="3" name="Notes Placeholder 2"/>
+          <p:cNvSpPr>
+            <a:spLocks noGrp="1"/>
+          </p:cNvSpPr>
+          <p:nvPr>
+            <p:ph type="body" idx="1"/>
+          </p:nvPr>
+        </p:nvSpPr>
+        <p:spPr/>
+        <p:txBody>
+          <a:bodyPr/>
+          <a:lstStyle/>
+          <a:p>
+            <a:r>
+              <a:rPr lang="en-US" dirty="0"/>
+              <a:t>Six steps. Say up front that only step 2 belongs to the model.</a:t>
+            </a:r>
+            <a:endParaRPr lang="en-US" dirty="0"/>
+          </a:p>
+        </p:txBody>
+      </p:sp>
+      <p:sp>
+        <p:nvSpPr>
+          <p:cNvPr id="4" name="Slide Number Placeholder 3"/>
+          <p:cNvSpPr>
+            <a:spLocks noGrp="1"/>
+          </p:cNvSpPr>
+          <p:nvPr>
+            <p:ph type="sldNum" sz="quarter" idx="10"/>
+          </p:nvPr>
+        </p:nvSpPr>
+        <p:spPr/>
+        <p:txBody>
+          <a:bodyPr/>
+          <a:lstStyle/>
+          <a:p>
+            <a:fld id="{F7021451-1387-4CA6-816F-3879F97B5CBC}" type="slidenum">
+              <a:rPr lang="en-US"/>
+              <a:t>7</a:t>
+            </a:fld>
+            <a:endParaRPr lang="en-US"/>
+          </a:p>
+        </p:txBody>
+      </p:sp>
+    </p:spTree>
+    <p:extLst>
+      <p:ext uri="{BB962C8B-B14F-4D97-AF65-F5344CB8AC3E}">
+        <p14:creationId xmlns:p14="http://schemas.microsoft.com/office/powerpoint/2010/main" val="1024086991"/>
+      </p:ext>
+    </p:extLst>
+  </p:cSld>
+  <p:clrMapOvr>
+    <a:masterClrMapping/>
+  </p:clrMapOvr>
+</p:notes>
+</file>
+
+<file path=ppt/notesSlides/notesSlide8.xml><?xml version="1.0" encoding="utf-8"?>
+<p:notes xmlns:a="http://schemas.openxmlformats.org/drawingml/2006/main" xmlns:r="http://schemas.openxmlformats.org/officeDocument/2006/relationships" xmlns:p="http://schemas.openxmlformats.org/presentationml/2006/main">
+  <p:cSld>
+    <p:spTree>
+      <p:nvGrpSpPr>
+        <p:cNvPr id="1" name=""/>
+        <p:cNvGrpSpPr/>
+        <p:nvPr/>
+      </p:nvGrpSpPr>
+      <p:grpSpPr>
+        <a:xfrm>
+          <a:off x="0" y="0"/>
+          <a:ext cx="0" cy="0"/>
+          <a:chOff x="0" y="0"/>
+          <a:chExt cx="0" cy="0"/>
+        </a:xfrm>
+      </p:grpSpPr>
+      <p:sp>
+        <p:nvSpPr>
+          <p:cNvPr id="2" name="Slide Image Placeholder 1"/>
+          <p:cNvSpPr>
+            <a:spLocks noGrp="1" noRot="1" noChangeAspect="1"/>
+          </p:cNvSpPr>
+          <p:nvPr>
+            <p:ph type="sldImg"/>
+          </p:nvPr>
+        </p:nvSpPr>
+        <p:spPr/>
+      </p:sp>
+      <p:sp>
+        <p:nvSpPr>
+          <p:cNvPr id="3" name="Notes Placeholder 2"/>
+          <p:cNvSpPr>
+            <a:spLocks noGrp="1"/>
+          </p:cNvSpPr>
+          <p:nvPr>
+            <p:ph type="body" idx="1"/>
+          </p:nvPr>
+        </p:nvSpPr>
+        <p:spPr/>
+        <p:txBody>
+          <a:bodyPr/>
+          <a:lstStyle/>
+          <a:p>
+            <a:r>
+              <a:rPr lang="en-US" dirty="0"/>
+              <a:t>Ask the room to find the arrow that writes a file. There is not one leaving the
+amber box. The model produced text, and a program decided what to do with it.
+This is a picture of Aider, not a required architecture for their build. They
+will draw their own version of this in a week.</a:t>
+            </a:r>
+            <a:endParaRPr lang="en-US" dirty="0"/>
+          </a:p>
+        </p:txBody>
+      </p:sp>
+      <p:sp>
+        <p:nvSpPr>
+          <p:cNvPr id="4" name="Slide Number Placeholder 3"/>
+          <p:cNvSpPr>
+            <a:spLocks noGrp="1"/>
+          </p:cNvSpPr>
+          <p:nvPr>
+            <p:ph type="sldNum" sz="quarter" idx="10"/>
+          </p:nvPr>
+        </p:nvSpPr>
+        <p:spPr/>
+        <p:txBody>
+          <a:bodyPr/>
+          <a:lstStyle/>
+          <a:p>
+            <a:fld id="{F7021451-1387-4CA6-816F-3879F97B5CBC}" type="slidenum">
+              <a:rPr lang="en-US"/>
+              <a:t>8</a:t>
+            </a:fld>
+            <a:endParaRPr lang="en-US"/>
+          </a:p>
+        </p:txBody>
+      </p:sp>
+    </p:spTree>
+    <p:extLst>
+      <p:ext uri="{BB962C8B-B14F-4D97-AF65-F5344CB8AC3E}">
+        <p14:creationId xmlns:p14="http://schemas.microsoft.com/office/powerpoint/2010/main" val="1024086991"/>
+      </p:ext>
+    </p:extLst>
+  </p:cSld>
+  <p:clrMapOvr>
+    <a:masterClrMapping/>
+  </p:clrMapOvr>
+</p:notes>
+</file>
+
 <file path=ppt/notesSlides/notesSlide9.xml><?xml version="1.0" encoding="utf-8"?>
 <p:notes xmlns:a="http://schemas.openxmlformats.org/drawingml/2006/main" xmlns:r="http://schemas.openxmlformats.org/officeDocument/2006/relationships" xmlns:p="http://schemas.openxmlformats.org/presentationml/2006/main">
   <p:cSld>
@@ -4384,7 +4215,11 @@
           <a:p>
             <a:r>
               <a:rPr lang="en-US" dirty="0"/>
-              <a:t>Six steps. Say up front that only step 2 belongs to the model.</a:t>
+              <a:t>Do not claim a fixed seven-part ordering. What actually goes into the prompt
+depends on the coder, the model and the settings, and it changes between
+releases. The list above is the shape, not the wire format.
+Ask what the model would need in order to add priority consistently to the CLI,
+the task and the store. That question sets up the next two slides.</a:t>
             </a:r>
             <a:endParaRPr lang="en-US" dirty="0"/>
           </a:p>
@@ -6101,84 +5936,6 @@
 <file path=ppt/slides/slide41.xml><?xml version="1.0" encoding="utf-8"?>
 <p:sld xmlns:a="http://schemas.openxmlformats.org/drawingml/2006/main" xmlns:r="http://schemas.openxmlformats.org/officeDocument/2006/relationships" xmlns:p="http://schemas.openxmlformats.org/presentationml/2006/main">
   <p:cSld name="Slide 41">
-    <p:bg>
-      <p:bgPr>
-        <a:blipFill dpi="0" rotWithShape="1">
-          <a:blip r:embed="rId1">
-            <a:lum/>
-          </a:blip>
-          <a:srcRect/>
-          <a:stretch>
-            <a:fillRect/>
-          </a:stretch>
-        </a:blipFill>
-        <a:effectLst/>
-      </p:bgPr>
-    </p:bg>
-    <p:spTree>
-      <p:nvGrpSpPr>
-        <p:cNvPr id="1" name=""/>
-        <p:cNvGrpSpPr/>
-        <p:nvPr/>
-      </p:nvGrpSpPr>
-      <p:grpSpPr>
-        <a:xfrm>
-          <a:off x="0" y="0"/>
-          <a:ext cx="0" cy="0"/>
-          <a:chOff x="0" y="0"/>
-          <a:chExt cx="0" cy="0"/>
-        </a:xfrm>
-      </p:grpSpPr>
-    </p:spTree>
-  </p:cSld>
-  <p:clrMapOvr>
-    <a:masterClrMapping/>
-  </p:clrMapOvr>
-</p:sld>
-</file>
-
-<file path=ppt/slides/slide42.xml><?xml version="1.0" encoding="utf-8"?>
-<p:sld xmlns:a="http://schemas.openxmlformats.org/drawingml/2006/main" xmlns:r="http://schemas.openxmlformats.org/officeDocument/2006/relationships" xmlns:p="http://schemas.openxmlformats.org/presentationml/2006/main">
-  <p:cSld name="Slide 42">
-    <p:bg>
-      <p:bgPr>
-        <a:blipFill dpi="0" rotWithShape="1">
-          <a:blip r:embed="rId1">
-            <a:lum/>
-          </a:blip>
-          <a:srcRect/>
-          <a:stretch>
-            <a:fillRect/>
-          </a:stretch>
-        </a:blipFill>
-        <a:effectLst/>
-      </p:bgPr>
-    </p:bg>
-    <p:spTree>
-      <p:nvGrpSpPr>
-        <p:cNvPr id="1" name=""/>
-        <p:cNvGrpSpPr/>
-        <p:nvPr/>
-      </p:nvGrpSpPr>
-      <p:grpSpPr>
-        <a:xfrm>
-          <a:off x="0" y="0"/>
-          <a:ext cx="0" cy="0"/>
-          <a:chOff x="0" y="0"/>
-          <a:chExt cx="0" cy="0"/>
-        </a:xfrm>
-      </p:grpSpPr>
-    </p:spTree>
-  </p:cSld>
-  <p:clrMapOvr>
-    <a:masterClrMapping/>
-  </p:clrMapOvr>
-</p:sld>
-</file>
-
-<file path=ppt/slides/slide43.xml><?xml version="1.0" encoding="utf-8"?>
-<p:sld xmlns:a="http://schemas.openxmlformats.org/drawingml/2006/main" xmlns:r="http://schemas.openxmlformats.org/officeDocument/2006/relationships" xmlns:p="http://schemas.openxmlformats.org/presentationml/2006/main">
-  <p:cSld name="Slide 43">
     <p:bg>
       <p:bgPr>
         <a:blipFill dpi="0" rotWithShape="1">

</xml_diff>

<commit_message>
Lab01: reship with the corrected presenter note
Matches eecs498-aase/aase-f26 at 722f970.

Co-Authored-By: Claude Opus 5 (1M context) <noreply@anthropic.com>
Claude-Session: https://claude.ai/code/session_015pu78gNF4378sH81fTPKSc
</commit_message>
<xml_diff>
--- a/labs/Lab01/slides.pptx
+++ b/labs/Lab01/slides.pptx
@@ -2476,10 +2476,11 @@
               <a:rPr lang="en-US" dirty="0"/>
               <a:t>base_url can carry any path prefix. Their client appends /chat/completions and
 nothing else.
-Say explicitly that this is not the .aider.conf.yml from the first ten minutes.
-Two YAML files, two owners: that one configures the tool they use, this one is
-a schema their own program has to implement. The deck now teaches both, so the
-collision is live.
+Say explicitly that this YAML is not the .aider.conf.yml they already have in
+aider-practice. Two files, two owners: that one configures the tool they use,
+this one is a schema their own program has to implement. The deck no longer
+walks through Aider's own config, so name the distinction out loud rather than
+assuming the contrast landed earlier in the hour.
 No Ollama-specific dependency belongs anywhere in the application. Provider
 independence is a requirement, not a preference.</a:t>
             </a:r>

</xml_diff>